<commit_message>
feat: add wireless android deployment script and power management tools
</commit_message>
<xml_diff>
--- a/WebGPU Renderer.pptx
+++ b/WebGPU Renderer.pptx
@@ -124,6 +124,7 @@
 <p1510:revInfo xmlns:a="http://schemas.openxmlformats.org/drawingml/2006/main" xmlns:r="http://schemas.openxmlformats.org/officeDocument/2006/relationships" xmlns:p1510="http://schemas.microsoft.com/office/powerpoint/2015/10/main">
   <p1510:revLst>
     <p1510:client id="{4E806664-B705-48D9-877F-D458C7EA0EF2}" v="1" dt="2026-10-08T08:35:45.944"/>
+    <p1510:client id="{CB766BFE-92B0-4947-B12B-4251E9BB4474}" v="2" dt="2026-10-08T12:22:31.155"/>
   </p1510:revLst>
 </p1510:revInfo>
 </file>
@@ -133,18 +134,18 @@
   <pc:docChgLst>
     <pc:chgData name="Tyrion Bao" userId="86a2b12e41226f78" providerId="LiveId" clId="{BE0B2CE4-1428-496C-ACE6-ADB1F60287EC}"/>
     <pc:docChg chg="undo custSel addSld delSld modSld sldOrd">
-      <pc:chgData name="Tyrion Bao" userId="86a2b12e41226f78" providerId="LiveId" clId="{BE0B2CE4-1428-496C-ACE6-ADB1F60287EC}" dt="2026-10-08T08:36:00.908" v="2194" actId="20577"/>
+      <pc:chgData name="Tyrion Bao" userId="86a2b12e41226f78" providerId="LiveId" clId="{BE0B2CE4-1428-496C-ACE6-ADB1F60287EC}" dt="2026-10-08T12:24:17.406" v="2681" actId="1076"/>
       <pc:docMkLst>
         <pc:docMk/>
       </pc:docMkLst>
       <pc:sldChg chg="modSp new mod">
-        <pc:chgData name="Tyrion Bao" userId="86a2b12e41226f78" providerId="LiveId" clId="{BE0B2CE4-1428-496C-ACE6-ADB1F60287EC}" dt="2026-10-08T08:36:00.908" v="2194" actId="20577"/>
+        <pc:chgData name="Tyrion Bao" userId="86a2b12e41226f78" providerId="LiveId" clId="{BE0B2CE4-1428-496C-ACE6-ADB1F60287EC}" dt="2026-10-08T12:22:41.281" v="2601" actId="1076"/>
         <pc:sldMkLst>
           <pc:docMk/>
           <pc:sldMk cId="3812720094" sldId="256"/>
         </pc:sldMkLst>
         <pc:spChg chg="mod">
-          <ac:chgData name="Tyrion Bao" userId="86a2b12e41226f78" providerId="LiveId" clId="{BE0B2CE4-1428-496C-ACE6-ADB1F60287EC}" dt="2026-10-08T08:36:00.908" v="2194" actId="20577"/>
+          <ac:chgData name="Tyrion Bao" userId="86a2b12e41226f78" providerId="LiveId" clId="{BE0B2CE4-1428-496C-ACE6-ADB1F60287EC}" dt="2026-10-08T12:22:37.526" v="2600" actId="20577"/>
           <ac:spMkLst>
             <pc:docMk/>
             <pc:sldMk cId="3812720094" sldId="256"/>
@@ -152,7 +153,7 @@
           </ac:spMkLst>
         </pc:spChg>
         <pc:spChg chg="mod">
-          <ac:chgData name="Tyrion Bao" userId="86a2b12e41226f78" providerId="LiveId" clId="{BE0B2CE4-1428-496C-ACE6-ADB1F60287EC}" dt="2026-10-08T08:31:51.793" v="2174" actId="14100"/>
+          <ac:chgData name="Tyrion Bao" userId="86a2b12e41226f78" providerId="LiveId" clId="{BE0B2CE4-1428-496C-ACE6-ADB1F60287EC}" dt="2026-10-08T12:22:41.281" v="2601" actId="1076"/>
           <ac:spMkLst>
             <pc:docMk/>
             <pc:sldMk cId="3812720094" sldId="256"/>
@@ -161,13 +162,13 @@
         </pc:spChg>
       </pc:sldChg>
       <pc:sldChg chg="addSp delSp modSp new mod">
-        <pc:chgData name="Tyrion Bao" userId="86a2b12e41226f78" providerId="LiveId" clId="{BE0B2CE4-1428-496C-ACE6-ADB1F60287EC}" dt="2026-10-08T08:32:24.651" v="2180" actId="1076"/>
+        <pc:chgData name="Tyrion Bao" userId="86a2b12e41226f78" providerId="LiveId" clId="{BE0B2CE4-1428-496C-ACE6-ADB1F60287EC}" dt="2026-10-08T12:24:17.406" v="2681" actId="1076"/>
         <pc:sldMkLst>
           <pc:docMk/>
           <pc:sldMk cId="1637792322" sldId="257"/>
         </pc:sldMkLst>
         <pc:spChg chg="mod">
-          <ac:chgData name="Tyrion Bao" userId="86a2b12e41226f78" providerId="LiveId" clId="{BE0B2CE4-1428-496C-ACE6-ADB1F60287EC}" dt="2026-10-02T09:57:59.370" v="1746" actId="20577"/>
+          <ac:chgData name="Tyrion Bao" userId="86a2b12e41226f78" providerId="LiveId" clId="{BE0B2CE4-1428-496C-ACE6-ADB1F60287EC}" dt="2026-10-08T12:23:12.873" v="2641" actId="20577"/>
           <ac:spMkLst>
             <pc:docMk/>
             <pc:sldMk cId="1637792322" sldId="257"/>
@@ -191,7 +192,7 @@
           </ac:picMkLst>
         </pc:picChg>
         <pc:picChg chg="add mod">
-          <ac:chgData name="Tyrion Bao" userId="86a2b12e41226f78" providerId="LiveId" clId="{BE0B2CE4-1428-496C-ACE6-ADB1F60287EC}" dt="2026-10-08T08:32:24.651" v="2180" actId="1076"/>
+          <ac:chgData name="Tyrion Bao" userId="86a2b12e41226f78" providerId="LiveId" clId="{BE0B2CE4-1428-496C-ACE6-ADB1F60287EC}" dt="2026-10-08T12:24:17.406" v="2681" actId="1076"/>
           <ac:picMkLst>
             <pc:docMk/>
             <pc:sldMk cId="1637792322" sldId="257"/>
@@ -200,13 +201,13 @@
         </pc:picChg>
       </pc:sldChg>
       <pc:sldChg chg="modSp new mod">
-        <pc:chgData name="Tyrion Bao" userId="86a2b12e41226f78" providerId="LiveId" clId="{BE0B2CE4-1428-496C-ACE6-ADB1F60287EC}" dt="2026-10-02T07:43:33.165" v="153" actId="20577"/>
+        <pc:chgData name="Tyrion Bao" userId="86a2b12e41226f78" providerId="LiveId" clId="{BE0B2CE4-1428-496C-ACE6-ADB1F60287EC}" dt="2026-10-08T12:22:53.244" v="2612" actId="20577"/>
         <pc:sldMkLst>
           <pc:docMk/>
           <pc:sldMk cId="2182435635" sldId="258"/>
         </pc:sldMkLst>
         <pc:spChg chg="mod">
-          <ac:chgData name="Tyrion Bao" userId="86a2b12e41226f78" providerId="LiveId" clId="{BE0B2CE4-1428-496C-ACE6-ADB1F60287EC}" dt="2026-10-02T07:43:33.165" v="153" actId="20577"/>
+          <ac:chgData name="Tyrion Bao" userId="86a2b12e41226f78" providerId="LiveId" clId="{BE0B2CE4-1428-496C-ACE6-ADB1F60287EC}" dt="2026-10-08T12:22:53.244" v="2612" actId="20577"/>
           <ac:spMkLst>
             <pc:docMk/>
             <pc:sldMk cId="2182435635" sldId="258"/>
@@ -215,7 +216,7 @@
         </pc:spChg>
       </pc:sldChg>
       <pc:sldChg chg="modSp new mod ord">
-        <pc:chgData name="Tyrion Bao" userId="86a2b12e41226f78" providerId="LiveId" clId="{BE0B2CE4-1428-496C-ACE6-ADB1F60287EC}" dt="2026-10-02T07:55:28.158" v="1737" actId="20577"/>
+        <pc:chgData name="Tyrion Bao" userId="86a2b12e41226f78" providerId="LiveId" clId="{BE0B2CE4-1428-496C-ACE6-ADB1F60287EC}" dt="2026-10-08T12:06:38.040" v="2563" actId="20577"/>
         <pc:sldMkLst>
           <pc:docMk/>
           <pc:sldMk cId="3127194409" sldId="259"/>
@@ -229,7 +230,7 @@
           </ac:spMkLst>
         </pc:spChg>
         <pc:spChg chg="mod">
-          <ac:chgData name="Tyrion Bao" userId="86a2b12e41226f78" providerId="LiveId" clId="{BE0B2CE4-1428-496C-ACE6-ADB1F60287EC}" dt="2026-10-02T07:55:28.158" v="1737" actId="20577"/>
+          <ac:chgData name="Tyrion Bao" userId="86a2b12e41226f78" providerId="LiveId" clId="{BE0B2CE4-1428-496C-ACE6-ADB1F60287EC}" dt="2026-10-08T12:06:38.040" v="2563" actId="20577"/>
           <ac:spMkLst>
             <pc:docMk/>
             <pc:sldMk cId="3127194409" sldId="259"/>
@@ -238,13 +239,13 @@
         </pc:spChg>
       </pc:sldChg>
       <pc:sldChg chg="modSp new mod">
-        <pc:chgData name="Tyrion Bao" userId="86a2b12e41226f78" providerId="LiveId" clId="{BE0B2CE4-1428-496C-ACE6-ADB1F60287EC}" dt="2026-10-08T08:10:25.802" v="2166" actId="20577"/>
+        <pc:chgData name="Tyrion Bao" userId="86a2b12e41226f78" providerId="LiveId" clId="{BE0B2CE4-1428-496C-ACE6-ADB1F60287EC}" dt="2026-10-08T12:22:58.205" v="2621" actId="20577"/>
         <pc:sldMkLst>
           <pc:docMk/>
           <pc:sldMk cId="1800488566" sldId="260"/>
         </pc:sldMkLst>
         <pc:spChg chg="mod">
-          <ac:chgData name="Tyrion Bao" userId="86a2b12e41226f78" providerId="LiveId" clId="{BE0B2CE4-1428-496C-ACE6-ADB1F60287EC}" dt="2026-10-08T08:10:25.802" v="2166" actId="20577"/>
+          <ac:chgData name="Tyrion Bao" userId="86a2b12e41226f78" providerId="LiveId" clId="{BE0B2CE4-1428-496C-ACE6-ADB1F60287EC}" dt="2026-10-08T12:22:58.205" v="2621" actId="20577"/>
           <ac:spMkLst>
             <pc:docMk/>
             <pc:sldMk cId="1800488566" sldId="260"/>
@@ -253,7 +254,7 @@
         </pc:spChg>
       </pc:sldChg>
       <pc:sldChg chg="modSp new add del mod">
-        <pc:chgData name="Tyrion Bao" userId="86a2b12e41226f78" providerId="LiveId" clId="{BE0B2CE4-1428-496C-ACE6-ADB1F60287EC}" dt="2026-10-02T09:59:00.326" v="1827" actId="20577"/>
+        <pc:chgData name="Tyrion Bao" userId="86a2b12e41226f78" providerId="LiveId" clId="{BE0B2CE4-1428-496C-ACE6-ADB1F60287EC}" dt="2026-10-08T12:23:52.779" v="2679" actId="20577"/>
         <pc:sldMkLst>
           <pc:docMk/>
           <pc:sldMk cId="3986438202" sldId="261"/>
@@ -267,7 +268,7 @@
           </ac:spMkLst>
         </pc:spChg>
         <pc:spChg chg="mod">
-          <ac:chgData name="Tyrion Bao" userId="86a2b12e41226f78" providerId="LiveId" clId="{BE0B2CE4-1428-496C-ACE6-ADB1F60287EC}" dt="2026-10-02T07:47:20.532" v="517" actId="20577"/>
+          <ac:chgData name="Tyrion Bao" userId="86a2b12e41226f78" providerId="LiveId" clId="{BE0B2CE4-1428-496C-ACE6-ADB1F60287EC}" dt="2026-10-08T12:23:52.779" v="2679" actId="20577"/>
           <ac:spMkLst>
             <pc:docMk/>
             <pc:sldMk cId="3986438202" sldId="261"/>
@@ -276,7 +277,7 @@
         </pc:spChg>
       </pc:sldChg>
       <pc:sldChg chg="modSp new mod">
-        <pc:chgData name="Tyrion Bao" userId="86a2b12e41226f78" providerId="LiveId" clId="{BE0B2CE4-1428-496C-ACE6-ADB1F60287EC}" dt="2026-10-02T10:05:37.055" v="2060" actId="20577"/>
+        <pc:chgData name="Tyrion Bao" userId="86a2b12e41226f78" providerId="LiveId" clId="{BE0B2CE4-1428-496C-ACE6-ADB1F60287EC}" dt="2026-10-08T12:24:01.065" v="2680" actId="20577"/>
         <pc:sldMkLst>
           <pc:docMk/>
           <pc:sldMk cId="943744701" sldId="262"/>
@@ -290,7 +291,7 @@
           </ac:spMkLst>
         </pc:spChg>
         <pc:spChg chg="mod">
-          <ac:chgData name="Tyrion Bao" userId="86a2b12e41226f78" providerId="LiveId" clId="{BE0B2CE4-1428-496C-ACE6-ADB1F60287EC}" dt="2026-10-02T10:05:37.055" v="2060" actId="20577"/>
+          <ac:chgData name="Tyrion Bao" userId="86a2b12e41226f78" providerId="LiveId" clId="{BE0B2CE4-1428-496C-ACE6-ADB1F60287EC}" dt="2026-10-08T12:24:01.065" v="2680" actId="20577"/>
           <ac:spMkLst>
             <pc:docMk/>
             <pc:sldMk cId="943744701" sldId="262"/>
@@ -3574,36 +3575,24 @@
         <p:spPr/>
         <p:txBody>
           <a:bodyPr>
-            <a:normAutofit/>
+            <a:normAutofit fontScale="90000"/>
           </a:bodyPr>
           <a:lstStyle/>
           <a:p>
             <a:r>
-              <a:rPr lang="en-US" altLang="zh-CN" err="1"/>
+              <a:rPr lang="en-US" altLang="zh-CN" dirty="0" err="1"/>
               <a:t>WebGPU</a:t>
             </a:r>
             <a:r>
-              <a:rPr lang="en-US" altLang="zh-CN"/>
-              <a:t> Renderer</a:t>
-            </a:r>
-            <a:r>
-              <a:rPr lang="en-US" altLang="zh-CN" sz="1800"/>
-              <a:t>(</a:t>
-            </a:r>
-            <a:r>
-              <a:rPr lang="en-US" altLang="zh-CN" sz="1800" dirty="0" err="1"/>
-              <a:t>WebGPU</a:t>
-            </a:r>
-            <a:r>
-              <a:rPr lang="en-US" altLang="zh-CN" sz="1800" dirty="0"/>
-              <a:t>-Vulkan-Android)</a:t>
+              <a:rPr lang="en-US" altLang="zh-CN" dirty="0"/>
+              <a:t>-Vulkan-Android Renderer</a:t>
             </a:r>
             <a:br>
               <a:rPr lang="en-US" altLang="zh-CN" dirty="0"/>
             </a:br>
             <a:r>
               <a:rPr lang="en-US" altLang="zh-CN" dirty="0"/>
-              <a:t>Car rendering showcase</a:t>
+              <a:t>Car rendering case study</a:t>
             </a:r>
             <a:endParaRPr lang="zh-CN" altLang="en-US" dirty="0"/>
           </a:p>
@@ -3627,7 +3616,7 @@
         </p:nvSpPr>
         <p:spPr>
           <a:xfrm>
-            <a:off x="1524000" y="3602038"/>
+            <a:off x="1524000" y="3620449"/>
             <a:ext cx="9144000" cy="982236"/>
           </a:xfrm>
         </p:spPr>
@@ -3706,7 +3695,7 @@
           <a:p>
             <a:r>
               <a:rPr lang="en-US" altLang="zh-CN" dirty="0"/>
-              <a:t>Rendering result</a:t>
+              <a:t>Showcase</a:t>
             </a:r>
             <a:endParaRPr lang="zh-CN" altLang="en-US" dirty="0"/>
           </a:p>
@@ -3790,7 +3779,7 @@
           <a:p>
             <a:r>
               <a:rPr lang="en-US" altLang="zh-CN" dirty="0"/>
-              <a:t>High level overview</a:t>
+              <a:t>Architecture</a:t>
             </a:r>
             <a:endParaRPr lang="zh-CN" altLang="en-US" dirty="0"/>
           </a:p>
@@ -3843,7 +3832,7 @@
         </p:blipFill>
         <p:spPr>
           <a:xfrm>
-            <a:off x="2920157" y="1659928"/>
+            <a:off x="2834240" y="1659928"/>
             <a:ext cx="6994898" cy="4832947"/>
           </a:xfrm>
           <a:prstGeom prst="rect">
@@ -3904,7 +3893,7 @@
           <a:p>
             <a:r>
               <a:rPr lang="en-US" altLang="zh-CN" dirty="0"/>
-              <a:t>Core Functionality</a:t>
+              <a:t>Core Feature</a:t>
             </a:r>
             <a:endParaRPr lang="zh-CN" altLang="en-US" dirty="0"/>
           </a:p>
@@ -4023,7 +4012,7 @@
           <a:p>
             <a:r>
               <a:rPr lang="en-US" altLang="zh-CN" dirty="0"/>
-              <a:t>Performance analysis</a:t>
+              <a:t>Functional analysis</a:t>
             </a:r>
           </a:p>
           <a:p>
@@ -4035,7 +4024,7 @@
           <a:p>
             <a:r>
               <a:rPr lang="en-US" altLang="zh-CN" dirty="0"/>
-              <a:t>AI potential analysis</a:t>
+              <a:t>AI integration analysis</a:t>
             </a:r>
           </a:p>
           <a:p>
@@ -4250,13 +4239,18 @@
           <a:p>
             <a:r>
               <a:rPr lang="en-US" altLang="zh-CN" dirty="0"/>
-              <a:t>Rust</a:t>
-            </a:r>
+              <a:t>Vulkan/ </a:t>
+            </a:r>
+            <a:r>
+              <a:rPr lang="en-US" altLang="zh-CN" dirty="0" err="1"/>
+              <a:t>WebGPU</a:t>
+            </a:r>
+            <a:endParaRPr lang="en-US" altLang="zh-CN" dirty="0"/>
           </a:p>
           <a:p>
             <a:r>
               <a:rPr lang="en-US" altLang="zh-CN" dirty="0"/>
-              <a:t>Vulkan rendering backend</a:t>
+              <a:t>Android ADB debugging</a:t>
             </a:r>
           </a:p>
           <a:p>
@@ -4352,13 +4346,13 @@
           <a:p>
             <a:r>
               <a:rPr lang="en-US" altLang="zh-CN" dirty="0"/>
-              <a:t>My technical goal is to deeply engage with AI development pipeline while understanding matters from an academic viewpoint so I can perform necessary customization when necessary</a:t>
+              <a:t>One of my goal is to deeply utilize AI during rendering engineering. While understanding matters from an academic viewpoint so I can perform necessary customization when necessary and provide accurate consulting services.</a:t>
             </a:r>
           </a:p>
           <a:p>
             <a:r>
               <a:rPr lang="en-US" altLang="zh-CN" dirty="0"/>
-              <a:t>My personal career goal will lean to engine optimization or client-facing technical consulting</a:t>
+              <a:t>My career goal will lean towards low level rendering engine optimization or client-facing consulting because of my language advantage</a:t>
             </a:r>
           </a:p>
           <a:p>

</xml_diff>

<commit_message>
feat: add wireless debugging deployment script and update debug APK
</commit_message>
<xml_diff>
--- a/WebGPU Renderer.pptx
+++ b/WebGPU Renderer.pptx
@@ -124,7 +124,7 @@
 <p1510:revInfo xmlns:a="http://schemas.openxmlformats.org/drawingml/2006/main" xmlns:r="http://schemas.openxmlformats.org/officeDocument/2006/relationships" xmlns:p1510="http://schemas.microsoft.com/office/powerpoint/2015/10/main">
   <p1510:revLst>
     <p1510:client id="{4E806664-B705-48D9-877F-D458C7EA0EF2}" v="1" dt="2026-10-08T08:35:45.944"/>
-    <p1510:client id="{CB766BFE-92B0-4947-B12B-4251E9BB4474}" v="2" dt="2026-10-08T12:22:31.155"/>
+    <p1510:client id="{CB766BFE-92B0-4947-B12B-4251E9BB4474}" v="3" dt="2026-10-08T12:27:12.495"/>
   </p1510:revLst>
 </p1510:revInfo>
 </file>
@@ -134,18 +134,18 @@
   <pc:docChgLst>
     <pc:chgData name="Tyrion Bao" userId="86a2b12e41226f78" providerId="LiveId" clId="{BE0B2CE4-1428-496C-ACE6-ADB1F60287EC}"/>
     <pc:docChg chg="undo custSel addSld delSld modSld sldOrd">
-      <pc:chgData name="Tyrion Bao" userId="86a2b12e41226f78" providerId="LiveId" clId="{BE0B2CE4-1428-496C-ACE6-ADB1F60287EC}" dt="2026-10-08T12:24:17.406" v="2681" actId="1076"/>
+      <pc:chgData name="Tyrion Bao" userId="86a2b12e41226f78" providerId="LiveId" clId="{BE0B2CE4-1428-496C-ACE6-ADB1F60287EC}" dt="2026-10-08T12:56:54.269" v="2752" actId="20577"/>
       <pc:docMkLst>
         <pc:docMk/>
       </pc:docMkLst>
       <pc:sldChg chg="modSp new mod">
-        <pc:chgData name="Tyrion Bao" userId="86a2b12e41226f78" providerId="LiveId" clId="{BE0B2CE4-1428-496C-ACE6-ADB1F60287EC}" dt="2026-10-08T12:22:41.281" v="2601" actId="1076"/>
+        <pc:chgData name="Tyrion Bao" userId="86a2b12e41226f78" providerId="LiveId" clId="{BE0B2CE4-1428-496C-ACE6-ADB1F60287EC}" dt="2026-10-08T12:27:43.123" v="2711" actId="20577"/>
         <pc:sldMkLst>
           <pc:docMk/>
           <pc:sldMk cId="3812720094" sldId="256"/>
         </pc:sldMkLst>
         <pc:spChg chg="mod">
-          <ac:chgData name="Tyrion Bao" userId="86a2b12e41226f78" providerId="LiveId" clId="{BE0B2CE4-1428-496C-ACE6-ADB1F60287EC}" dt="2026-10-08T12:22:37.526" v="2600" actId="20577"/>
+          <ac:chgData name="Tyrion Bao" userId="86a2b12e41226f78" providerId="LiveId" clId="{BE0B2CE4-1428-496C-ACE6-ADB1F60287EC}" dt="2026-10-08T12:27:21.950" v="2685" actId="20577"/>
           <ac:spMkLst>
             <pc:docMk/>
             <pc:sldMk cId="3812720094" sldId="256"/>
@@ -153,7 +153,7 @@
           </ac:spMkLst>
         </pc:spChg>
         <pc:spChg chg="mod">
-          <ac:chgData name="Tyrion Bao" userId="86a2b12e41226f78" providerId="LiveId" clId="{BE0B2CE4-1428-496C-ACE6-ADB1F60287EC}" dt="2026-10-08T12:22:41.281" v="2601" actId="1076"/>
+          <ac:chgData name="Tyrion Bao" userId="86a2b12e41226f78" providerId="LiveId" clId="{BE0B2CE4-1428-496C-ACE6-ADB1F60287EC}" dt="2026-10-08T12:27:43.123" v="2711" actId="20577"/>
           <ac:spMkLst>
             <pc:docMk/>
             <pc:sldMk cId="3812720094" sldId="256"/>
@@ -277,13 +277,13 @@
         </pc:spChg>
       </pc:sldChg>
       <pc:sldChg chg="modSp new mod">
-        <pc:chgData name="Tyrion Bao" userId="86a2b12e41226f78" providerId="LiveId" clId="{BE0B2CE4-1428-496C-ACE6-ADB1F60287EC}" dt="2026-10-08T12:24:01.065" v="2680" actId="20577"/>
+        <pc:chgData name="Tyrion Bao" userId="86a2b12e41226f78" providerId="LiveId" clId="{BE0B2CE4-1428-496C-ACE6-ADB1F60287EC}" dt="2026-10-08T12:56:54.269" v="2752" actId="20577"/>
         <pc:sldMkLst>
           <pc:docMk/>
           <pc:sldMk cId="943744701" sldId="262"/>
         </pc:sldMkLst>
         <pc:spChg chg="mod">
-          <ac:chgData name="Tyrion Bao" userId="86a2b12e41226f78" providerId="LiveId" clId="{BE0B2CE4-1428-496C-ACE6-ADB1F60287EC}" dt="2026-10-02T10:05:20.945" v="2057" actId="20577"/>
+          <ac:chgData name="Tyrion Bao" userId="86a2b12e41226f78" providerId="LiveId" clId="{BE0B2CE4-1428-496C-ACE6-ADB1F60287EC}" dt="2026-10-08T12:52:35.695" v="2747" actId="20577"/>
           <ac:spMkLst>
             <pc:docMk/>
             <pc:sldMk cId="943744701" sldId="262"/>
@@ -291,7 +291,7 @@
           </ac:spMkLst>
         </pc:spChg>
         <pc:spChg chg="mod">
-          <ac:chgData name="Tyrion Bao" userId="86a2b12e41226f78" providerId="LiveId" clId="{BE0B2CE4-1428-496C-ACE6-ADB1F60287EC}" dt="2026-10-08T12:24:01.065" v="2680" actId="20577"/>
+          <ac:chgData name="Tyrion Bao" userId="86a2b12e41226f78" providerId="LiveId" clId="{BE0B2CE4-1428-496C-ACE6-ADB1F60287EC}" dt="2026-10-08T12:56:54.269" v="2752" actId="20577"/>
           <ac:spMkLst>
             <pc:docMk/>
             <pc:sldMk cId="943744701" sldId="262"/>
@@ -3621,7 +3621,9 @@
           </a:xfrm>
         </p:spPr>
         <p:txBody>
-          <a:bodyPr/>
+          <a:bodyPr>
+            <a:normAutofit/>
+          </a:bodyPr>
           <a:lstStyle/>
           <a:p>
             <a:r>
@@ -3630,7 +3632,7 @@
             </a:r>
             <a:r>
               <a:rPr lang="en-US" altLang="zh-CN" dirty="0"/>
-              <a:t> Japan </a:t>
+              <a:t> Japan</a:t>
             </a:r>
           </a:p>
           <a:p>
@@ -4186,7 +4188,7 @@
           <a:p>
             <a:r>
               <a:rPr lang="en-US" altLang="zh-CN" dirty="0"/>
-              <a:t>Other technology I learnt from the experience</a:t>
+              <a:t>Other technologies help with the project</a:t>
             </a:r>
             <a:endParaRPr lang="zh-CN" altLang="en-US" dirty="0"/>
           </a:p>
@@ -4245,12 +4247,26 @@
               <a:rPr lang="en-US" altLang="zh-CN" dirty="0" err="1"/>
               <a:t>WebGPU</a:t>
             </a:r>
+            <a:r>
+              <a:rPr lang="en-US" altLang="zh-CN" dirty="0"/>
+              <a:t> </a:t>
+            </a:r>
+            <a:r>
+              <a:rPr lang="zh-CN" altLang="zh-CN" dirty="0"/>
+              <a:t>specification</a:t>
+            </a:r>
             <a:endParaRPr lang="en-US" altLang="zh-CN" dirty="0"/>
           </a:p>
           <a:p>
             <a:r>
               <a:rPr lang="en-US" altLang="zh-CN" dirty="0"/>
               <a:t>Android ADB debugging</a:t>
+            </a:r>
+          </a:p>
+          <a:p>
+            <a:r>
+              <a:rPr lang="en-US" altLang="zh-CN" dirty="0"/>
+              <a:t>Rust</a:t>
             </a:r>
           </a:p>
           <a:p>

</xml_diff>

<commit_message>
feat(android): implement native ANativeWindow presentation swapchain and update dependencies
</commit_message>
<xml_diff>
--- a/WebGPU Renderer.pptx
+++ b/WebGPU Renderer.pptx
@@ -134,7 +134,7 @@
   <pc:docChgLst>
     <pc:chgData name="Tyrion Bao" userId="86a2b12e41226f78" providerId="LiveId" clId="{BE0B2CE4-1428-496C-ACE6-ADB1F60287EC}"/>
     <pc:docChg chg="undo custSel addSld delSld modSld sldOrd">
-      <pc:chgData name="Tyrion Bao" userId="86a2b12e41226f78" providerId="LiveId" clId="{BE0B2CE4-1428-496C-ACE6-ADB1F60287EC}" dt="2026-10-08T12:56:54.269" v="2752" actId="20577"/>
+      <pc:chgData name="Tyrion Bao" userId="86a2b12e41226f78" providerId="LiveId" clId="{BE0B2CE4-1428-496C-ACE6-ADB1F60287EC}" dt="2026-10-09T05:59:57.721" v="2879" actId="20577"/>
       <pc:docMkLst>
         <pc:docMk/>
       </pc:docMkLst>
@@ -277,13 +277,13 @@
         </pc:spChg>
       </pc:sldChg>
       <pc:sldChg chg="modSp new mod">
-        <pc:chgData name="Tyrion Bao" userId="86a2b12e41226f78" providerId="LiveId" clId="{BE0B2CE4-1428-496C-ACE6-ADB1F60287EC}" dt="2026-10-08T12:56:54.269" v="2752" actId="20577"/>
+        <pc:chgData name="Tyrion Bao" userId="86a2b12e41226f78" providerId="LiveId" clId="{BE0B2CE4-1428-496C-ACE6-ADB1F60287EC}" dt="2026-10-09T05:59:57.721" v="2879" actId="20577"/>
         <pc:sldMkLst>
           <pc:docMk/>
           <pc:sldMk cId="943744701" sldId="262"/>
         </pc:sldMkLst>
         <pc:spChg chg="mod">
-          <ac:chgData name="Tyrion Bao" userId="86a2b12e41226f78" providerId="LiveId" clId="{BE0B2CE4-1428-496C-ACE6-ADB1F60287EC}" dt="2026-10-08T12:52:35.695" v="2747" actId="20577"/>
+          <ac:chgData name="Tyrion Bao" userId="86a2b12e41226f78" providerId="LiveId" clId="{BE0B2CE4-1428-496C-ACE6-ADB1F60287EC}" dt="2026-10-09T05:59:32.981" v="2787" actId="20577"/>
           <ac:spMkLst>
             <pc:docMk/>
             <pc:sldMk cId="943744701" sldId="262"/>
@@ -291,7 +291,7 @@
           </ac:spMkLst>
         </pc:spChg>
         <pc:spChg chg="mod">
-          <ac:chgData name="Tyrion Bao" userId="86a2b12e41226f78" providerId="LiveId" clId="{BE0B2CE4-1428-496C-ACE6-ADB1F60287EC}" dt="2026-10-08T12:56:54.269" v="2752" actId="20577"/>
+          <ac:chgData name="Tyrion Bao" userId="86a2b12e41226f78" providerId="LiveId" clId="{BE0B2CE4-1428-496C-ACE6-ADB1F60287EC}" dt="2026-10-09T05:59:57.721" v="2879" actId="20577"/>
           <ac:spMkLst>
             <pc:docMk/>
             <pc:sldMk cId="943744701" sldId="262"/>
@@ -4188,7 +4188,7 @@
           <a:p>
             <a:r>
               <a:rPr lang="en-US" altLang="zh-CN" dirty="0"/>
-              <a:t>Other technologies help with the project</a:t>
+              <a:t>Other technologies used</a:t>
             </a:r>
             <a:endParaRPr lang="zh-CN" altLang="en-US" dirty="0"/>
           </a:p>
@@ -4214,12 +4214,6 @@
         <p:txBody>
           <a:bodyPr/>
           <a:lstStyle/>
-          <a:p>
-            <a:r>
-              <a:rPr lang="en-US" altLang="zh-CN" dirty="0"/>
-              <a:t>Google Antigravity IDE</a:t>
-            </a:r>
-          </a:p>
           <a:p>
             <a:r>
               <a:rPr lang="en-US" altLang="zh-CN" dirty="0"/>
@@ -4234,40 +4228,34 @@
           </a:p>
           <a:p>
             <a:r>
-              <a:rPr lang="en-US" altLang="zh-CN" dirty="0"/>
-              <a:t>Python</a:t>
-            </a:r>
-          </a:p>
-          <a:p>
-            <a:r>
-              <a:rPr lang="en-US" altLang="zh-CN" dirty="0"/>
-              <a:t>Vulkan/ </a:t>
-            </a:r>
-            <a:r>
               <a:rPr lang="en-US" altLang="zh-CN" dirty="0" err="1"/>
               <a:t>WebGPU</a:t>
             </a:r>
             <a:r>
               <a:rPr lang="en-US" altLang="zh-CN" dirty="0"/>
+              <a:t> standard</a:t>
+            </a:r>
+          </a:p>
+          <a:p>
+            <a:r>
+              <a:rPr lang="en-US" altLang="zh-CN" dirty="0"/>
+              <a:t>Android ADB debugging/Android OS/Android APK structure</a:t>
+            </a:r>
+          </a:p>
+          <a:p>
+            <a:r>
+              <a:rPr lang="en-US" altLang="zh-CN" dirty="0"/>
+              <a:t>Rust programming language for </a:t>
+            </a:r>
+            <a:r>
+              <a:rPr lang="en-US" altLang="zh-CN" dirty="0" err="1"/>
+              <a:t>WebGPU</a:t>
+            </a:r>
+            <a:r>
+              <a:rPr lang="en-US" altLang="zh-CN"/>
               <a:t> </a:t>
             </a:r>
-            <a:r>
-              <a:rPr lang="zh-CN" altLang="zh-CN" dirty="0"/>
-              <a:t>specification</a:t>
-            </a:r>
             <a:endParaRPr lang="en-US" altLang="zh-CN" dirty="0"/>
-          </a:p>
-          <a:p>
-            <a:r>
-              <a:rPr lang="en-US" altLang="zh-CN" dirty="0"/>
-              <a:t>Android ADB debugging</a:t>
-            </a:r>
-          </a:p>
-          <a:p>
-            <a:r>
-              <a:rPr lang="en-US" altLang="zh-CN" dirty="0"/>
-              <a:t>Rust</a:t>
-            </a:r>
           </a:p>
           <a:p>
             <a:pPr marL="0" indent="0">

</xml_diff>

<commit_message>
fix: handle empty file list in commit message generator
</commit_message>
<xml_diff>
--- a/WebGPU Renderer.pptx
+++ b/WebGPU Renderer.pptx
@@ -123,7 +123,6 @@
 <file path=ppt/revisionInfo.xml><?xml version="1.0" encoding="utf-8"?>
 <p1510:revInfo xmlns:a="http://schemas.openxmlformats.org/drawingml/2006/main" xmlns:r="http://schemas.openxmlformats.org/officeDocument/2006/relationships" xmlns:p1510="http://schemas.microsoft.com/office/powerpoint/2015/10/main">
   <p1510:revLst>
-    <p1510:client id="{4E806664-B705-48D9-877F-D458C7EA0EF2}" v="1" dt="2026-10-08T08:35:45.944"/>
     <p1510:client id="{CB766BFE-92B0-4947-B12B-4251E9BB4474}" v="3" dt="2026-10-08T12:27:12.495"/>
   </p1510:revLst>
 </p1510:revInfo>
@@ -134,7 +133,7 @@
   <pc:docChgLst>
     <pc:chgData name="Tyrion Bao" userId="86a2b12e41226f78" providerId="LiveId" clId="{BE0B2CE4-1428-496C-ACE6-ADB1F60287EC}"/>
     <pc:docChg chg="undo custSel addSld delSld modSld sldOrd">
-      <pc:chgData name="Tyrion Bao" userId="86a2b12e41226f78" providerId="LiveId" clId="{BE0B2CE4-1428-496C-ACE6-ADB1F60287EC}" dt="2026-10-09T05:59:57.721" v="2879" actId="20577"/>
+      <pc:chgData name="Tyrion Bao" userId="86a2b12e41226f78" providerId="LiveId" clId="{BE0B2CE4-1428-496C-ACE6-ADB1F60287EC}" dt="2026-10-09T10:18:23.916" v="2883" actId="1076"/>
       <pc:docMkLst>
         <pc:docMk/>
       </pc:docMkLst>
@@ -162,7 +161,7 @@
         </pc:spChg>
       </pc:sldChg>
       <pc:sldChg chg="addSp delSp modSp new mod">
-        <pc:chgData name="Tyrion Bao" userId="86a2b12e41226f78" providerId="LiveId" clId="{BE0B2CE4-1428-496C-ACE6-ADB1F60287EC}" dt="2026-10-08T12:24:17.406" v="2681" actId="1076"/>
+        <pc:chgData name="Tyrion Bao" userId="86a2b12e41226f78" providerId="LiveId" clId="{BE0B2CE4-1428-496C-ACE6-ADB1F60287EC}" dt="2026-10-09T10:18:23.916" v="2883" actId="1076"/>
         <pc:sldMkLst>
           <pc:docMk/>
           <pc:sldMk cId="1637792322" sldId="257"/>
@@ -192,7 +191,15 @@
           </ac:picMkLst>
         </pc:picChg>
         <pc:picChg chg="add mod">
-          <ac:chgData name="Tyrion Bao" userId="86a2b12e41226f78" providerId="LiveId" clId="{BE0B2CE4-1428-496C-ACE6-ADB1F60287EC}" dt="2026-10-08T12:24:17.406" v="2681" actId="1076"/>
+          <ac:chgData name="Tyrion Bao" userId="86a2b12e41226f78" providerId="LiveId" clId="{BE0B2CE4-1428-496C-ACE6-ADB1F60287EC}" dt="2026-10-09T10:18:23.916" v="2883" actId="1076"/>
+          <ac:picMkLst>
+            <pc:docMk/>
+            <pc:sldMk cId="1637792322" sldId="257"/>
+            <ac:picMk id="5" creationId="{8923175F-3781-1CBD-86B8-235251AAD9CB}"/>
+          </ac:picMkLst>
+        </pc:picChg>
+        <pc:picChg chg="add del mod">
+          <ac:chgData name="Tyrion Bao" userId="86a2b12e41226f78" providerId="LiveId" clId="{BE0B2CE4-1428-496C-ACE6-ADB1F60287EC}" dt="2026-10-09T10:18:15.626" v="2880" actId="478"/>
           <ac:picMkLst>
             <pc:docMk/>
             <pc:sldMk cId="1637792322" sldId="257"/>
@@ -489,7 +496,7 @@
           <a:p>
             <a:fld id="{9B10F84E-4F92-482B-9E59-E7E052490FE2}" type="datetimeFigureOut">
               <a:rPr lang="zh-CN" altLang="en-US" smtClean="0"/>
-              <a:t>2026/10/8</a:t>
+              <a:t>2026/10/9</a:t>
             </a:fld>
             <a:endParaRPr lang="zh-CN" altLang="en-US"/>
           </a:p>
@@ -687,7 +694,7 @@
           <a:p>
             <a:fld id="{9B10F84E-4F92-482B-9E59-E7E052490FE2}" type="datetimeFigureOut">
               <a:rPr lang="zh-CN" altLang="en-US" smtClean="0"/>
-              <a:t>2026/10/8</a:t>
+              <a:t>2026/10/9</a:t>
             </a:fld>
             <a:endParaRPr lang="zh-CN" altLang="en-US"/>
           </a:p>
@@ -895,7 +902,7 @@
           <a:p>
             <a:fld id="{9B10F84E-4F92-482B-9E59-E7E052490FE2}" type="datetimeFigureOut">
               <a:rPr lang="zh-CN" altLang="en-US" smtClean="0"/>
-              <a:t>2026/10/8</a:t>
+              <a:t>2026/10/9</a:t>
             </a:fld>
             <a:endParaRPr lang="zh-CN" altLang="en-US"/>
           </a:p>
@@ -1093,7 +1100,7 @@
           <a:p>
             <a:fld id="{9B10F84E-4F92-482B-9E59-E7E052490FE2}" type="datetimeFigureOut">
               <a:rPr lang="zh-CN" altLang="en-US" smtClean="0"/>
-              <a:t>2026/10/8</a:t>
+              <a:t>2026/10/9</a:t>
             </a:fld>
             <a:endParaRPr lang="zh-CN" altLang="en-US"/>
           </a:p>
@@ -1368,7 +1375,7 @@
           <a:p>
             <a:fld id="{9B10F84E-4F92-482B-9E59-E7E052490FE2}" type="datetimeFigureOut">
               <a:rPr lang="zh-CN" altLang="en-US" smtClean="0"/>
-              <a:t>2026/10/8</a:t>
+              <a:t>2026/10/9</a:t>
             </a:fld>
             <a:endParaRPr lang="zh-CN" altLang="en-US"/>
           </a:p>
@@ -1633,7 +1640,7 @@
           <a:p>
             <a:fld id="{9B10F84E-4F92-482B-9E59-E7E052490FE2}" type="datetimeFigureOut">
               <a:rPr lang="zh-CN" altLang="en-US" smtClean="0"/>
-              <a:t>2026/10/8</a:t>
+              <a:t>2026/10/9</a:t>
             </a:fld>
             <a:endParaRPr lang="zh-CN" altLang="en-US"/>
           </a:p>
@@ -2045,7 +2052,7 @@
           <a:p>
             <a:fld id="{9B10F84E-4F92-482B-9E59-E7E052490FE2}" type="datetimeFigureOut">
               <a:rPr lang="zh-CN" altLang="en-US" smtClean="0"/>
-              <a:t>2026/10/8</a:t>
+              <a:t>2026/10/9</a:t>
             </a:fld>
             <a:endParaRPr lang="zh-CN" altLang="en-US"/>
           </a:p>
@@ -2186,7 +2193,7 @@
           <a:p>
             <a:fld id="{9B10F84E-4F92-482B-9E59-E7E052490FE2}" type="datetimeFigureOut">
               <a:rPr lang="zh-CN" altLang="en-US" smtClean="0"/>
-              <a:t>2026/10/8</a:t>
+              <a:t>2026/10/9</a:t>
             </a:fld>
             <a:endParaRPr lang="zh-CN" altLang="en-US"/>
           </a:p>
@@ -2299,7 +2306,7 @@
           <a:p>
             <a:fld id="{9B10F84E-4F92-482B-9E59-E7E052490FE2}" type="datetimeFigureOut">
               <a:rPr lang="zh-CN" altLang="en-US" smtClean="0"/>
-              <a:t>2026/10/8</a:t>
+              <a:t>2026/10/9</a:t>
             </a:fld>
             <a:endParaRPr lang="zh-CN" altLang="en-US"/>
           </a:p>
@@ -2610,7 +2617,7 @@
           <a:p>
             <a:fld id="{9B10F84E-4F92-482B-9E59-E7E052490FE2}" type="datetimeFigureOut">
               <a:rPr lang="zh-CN" altLang="en-US" smtClean="0"/>
-              <a:t>2026/10/8</a:t>
+              <a:t>2026/10/9</a:t>
             </a:fld>
             <a:endParaRPr lang="zh-CN" altLang="en-US"/>
           </a:p>
@@ -2898,7 +2905,7 @@
           <a:p>
             <a:fld id="{9B10F84E-4F92-482B-9E59-E7E052490FE2}" type="datetimeFigureOut">
               <a:rPr lang="zh-CN" altLang="en-US" smtClean="0"/>
-              <a:t>2026/10/8</a:t>
+              <a:t>2026/10/9</a:t>
             </a:fld>
             <a:endParaRPr lang="zh-CN" altLang="en-US"/>
           </a:p>
@@ -3139,7 +3146,7 @@
           <a:p>
             <a:fld id="{9B10F84E-4F92-482B-9E59-E7E052490FE2}" type="datetimeFigureOut">
               <a:rPr lang="zh-CN" altLang="en-US" smtClean="0"/>
-              <a:t>2026/10/8</a:t>
+              <a:t>2026/10/9</a:t>
             </a:fld>
             <a:endParaRPr lang="zh-CN" altLang="en-US"/>
           </a:p>
@@ -3814,10 +3821,10 @@
       </p:sp>
       <p:pic>
         <p:nvPicPr>
-          <p:cNvPr id="7" name="图片 6">
-            <a:extLst>
-              <a:ext uri="{FF2B5EF4-FFF2-40B4-BE49-F238E27FC236}">
-                <a16:creationId xmlns:a16="http://schemas.microsoft.com/office/drawing/2014/main" id="{276E3B66-26FF-AD36-908C-F3F6ECA2261E}"/>
+          <p:cNvPr id="5" name="图片 4">
+            <a:extLst>
+              <a:ext uri="{FF2B5EF4-FFF2-40B4-BE49-F238E27FC236}">
+                <a16:creationId xmlns:a16="http://schemas.microsoft.com/office/drawing/2014/main" id="{8923175F-3781-1CBD-86B8-235251AAD9CB}"/>
               </a:ext>
             </a:extLst>
           </p:cNvPr>
@@ -3834,8 +3841,8 @@
         </p:blipFill>
         <p:spPr>
           <a:xfrm>
-            <a:off x="2834240" y="1659928"/>
-            <a:ext cx="6994898" cy="4832947"/>
+            <a:off x="3820131" y="237961"/>
+            <a:ext cx="5423179" cy="6382078"/>
           </a:xfrm>
           <a:prstGeom prst="rect">
             <a:avLst/>

</xml_diff>

<commit_message>
feat(model): add blender automation scripts, foliage LOD skill, update mclaren model and presentation slides
</commit_message>
<xml_diff>
--- a/WebGPU Renderer.pptx
+++ b/WebGPU Renderer.pptx
@@ -4,16 +4,24 @@
   <p:sldMasterIdLst>
     <p:sldMasterId id="2147483648" r:id="rId1"/>
   </p:sldMasterIdLst>
+  <p:notesMasterIdLst>
+    <p:notesMasterId r:id="rId16"/>
+  </p:notesMasterIdLst>
   <p:sldIdLst>
     <p:sldId id="256" r:id="rId2"/>
     <p:sldId id="260" r:id="rId3"/>
     <p:sldId id="257" r:id="rId4"/>
-    <p:sldId id="258" r:id="rId5"/>
-    <p:sldId id="261" r:id="rId6"/>
-    <p:sldId id="263" r:id="rId7"/>
-    <p:sldId id="262" r:id="rId8"/>
-    <p:sldId id="259" r:id="rId9"/>
-    <p:sldId id="265" r:id="rId10"/>
+    <p:sldId id="261" r:id="rId5"/>
+    <p:sldId id="263" r:id="rId6"/>
+    <p:sldId id="274" r:id="rId7"/>
+    <p:sldId id="268" r:id="rId8"/>
+    <p:sldId id="266" r:id="rId9"/>
+    <p:sldId id="262" r:id="rId10"/>
+    <p:sldId id="271" r:id="rId11"/>
+    <p:sldId id="272" r:id="rId12"/>
+    <p:sldId id="273" r:id="rId13"/>
+    <p:sldId id="259" r:id="rId14"/>
+    <p:sldId id="265" r:id="rId15"/>
   </p:sldIdLst>
   <p:sldSz cx="12192000" cy="6858000"/>
   <p:notesSz cx="6858000" cy="9144000"/>
@@ -123,7 +131,7 @@
 <file path=ppt/revisionInfo.xml><?xml version="1.0" encoding="utf-8"?>
 <p1510:revInfo xmlns:a="http://schemas.openxmlformats.org/drawingml/2006/main" xmlns:r="http://schemas.openxmlformats.org/officeDocument/2006/relationships" xmlns:p1510="http://schemas.microsoft.com/office/powerpoint/2015/10/main">
   <p1510:revLst>
-    <p1510:client id="{CB766BFE-92B0-4947-B12B-4251E9BB4474}" v="3" dt="2026-10-08T12:27:12.495"/>
+    <p1510:client id="{CE661803-590C-4BF4-8418-3A596B2AE982}" v="35" dt="2026-10-13T12:11:19.985"/>
   </p1510:revLst>
 </p1510:revInfo>
 </file>
@@ -133,18 +141,18 @@
   <pc:docChgLst>
     <pc:chgData name="Tyrion Bao" userId="86a2b12e41226f78" providerId="LiveId" clId="{BE0B2CE4-1428-496C-ACE6-ADB1F60287EC}"/>
     <pc:docChg chg="undo custSel addSld delSld modSld sldOrd">
-      <pc:chgData name="Tyrion Bao" userId="86a2b12e41226f78" providerId="LiveId" clId="{BE0B2CE4-1428-496C-ACE6-ADB1F60287EC}" dt="2026-10-09T10:18:23.916" v="2883" actId="1076"/>
+      <pc:chgData name="Tyrion Bao" userId="86a2b12e41226f78" providerId="LiveId" clId="{BE0B2CE4-1428-496C-ACE6-ADB1F60287EC}" dt="2026-10-09T10:41:21.447" v="3816"/>
       <pc:docMkLst>
         <pc:docMk/>
       </pc:docMkLst>
       <pc:sldChg chg="modSp new mod">
-        <pc:chgData name="Tyrion Bao" userId="86a2b12e41226f78" providerId="LiveId" clId="{BE0B2CE4-1428-496C-ACE6-ADB1F60287EC}" dt="2026-10-08T12:27:43.123" v="2711" actId="20577"/>
+        <pc:chgData name="Tyrion Bao" userId="86a2b12e41226f78" providerId="LiveId" clId="{BE0B2CE4-1428-496C-ACE6-ADB1F60287EC}" dt="2026-10-09T10:20:50.348" v="2886" actId="20577"/>
         <pc:sldMkLst>
           <pc:docMk/>
           <pc:sldMk cId="3812720094" sldId="256"/>
         </pc:sldMkLst>
         <pc:spChg chg="mod">
-          <ac:chgData name="Tyrion Bao" userId="86a2b12e41226f78" providerId="LiveId" clId="{BE0B2CE4-1428-496C-ACE6-ADB1F60287EC}" dt="2026-10-08T12:27:21.950" v="2685" actId="20577"/>
+          <ac:chgData name="Tyrion Bao" userId="86a2b12e41226f78" providerId="LiveId" clId="{BE0B2CE4-1428-496C-ACE6-ADB1F60287EC}" dt="2026-10-09T10:20:50.348" v="2886" actId="20577"/>
           <ac:spMkLst>
             <pc:docMk/>
             <pc:sldMk cId="3812720094" sldId="256"/>
@@ -182,14 +190,6 @@
             <ac:spMk id="3" creationId="{4010F9DF-5F23-AAB3-E1EA-5ADEE9B77134}"/>
           </ac:spMkLst>
         </pc:spChg>
-        <pc:picChg chg="add del mod">
-          <ac:chgData name="Tyrion Bao" userId="86a2b12e41226f78" providerId="LiveId" clId="{BE0B2CE4-1428-496C-ACE6-ADB1F60287EC}" dt="2026-10-08T08:21:50.991" v="2173" actId="478"/>
-          <ac:picMkLst>
-            <pc:docMk/>
-            <pc:sldMk cId="1637792322" sldId="257"/>
-            <ac:picMk id="5" creationId="{59F0022F-20A8-AB83-956C-892CB90B7772}"/>
-          </ac:picMkLst>
-        </pc:picChg>
         <pc:picChg chg="add mod">
           <ac:chgData name="Tyrion Bao" userId="86a2b12e41226f78" providerId="LiveId" clId="{BE0B2CE4-1428-496C-ACE6-ADB1F60287EC}" dt="2026-10-09T10:18:23.916" v="2883" actId="1076"/>
           <ac:picMkLst>
@@ -198,29 +198,6 @@
             <ac:picMk id="5" creationId="{8923175F-3781-1CBD-86B8-235251AAD9CB}"/>
           </ac:picMkLst>
         </pc:picChg>
-        <pc:picChg chg="add del mod">
-          <ac:chgData name="Tyrion Bao" userId="86a2b12e41226f78" providerId="LiveId" clId="{BE0B2CE4-1428-496C-ACE6-ADB1F60287EC}" dt="2026-10-09T10:18:15.626" v="2880" actId="478"/>
-          <ac:picMkLst>
-            <pc:docMk/>
-            <pc:sldMk cId="1637792322" sldId="257"/>
-            <ac:picMk id="7" creationId="{276E3B66-26FF-AD36-908C-F3F6ECA2261E}"/>
-          </ac:picMkLst>
-        </pc:picChg>
-      </pc:sldChg>
-      <pc:sldChg chg="modSp new mod">
-        <pc:chgData name="Tyrion Bao" userId="86a2b12e41226f78" providerId="LiveId" clId="{BE0B2CE4-1428-496C-ACE6-ADB1F60287EC}" dt="2026-10-08T12:22:53.244" v="2612" actId="20577"/>
-        <pc:sldMkLst>
-          <pc:docMk/>
-          <pc:sldMk cId="2182435635" sldId="258"/>
-        </pc:sldMkLst>
-        <pc:spChg chg="mod">
-          <ac:chgData name="Tyrion Bao" userId="86a2b12e41226f78" providerId="LiveId" clId="{BE0B2CE4-1428-496C-ACE6-ADB1F60287EC}" dt="2026-10-08T12:22:53.244" v="2612" actId="20577"/>
-          <ac:spMkLst>
-            <pc:docMk/>
-            <pc:sldMk cId="2182435635" sldId="258"/>
-            <ac:spMk id="2" creationId="{5A6A0DDF-6AE1-2597-B37F-5E53B7B0AAAE}"/>
-          </ac:spMkLst>
-        </pc:spChg>
       </pc:sldChg>
       <pc:sldChg chg="modSp new mod ord">
         <pc:chgData name="Tyrion Bao" userId="86a2b12e41226f78" providerId="LiveId" clId="{BE0B2CE4-1428-496C-ACE6-ADB1F60287EC}" dt="2026-10-08T12:06:38.040" v="2563" actId="20577"/>
@@ -261,7 +238,7 @@
         </pc:spChg>
       </pc:sldChg>
       <pc:sldChg chg="modSp new add del mod">
-        <pc:chgData name="Tyrion Bao" userId="86a2b12e41226f78" providerId="LiveId" clId="{BE0B2CE4-1428-496C-ACE6-ADB1F60287EC}" dt="2026-10-08T12:23:52.779" v="2679" actId="20577"/>
+        <pc:chgData name="Tyrion Bao" userId="86a2b12e41226f78" providerId="LiveId" clId="{BE0B2CE4-1428-496C-ACE6-ADB1F60287EC}" dt="2026-10-09T10:41:05.777" v="3812" actId="20577"/>
         <pc:sldMkLst>
           <pc:docMk/>
           <pc:sldMk cId="3986438202" sldId="261"/>
@@ -275,7 +252,7 @@
           </ac:spMkLst>
         </pc:spChg>
         <pc:spChg chg="mod">
-          <ac:chgData name="Tyrion Bao" userId="86a2b12e41226f78" providerId="LiveId" clId="{BE0B2CE4-1428-496C-ACE6-ADB1F60287EC}" dt="2026-10-08T12:23:52.779" v="2679" actId="20577"/>
+          <ac:chgData name="Tyrion Bao" userId="86a2b12e41226f78" providerId="LiveId" clId="{BE0B2CE4-1428-496C-ACE6-ADB1F60287EC}" dt="2026-10-09T10:41:05.777" v="3812" actId="20577"/>
           <ac:spMkLst>
             <pc:docMk/>
             <pc:sldMk cId="3986438202" sldId="261"/>
@@ -284,13 +261,13 @@
         </pc:spChg>
       </pc:sldChg>
       <pc:sldChg chg="modSp new mod">
-        <pc:chgData name="Tyrion Bao" userId="86a2b12e41226f78" providerId="LiveId" clId="{BE0B2CE4-1428-496C-ACE6-ADB1F60287EC}" dt="2026-10-09T05:59:57.721" v="2879" actId="20577"/>
+        <pc:chgData name="Tyrion Bao" userId="86a2b12e41226f78" providerId="LiveId" clId="{BE0B2CE4-1428-496C-ACE6-ADB1F60287EC}" dt="2026-10-09T10:38:09.430" v="3739" actId="1076"/>
         <pc:sldMkLst>
           <pc:docMk/>
           <pc:sldMk cId="943744701" sldId="262"/>
         </pc:sldMkLst>
         <pc:spChg chg="mod">
-          <ac:chgData name="Tyrion Bao" userId="86a2b12e41226f78" providerId="LiveId" clId="{BE0B2CE4-1428-496C-ACE6-ADB1F60287EC}" dt="2026-10-09T05:59:32.981" v="2787" actId="20577"/>
+          <ac:chgData name="Tyrion Bao" userId="86a2b12e41226f78" providerId="LiveId" clId="{BE0B2CE4-1428-496C-ACE6-ADB1F60287EC}" dt="2026-10-09T10:37:06.360" v="3645" actId="20577"/>
           <ac:spMkLst>
             <pc:docMk/>
             <pc:sldMk cId="943744701" sldId="262"/>
@@ -298,7 +275,7 @@
           </ac:spMkLst>
         </pc:spChg>
         <pc:spChg chg="mod">
-          <ac:chgData name="Tyrion Bao" userId="86a2b12e41226f78" providerId="LiveId" clId="{BE0B2CE4-1428-496C-ACE6-ADB1F60287EC}" dt="2026-10-09T05:59:57.721" v="2879" actId="20577"/>
+          <ac:chgData name="Tyrion Bao" userId="86a2b12e41226f78" providerId="LiveId" clId="{BE0B2CE4-1428-496C-ACE6-ADB1F60287EC}" dt="2026-10-09T10:38:09.430" v="3739" actId="1076"/>
           <ac:spMkLst>
             <pc:docMk/>
             <pc:sldMk cId="943744701" sldId="262"/>
@@ -307,25 +284,17 @@
         </pc:spChg>
       </pc:sldChg>
       <pc:sldChg chg="modSp new mod">
-        <pc:chgData name="Tyrion Bao" userId="86a2b12e41226f78" providerId="LiveId" clId="{BE0B2CE4-1428-496C-ACE6-ADB1F60287EC}" dt="2026-10-02T10:04:59.438" v="2000" actId="20577"/>
+        <pc:chgData name="Tyrion Bao" userId="86a2b12e41226f78" providerId="LiveId" clId="{BE0B2CE4-1428-496C-ACE6-ADB1F60287EC}" dt="2026-10-09T10:40:24.247" v="3745"/>
         <pc:sldMkLst>
           <pc:docMk/>
           <pc:sldMk cId="1949254824" sldId="263"/>
         </pc:sldMkLst>
         <pc:spChg chg="mod">
-          <ac:chgData name="Tyrion Bao" userId="86a2b12e41226f78" providerId="LiveId" clId="{BE0B2CE4-1428-496C-ACE6-ADB1F60287EC}" dt="2026-10-02T10:03:58.819" v="1831" actId="12"/>
+          <ac:chgData name="Tyrion Bao" userId="86a2b12e41226f78" providerId="LiveId" clId="{BE0B2CE4-1428-496C-ACE6-ADB1F60287EC}" dt="2026-10-09T10:40:24.247" v="3745"/>
           <ac:spMkLst>
             <pc:docMk/>
             <pc:sldMk cId="1949254824" sldId="263"/>
             <ac:spMk id="2" creationId="{9C52CD5E-0479-C15D-685C-53C96A9A2573}"/>
-          </ac:spMkLst>
-        </pc:spChg>
-        <pc:spChg chg="mod">
-          <ac:chgData name="Tyrion Bao" userId="86a2b12e41226f78" providerId="LiveId" clId="{BE0B2CE4-1428-496C-ACE6-ADB1F60287EC}" dt="2026-10-02T10:04:59.438" v="2000" actId="20577"/>
-          <ac:spMkLst>
-            <pc:docMk/>
-            <pc:sldMk cId="1949254824" sldId="263"/>
-            <ac:spMk id="3" creationId="{76C5F6CF-1048-44CE-5671-5D14C8C22D4E}"/>
           </ac:spMkLst>
         </pc:spChg>
       </pc:sldChg>
@@ -344,9 +313,977 @@
           </ac:spMkLst>
         </pc:spChg>
       </pc:sldChg>
+      <pc:sldChg chg="add ord">
+        <pc:chgData name="Tyrion Bao" userId="86a2b12e41226f78" providerId="LiveId" clId="{BE0B2CE4-1428-496C-ACE6-ADB1F60287EC}" dt="2026-10-09T10:36:49.756" v="3639"/>
+        <pc:sldMkLst>
+          <pc:docMk/>
+          <pc:sldMk cId="2530839382" sldId="266"/>
+        </pc:sldMkLst>
+      </pc:sldChg>
+      <pc:sldChg chg="modSp add">
+        <pc:chgData name="Tyrion Bao" userId="86a2b12e41226f78" providerId="LiveId" clId="{BE0B2CE4-1428-496C-ACE6-ADB1F60287EC}" dt="2026-10-09T10:40:36.309" v="3747"/>
+        <pc:sldMkLst>
+          <pc:docMk/>
+          <pc:sldMk cId="2556202693" sldId="268"/>
+        </pc:sldMkLst>
+        <pc:spChg chg="mod">
+          <ac:chgData name="Tyrion Bao" userId="86a2b12e41226f78" providerId="LiveId" clId="{BE0B2CE4-1428-496C-ACE6-ADB1F60287EC}" dt="2026-10-09T10:40:36.309" v="3747"/>
+          <ac:spMkLst>
+            <pc:docMk/>
+            <pc:sldMk cId="2556202693" sldId="268"/>
+            <ac:spMk id="2" creationId="{09E2114C-741A-544B-6F85-EB2F790F1920}"/>
+          </ac:spMkLst>
+        </pc:spChg>
+      </pc:sldChg>
+    </pc:docChg>
+  </pc:docChgLst>
+  <pc:docChgLst>
+    <pc:chgData name="Tyrion Bao" userId="86a2b12e41226f78" providerId="LiveId" clId="{4891CA31-0AE7-4ECE-B60E-21685528A7C5}"/>
+    <pc:docChg chg="undo custSel addSld delSld modSld">
+      <pc:chgData name="Tyrion Bao" userId="86a2b12e41226f78" providerId="LiveId" clId="{4891CA31-0AE7-4ECE-B60E-21685528A7C5}" dt="2026-10-13T12:20:14.083" v="1565" actId="1076"/>
+      <pc:docMkLst>
+        <pc:docMk/>
+      </pc:docMkLst>
+      <pc:sldChg chg="modSp mod">
+        <pc:chgData name="Tyrion Bao" userId="86a2b12e41226f78" providerId="LiveId" clId="{4891CA31-0AE7-4ECE-B60E-21685528A7C5}" dt="2026-10-13T11:10:12.346" v="1456" actId="20577"/>
+        <pc:sldMkLst>
+          <pc:docMk/>
+          <pc:sldMk cId="3127194409" sldId="259"/>
+        </pc:sldMkLst>
+        <pc:spChg chg="mod">
+          <ac:chgData name="Tyrion Bao" userId="86a2b12e41226f78" providerId="LiveId" clId="{4891CA31-0AE7-4ECE-B60E-21685528A7C5}" dt="2026-10-10T10:22:43.705" v="418" actId="20577"/>
+          <ac:spMkLst>
+            <pc:docMk/>
+            <pc:sldMk cId="3127194409" sldId="259"/>
+            <ac:spMk id="2" creationId="{1631EA1C-1B4C-8E94-51C2-D8E2E04625BA}"/>
+          </ac:spMkLst>
+        </pc:spChg>
+        <pc:spChg chg="mod">
+          <ac:chgData name="Tyrion Bao" userId="86a2b12e41226f78" providerId="LiveId" clId="{4891CA31-0AE7-4ECE-B60E-21685528A7C5}" dt="2026-10-13T11:10:12.346" v="1456" actId="20577"/>
+          <ac:spMkLst>
+            <pc:docMk/>
+            <pc:sldMk cId="3127194409" sldId="259"/>
+            <ac:spMk id="3" creationId="{D864FF2B-5D3B-E95E-834D-1B30DB2A2B6B}"/>
+          </ac:spMkLst>
+        </pc:spChg>
+      </pc:sldChg>
+      <pc:sldChg chg="modSp mod">
+        <pc:chgData name="Tyrion Bao" userId="86a2b12e41226f78" providerId="LiveId" clId="{4891CA31-0AE7-4ECE-B60E-21685528A7C5}" dt="2026-10-13T11:30:32.135" v="1537" actId="20577"/>
+        <pc:sldMkLst>
+          <pc:docMk/>
+          <pc:sldMk cId="3986438202" sldId="261"/>
+        </pc:sldMkLst>
+        <pc:spChg chg="mod">
+          <ac:chgData name="Tyrion Bao" userId="86a2b12e41226f78" providerId="LiveId" clId="{4891CA31-0AE7-4ECE-B60E-21685528A7C5}" dt="2026-10-13T11:30:32.135" v="1537" actId="20577"/>
+          <ac:spMkLst>
+            <pc:docMk/>
+            <pc:sldMk cId="3986438202" sldId="261"/>
+            <ac:spMk id="3" creationId="{2413A87A-A300-E5BC-D77E-E5ACD4FA9EBD}"/>
+          </ac:spMkLst>
+        </pc:spChg>
+      </pc:sldChg>
+      <pc:sldChg chg="addSp modSp mod">
+        <pc:chgData name="Tyrion Bao" userId="86a2b12e41226f78" providerId="LiveId" clId="{4891CA31-0AE7-4ECE-B60E-21685528A7C5}" dt="2026-10-13T11:09:54.723" v="1448" actId="20577"/>
+        <pc:sldMkLst>
+          <pc:docMk/>
+          <pc:sldMk cId="943744701" sldId="262"/>
+        </pc:sldMkLst>
+        <pc:spChg chg="mod">
+          <ac:chgData name="Tyrion Bao" userId="86a2b12e41226f78" providerId="LiveId" clId="{4891CA31-0AE7-4ECE-B60E-21685528A7C5}" dt="2026-10-10T09:48:41.282" v="138" actId="20577"/>
+          <ac:spMkLst>
+            <pc:docMk/>
+            <pc:sldMk cId="943744701" sldId="262"/>
+            <ac:spMk id="2" creationId="{95665380-229C-8A34-832A-ED2E12BF40D0}"/>
+          </ac:spMkLst>
+        </pc:spChg>
+        <pc:spChg chg="mod">
+          <ac:chgData name="Tyrion Bao" userId="86a2b12e41226f78" providerId="LiveId" clId="{4891CA31-0AE7-4ECE-B60E-21685528A7C5}" dt="2026-10-13T11:09:54.723" v="1448" actId="20577"/>
+          <ac:spMkLst>
+            <pc:docMk/>
+            <pc:sldMk cId="943744701" sldId="262"/>
+            <ac:spMk id="3" creationId="{1CDD36FB-14EB-E63C-DB13-5B0DFEF0AE1D}"/>
+          </ac:spMkLst>
+        </pc:spChg>
+        <pc:spChg chg="add mod">
+          <ac:chgData name="Tyrion Bao" userId="86a2b12e41226f78" providerId="LiveId" clId="{4891CA31-0AE7-4ECE-B60E-21685528A7C5}" dt="2026-10-13T08:04:15.805" v="1147" actId="21"/>
+          <ac:spMkLst>
+            <pc:docMk/>
+            <pc:sldMk cId="943744701" sldId="262"/>
+            <ac:spMk id="4" creationId="{76C5F6CF-1048-44CE-5671-5D14C8C22D4E}"/>
+          </ac:spMkLst>
+        </pc:spChg>
+      </pc:sldChg>
+      <pc:sldChg chg="addSp delSp modSp mod">
+        <pc:chgData name="Tyrion Bao" userId="86a2b12e41226f78" providerId="LiveId" clId="{4891CA31-0AE7-4ECE-B60E-21685528A7C5}" dt="2026-10-13T11:28:12.548" v="1459" actId="1076"/>
+        <pc:sldMkLst>
+          <pc:docMk/>
+          <pc:sldMk cId="1949254824" sldId="263"/>
+        </pc:sldMkLst>
+        <pc:spChg chg="mod">
+          <ac:chgData name="Tyrion Bao" userId="86a2b12e41226f78" providerId="LiveId" clId="{4891CA31-0AE7-4ECE-B60E-21685528A7C5}" dt="2026-10-13T10:45:46.259" v="1228" actId="5793"/>
+          <ac:spMkLst>
+            <pc:docMk/>
+            <pc:sldMk cId="1949254824" sldId="263"/>
+            <ac:spMk id="2" creationId="{9C52CD5E-0479-C15D-685C-53C96A9A2573}"/>
+          </ac:spMkLst>
+        </pc:spChg>
+        <pc:spChg chg="del mod">
+          <ac:chgData name="Tyrion Bao" userId="86a2b12e41226f78" providerId="LiveId" clId="{4891CA31-0AE7-4ECE-B60E-21685528A7C5}" dt="2026-10-13T08:04:05.855" v="1144" actId="21"/>
+          <ac:spMkLst>
+            <pc:docMk/>
+            <pc:sldMk cId="1949254824" sldId="263"/>
+            <ac:spMk id="3" creationId="{76C5F6CF-1048-44CE-5671-5D14C8C22D4E}"/>
+          </ac:spMkLst>
+        </pc:spChg>
+        <pc:spChg chg="add del mod">
+          <ac:chgData name="Tyrion Bao" userId="86a2b12e41226f78" providerId="LiveId" clId="{4891CA31-0AE7-4ECE-B60E-21685528A7C5}" dt="2026-10-13T10:44:10.843" v="1206" actId="22"/>
+          <ac:spMkLst>
+            <pc:docMk/>
+            <pc:sldMk cId="1949254824" sldId="263"/>
+            <ac:spMk id="7" creationId="{975A50ED-1576-0792-AB22-AED35F1F6523}"/>
+          </ac:spMkLst>
+        </pc:spChg>
+        <pc:spChg chg="add mod">
+          <ac:chgData name="Tyrion Bao" userId="86a2b12e41226f78" providerId="LiveId" clId="{4891CA31-0AE7-4ECE-B60E-21685528A7C5}" dt="2026-10-13T10:45:50.184" v="1229" actId="1076"/>
+          <ac:spMkLst>
+            <pc:docMk/>
+            <pc:sldMk cId="1949254824" sldId="263"/>
+            <ac:spMk id="10" creationId="{63364981-20CC-598C-717F-99096FB5CF8F}"/>
+          </ac:spMkLst>
+        </pc:spChg>
+        <pc:spChg chg="add mod">
+          <ac:chgData name="Tyrion Bao" userId="86a2b12e41226f78" providerId="LiveId" clId="{4891CA31-0AE7-4ECE-B60E-21685528A7C5}" dt="2026-10-13T10:44:49.966" v="1217"/>
+          <ac:spMkLst>
+            <pc:docMk/>
+            <pc:sldMk cId="1949254824" sldId="263"/>
+            <ac:spMk id="11" creationId="{A7F8971B-29FC-9643-ADA1-BE6DE26A9A34}"/>
+          </ac:spMkLst>
+        </pc:spChg>
+        <pc:picChg chg="add del mod">
+          <ac:chgData name="Tyrion Bao" userId="86a2b12e41226f78" providerId="LiveId" clId="{4891CA31-0AE7-4ECE-B60E-21685528A7C5}" dt="2026-10-13T08:04:32.912" v="1153" actId="478"/>
+          <ac:picMkLst>
+            <pc:docMk/>
+            <pc:sldMk cId="1949254824" sldId="263"/>
+            <ac:picMk id="5" creationId="{8C628B91-B494-065E-A90E-405ED68797F2}"/>
+          </ac:picMkLst>
+        </pc:picChg>
+        <pc:picChg chg="add mod">
+          <ac:chgData name="Tyrion Bao" userId="86a2b12e41226f78" providerId="LiveId" clId="{4891CA31-0AE7-4ECE-B60E-21685528A7C5}" dt="2026-10-13T11:28:12.548" v="1459" actId="1076"/>
+          <ac:picMkLst>
+            <pc:docMk/>
+            <pc:sldMk cId="1949254824" sldId="263"/>
+            <ac:picMk id="9" creationId="{01B64DD8-E036-628D-36EA-25272E6644B1}"/>
+          </ac:picMkLst>
+        </pc:picChg>
+      </pc:sldChg>
+      <pc:sldChg chg="modSp mod">
+        <pc:chgData name="Tyrion Bao" userId="86a2b12e41226f78" providerId="LiveId" clId="{4891CA31-0AE7-4ECE-B60E-21685528A7C5}" dt="2026-10-10T10:22:46.595" v="419" actId="20577"/>
+        <pc:sldMkLst>
+          <pc:docMk/>
+          <pc:sldMk cId="2396252889" sldId="265"/>
+        </pc:sldMkLst>
+        <pc:spChg chg="mod">
+          <ac:chgData name="Tyrion Bao" userId="86a2b12e41226f78" providerId="LiveId" clId="{4891CA31-0AE7-4ECE-B60E-21685528A7C5}" dt="2026-10-10T10:22:46.595" v="419" actId="20577"/>
+          <ac:spMkLst>
+            <pc:docMk/>
+            <pc:sldMk cId="2396252889" sldId="265"/>
+            <ac:spMk id="2" creationId="{493A2EF7-200C-22DA-3C40-B6F90972A172}"/>
+          </ac:spMkLst>
+        </pc:spChg>
+      </pc:sldChg>
+      <pc:sldChg chg="modSp mod">
+        <pc:chgData name="Tyrion Bao" userId="86a2b12e41226f78" providerId="LiveId" clId="{4891CA31-0AE7-4ECE-B60E-21685528A7C5}" dt="2026-10-13T11:30:40.282" v="1546" actId="20577"/>
+        <pc:sldMkLst>
+          <pc:docMk/>
+          <pc:sldMk cId="2530839382" sldId="266"/>
+        </pc:sldMkLst>
+        <pc:spChg chg="mod">
+          <ac:chgData name="Tyrion Bao" userId="86a2b12e41226f78" providerId="LiveId" clId="{4891CA31-0AE7-4ECE-B60E-21685528A7C5}" dt="2026-10-13T11:30:40.282" v="1546" actId="20577"/>
+          <ac:spMkLst>
+            <pc:docMk/>
+            <pc:sldMk cId="2530839382" sldId="266"/>
+            <ac:spMk id="2" creationId="{844C9FA9-FA19-708A-4CEF-5F4F2C7A886B}"/>
+          </ac:spMkLst>
+        </pc:spChg>
+      </pc:sldChg>
+      <pc:sldChg chg="del">
+        <pc:chgData name="Tyrion Bao" userId="86a2b12e41226f78" providerId="LiveId" clId="{4891CA31-0AE7-4ECE-B60E-21685528A7C5}" dt="2026-10-13T11:08:58.647" v="1413" actId="47"/>
+        <pc:sldMkLst>
+          <pc:docMk/>
+          <pc:sldMk cId="1341844599" sldId="267"/>
+        </pc:sldMkLst>
+      </pc:sldChg>
+      <pc:sldChg chg="addSp delSp modSp mod">
+        <pc:chgData name="Tyrion Bao" userId="86a2b12e41226f78" providerId="LiveId" clId="{4891CA31-0AE7-4ECE-B60E-21685528A7C5}" dt="2026-10-13T09:54:53.916" v="1161" actId="14100"/>
+        <pc:sldMkLst>
+          <pc:docMk/>
+          <pc:sldMk cId="2556202693" sldId="268"/>
+        </pc:sldMkLst>
+        <pc:spChg chg="mod">
+          <ac:chgData name="Tyrion Bao" userId="86a2b12e41226f78" providerId="LiveId" clId="{4891CA31-0AE7-4ECE-B60E-21685528A7C5}" dt="2026-10-12T07:02:33.443" v="623" actId="20577"/>
+          <ac:spMkLst>
+            <pc:docMk/>
+            <pc:sldMk cId="2556202693" sldId="268"/>
+            <ac:spMk id="2" creationId="{09E2114C-741A-544B-6F85-EB2F790F1920}"/>
+          </ac:spMkLst>
+        </pc:spChg>
+        <pc:spChg chg="mod">
+          <ac:chgData name="Tyrion Bao" userId="86a2b12e41226f78" providerId="LiveId" clId="{4891CA31-0AE7-4ECE-B60E-21685528A7C5}" dt="2026-10-12T06:06:20.282" v="537" actId="27636"/>
+          <ac:spMkLst>
+            <pc:docMk/>
+            <pc:sldMk cId="2556202693" sldId="268"/>
+            <ac:spMk id="3" creationId="{319AD4AA-A236-D115-96E6-B2F9ED260A75}"/>
+          </ac:spMkLst>
+        </pc:spChg>
+        <pc:spChg chg="add mod">
+          <ac:chgData name="Tyrion Bao" userId="86a2b12e41226f78" providerId="LiveId" clId="{4891CA31-0AE7-4ECE-B60E-21685528A7C5}" dt="2026-10-12T07:02:07.222" v="610" actId="27636"/>
+          <ac:spMkLst>
+            <pc:docMk/>
+            <pc:sldMk cId="2556202693" sldId="268"/>
+            <ac:spMk id="10" creationId="{95DD8A95-94AF-0BF2-ADA4-498CD2578109}"/>
+          </ac:spMkLst>
+        </pc:spChg>
+        <pc:spChg chg="add mod">
+          <ac:chgData name="Tyrion Bao" userId="86a2b12e41226f78" providerId="LiveId" clId="{4891CA31-0AE7-4ECE-B60E-21685528A7C5}" dt="2026-10-12T06:06:41.812" v="570" actId="20577"/>
+          <ac:spMkLst>
+            <pc:docMk/>
+            <pc:sldMk cId="2556202693" sldId="268"/>
+            <ac:spMk id="11" creationId="{7385F1EA-A542-3CF4-3490-CB75144606FE}"/>
+          </ac:spMkLst>
+        </pc:spChg>
+        <pc:spChg chg="add del mod">
+          <ac:chgData name="Tyrion Bao" userId="86a2b12e41226f78" providerId="LiveId" clId="{4891CA31-0AE7-4ECE-B60E-21685528A7C5}" dt="2026-10-12T06:06:52.031" v="576" actId="478"/>
+          <ac:spMkLst>
+            <pc:docMk/>
+            <pc:sldMk cId="2556202693" sldId="268"/>
+            <ac:spMk id="12" creationId="{61249B81-7BF9-207D-F10C-C84D190132E6}"/>
+          </ac:spMkLst>
+        </pc:spChg>
+        <pc:spChg chg="add mod">
+          <ac:chgData name="Tyrion Bao" userId="86a2b12e41226f78" providerId="LiveId" clId="{4891CA31-0AE7-4ECE-B60E-21685528A7C5}" dt="2026-10-13T07:25:58.841" v="1073" actId="14100"/>
+          <ac:spMkLst>
+            <pc:docMk/>
+            <pc:sldMk cId="2556202693" sldId="268"/>
+            <ac:spMk id="16" creationId="{39559C9E-5E24-3455-298C-A4023740F75B}"/>
+          </ac:spMkLst>
+        </pc:spChg>
+        <pc:spChg chg="add mod">
+          <ac:chgData name="Tyrion Bao" userId="86a2b12e41226f78" providerId="LiveId" clId="{4891CA31-0AE7-4ECE-B60E-21685528A7C5}" dt="2026-10-13T07:26:15.578" v="1085" actId="1076"/>
+          <ac:spMkLst>
+            <pc:docMk/>
+            <pc:sldMk cId="2556202693" sldId="268"/>
+            <ac:spMk id="18" creationId="{A5429B54-E4D7-4ABD-D755-C303090F161D}"/>
+          </ac:spMkLst>
+        </pc:spChg>
+        <pc:spChg chg="add mod">
+          <ac:chgData name="Tyrion Bao" userId="86a2b12e41226f78" providerId="LiveId" clId="{4891CA31-0AE7-4ECE-B60E-21685528A7C5}" dt="2026-10-13T08:02:51.434" v="1128"/>
+          <ac:spMkLst>
+            <pc:docMk/>
+            <pc:sldMk cId="2556202693" sldId="268"/>
+            <ac:spMk id="22" creationId="{9E8541F7-321F-8AC6-847E-F35247FFA7CB}"/>
+          </ac:spMkLst>
+        </pc:spChg>
+        <pc:spChg chg="add mod">
+          <ac:chgData name="Tyrion Bao" userId="86a2b12e41226f78" providerId="LiveId" clId="{4891CA31-0AE7-4ECE-B60E-21685528A7C5}" dt="2026-10-13T08:03:45.509" v="1143" actId="20577"/>
+          <ac:spMkLst>
+            <pc:docMk/>
+            <pc:sldMk cId="2556202693" sldId="268"/>
+            <ac:spMk id="24" creationId="{AA80C8C9-13B2-2C87-1E0E-6AFF692CFAF3}"/>
+          </ac:spMkLst>
+        </pc:spChg>
+        <pc:picChg chg="add del">
+          <ac:chgData name="Tyrion Bao" userId="86a2b12e41226f78" providerId="LiveId" clId="{4891CA31-0AE7-4ECE-B60E-21685528A7C5}" dt="2026-10-12T05:58:06.995" v="530" actId="478"/>
+          <ac:picMkLst>
+            <pc:docMk/>
+            <pc:sldMk cId="2556202693" sldId="268"/>
+            <ac:picMk id="7" creationId="{2951EAE8-F144-BBB8-1F43-DEA0E20ABE82}"/>
+          </ac:picMkLst>
+        </pc:picChg>
+        <pc:picChg chg="add mod">
+          <ac:chgData name="Tyrion Bao" userId="86a2b12e41226f78" providerId="LiveId" clId="{4891CA31-0AE7-4ECE-B60E-21685528A7C5}" dt="2026-10-12T06:06:13.960" v="535" actId="14100"/>
+          <ac:picMkLst>
+            <pc:docMk/>
+            <pc:sldMk cId="2556202693" sldId="268"/>
+            <ac:picMk id="9" creationId="{CE0C8902-F7D5-5D1D-AB5F-5F52C363D314}"/>
+          </ac:picMkLst>
+        </pc:picChg>
+        <pc:picChg chg="add mod">
+          <ac:chgData name="Tyrion Bao" userId="86a2b12e41226f78" providerId="LiveId" clId="{4891CA31-0AE7-4ECE-B60E-21685528A7C5}" dt="2026-10-12T06:25:49.878" v="592" actId="1076"/>
+          <ac:picMkLst>
+            <pc:docMk/>
+            <pc:sldMk cId="2556202693" sldId="268"/>
+            <ac:picMk id="14" creationId="{F4D88FF5-D639-D542-A7FB-D976FD47590B}"/>
+          </ac:picMkLst>
+        </pc:picChg>
+        <pc:picChg chg="add mod">
+          <ac:chgData name="Tyrion Bao" userId="86a2b12e41226f78" providerId="LiveId" clId="{4891CA31-0AE7-4ECE-B60E-21685528A7C5}" dt="2026-10-13T07:52:00.348" v="1091" actId="1076"/>
+          <ac:picMkLst>
+            <pc:docMk/>
+            <pc:sldMk cId="2556202693" sldId="268"/>
+            <ac:picMk id="20" creationId="{7D05E34A-723E-FADB-4FB0-EBC9CBFA457D}"/>
+          </ac:picMkLst>
+        </pc:picChg>
+        <pc:picChg chg="add mod">
+          <ac:chgData name="Tyrion Bao" userId="86a2b12e41226f78" providerId="LiveId" clId="{4891CA31-0AE7-4ECE-B60E-21685528A7C5}" dt="2026-10-13T09:54:33.371" v="1157" actId="1076"/>
+          <ac:picMkLst>
+            <pc:docMk/>
+            <pc:sldMk cId="2556202693" sldId="268"/>
+            <ac:picMk id="26" creationId="{E2BA4C4A-3318-92FB-A6AC-8C9578BC9D31}"/>
+          </ac:picMkLst>
+        </pc:picChg>
+        <pc:picChg chg="add mod">
+          <ac:chgData name="Tyrion Bao" userId="86a2b12e41226f78" providerId="LiveId" clId="{4891CA31-0AE7-4ECE-B60E-21685528A7C5}" dt="2026-10-13T09:54:53.916" v="1161" actId="14100"/>
+          <ac:picMkLst>
+            <pc:docMk/>
+            <pc:sldMk cId="2556202693" sldId="268"/>
+            <ac:picMk id="28" creationId="{BAA5E4C8-CCD6-984E-AA74-D5985DD7A53C}"/>
+          </ac:picMkLst>
+        </pc:picChg>
+      </pc:sldChg>
+      <pc:sldChg chg="del">
+        <pc:chgData name="Tyrion Bao" userId="86a2b12e41226f78" providerId="LiveId" clId="{4891CA31-0AE7-4ECE-B60E-21685528A7C5}" dt="2026-10-13T10:02:03.484" v="1164" actId="2696"/>
+        <pc:sldMkLst>
+          <pc:docMk/>
+          <pc:sldMk cId="3762175992" sldId="269"/>
+        </pc:sldMkLst>
+      </pc:sldChg>
+      <pc:sldChg chg="del">
+        <pc:chgData name="Tyrion Bao" userId="86a2b12e41226f78" providerId="LiveId" clId="{4891CA31-0AE7-4ECE-B60E-21685528A7C5}" dt="2026-10-13T10:02:04.886" v="1165" actId="2696"/>
+        <pc:sldMkLst>
+          <pc:docMk/>
+          <pc:sldMk cId="206457850" sldId="270"/>
+        </pc:sldMkLst>
+      </pc:sldChg>
+      <pc:sldChg chg="addSp delSp modSp add mod">
+        <pc:chgData name="Tyrion Bao" userId="86a2b12e41226f78" providerId="LiveId" clId="{4891CA31-0AE7-4ECE-B60E-21685528A7C5}" dt="2026-10-12T06:45:17.574" v="598" actId="14100"/>
+        <pc:sldMkLst>
+          <pc:docMk/>
+          <pc:sldMk cId="2124816499" sldId="271"/>
+        </pc:sldMkLst>
+        <pc:spChg chg="mod">
+          <ac:chgData name="Tyrion Bao" userId="86a2b12e41226f78" providerId="LiveId" clId="{4891CA31-0AE7-4ECE-B60E-21685528A7C5}" dt="2026-10-10T09:38:06.706" v="81" actId="20577"/>
+          <ac:spMkLst>
+            <pc:docMk/>
+            <pc:sldMk cId="2124816499" sldId="271"/>
+            <ac:spMk id="2" creationId="{A07AE7C9-8F03-CDB0-D027-363093275095}"/>
+          </ac:spMkLst>
+        </pc:spChg>
+        <pc:picChg chg="add mod">
+          <ac:chgData name="Tyrion Bao" userId="86a2b12e41226f78" providerId="LiveId" clId="{4891CA31-0AE7-4ECE-B60E-21685528A7C5}" dt="2026-10-10T09:43:41.517" v="107" actId="1076"/>
+          <ac:picMkLst>
+            <pc:docMk/>
+            <pc:sldMk cId="2124816499" sldId="271"/>
+            <ac:picMk id="7" creationId="{15623197-5A4C-2FF6-5850-E1A8517A291F}"/>
+          </ac:picMkLst>
+        </pc:picChg>
+        <pc:picChg chg="add mod">
+          <ac:chgData name="Tyrion Bao" userId="86a2b12e41226f78" providerId="LiveId" clId="{4891CA31-0AE7-4ECE-B60E-21685528A7C5}" dt="2026-10-12T06:45:05.944" v="593" actId="14100"/>
+          <ac:picMkLst>
+            <pc:docMk/>
+            <pc:sldMk cId="2124816499" sldId="271"/>
+            <ac:picMk id="11" creationId="{58EEFE3E-A182-F32B-2720-1B55C6E98940}"/>
+          </ac:picMkLst>
+        </pc:picChg>
+        <pc:picChg chg="add mod">
+          <ac:chgData name="Tyrion Bao" userId="86a2b12e41226f78" providerId="LiveId" clId="{4891CA31-0AE7-4ECE-B60E-21685528A7C5}" dt="2026-10-12T06:45:17.574" v="598" actId="14100"/>
+          <ac:picMkLst>
+            <pc:docMk/>
+            <pc:sldMk cId="2124816499" sldId="271"/>
+            <ac:picMk id="15" creationId="{7CB3A017-B718-300C-41CD-D9CCEF9CF140}"/>
+          </ac:picMkLst>
+        </pc:picChg>
+      </pc:sldChg>
+      <pc:sldChg chg="addSp delSp modSp add mod">
+        <pc:chgData name="Tyrion Bao" userId="86a2b12e41226f78" providerId="LiveId" clId="{4891CA31-0AE7-4ECE-B60E-21685528A7C5}" dt="2026-10-10T10:17:24.427" v="166" actId="1076"/>
+        <pc:sldMkLst>
+          <pc:docMk/>
+          <pc:sldMk cId="1140172268" sldId="272"/>
+        </pc:sldMkLst>
+        <pc:spChg chg="mod">
+          <ac:chgData name="Tyrion Bao" userId="86a2b12e41226f78" providerId="LiveId" clId="{4891CA31-0AE7-4ECE-B60E-21685528A7C5}" dt="2026-10-10T10:08:31.809" v="163" actId="20577"/>
+          <ac:spMkLst>
+            <pc:docMk/>
+            <pc:sldMk cId="1140172268" sldId="272"/>
+            <ac:spMk id="2" creationId="{4449A65D-BCA9-EBDD-F495-8AA66AF2882D}"/>
+          </ac:spMkLst>
+        </pc:spChg>
+        <pc:picChg chg="add mod">
+          <ac:chgData name="Tyrion Bao" userId="86a2b12e41226f78" providerId="LiveId" clId="{4891CA31-0AE7-4ECE-B60E-21685528A7C5}" dt="2026-10-10T10:17:24.427" v="166" actId="1076"/>
+          <ac:picMkLst>
+            <pc:docMk/>
+            <pc:sldMk cId="1140172268" sldId="272"/>
+            <ac:picMk id="4" creationId="{049434F6-E4A4-20BD-E2F4-BAA18285ED8E}"/>
+          </ac:picMkLst>
+        </pc:picChg>
+      </pc:sldChg>
+      <pc:sldChg chg="addSp delSp modSp add mod">
+        <pc:chgData name="Tyrion Bao" userId="86a2b12e41226f78" providerId="LiveId" clId="{4891CA31-0AE7-4ECE-B60E-21685528A7C5}" dt="2026-10-13T10:43:47.439" v="1176" actId="21"/>
+        <pc:sldMkLst>
+          <pc:docMk/>
+          <pc:sldMk cId="2948105093" sldId="273"/>
+        </pc:sldMkLst>
+        <pc:spChg chg="mod">
+          <ac:chgData name="Tyrion Bao" userId="86a2b12e41226f78" providerId="LiveId" clId="{4891CA31-0AE7-4ECE-B60E-21685528A7C5}" dt="2026-10-13T10:02:31.325" v="1171" actId="20577"/>
+          <ac:spMkLst>
+            <pc:docMk/>
+            <pc:sldMk cId="2948105093" sldId="273"/>
+            <ac:spMk id="2" creationId="{908AD7D4-E292-EA64-F0D4-B2512616F071}"/>
+          </ac:spMkLst>
+        </pc:spChg>
+        <pc:picChg chg="add mod">
+          <ac:chgData name="Tyrion Bao" userId="86a2b12e41226f78" providerId="LiveId" clId="{4891CA31-0AE7-4ECE-B60E-21685528A7C5}" dt="2026-10-13T10:28:52.780" v="1174" actId="14100"/>
+          <ac:picMkLst>
+            <pc:docMk/>
+            <pc:sldMk cId="2948105093" sldId="273"/>
+            <ac:picMk id="5" creationId="{D5731147-B5A1-F0B0-2687-A47A37792A7A}"/>
+          </ac:picMkLst>
+        </pc:picChg>
+        <pc:picChg chg="add del">
+          <ac:chgData name="Tyrion Bao" userId="86a2b12e41226f78" providerId="LiveId" clId="{4891CA31-0AE7-4ECE-B60E-21685528A7C5}" dt="2026-10-13T10:43:47.439" v="1176" actId="21"/>
+          <ac:picMkLst>
+            <pc:docMk/>
+            <pc:sldMk cId="2948105093" sldId="273"/>
+            <ac:picMk id="7" creationId="{395FDD8E-17C3-0CA4-AB93-62B90C13605E}"/>
+          </ac:picMkLst>
+        </pc:picChg>
+      </pc:sldChg>
+      <pc:sldChg chg="addSp delSp modSp add mod">
+        <pc:chgData name="Tyrion Bao" userId="86a2b12e41226f78" providerId="LiveId" clId="{4891CA31-0AE7-4ECE-B60E-21685528A7C5}" dt="2026-10-13T12:20:14.083" v="1565" actId="1076"/>
+        <pc:sldMkLst>
+          <pc:docMk/>
+          <pc:sldMk cId="843727772" sldId="274"/>
+        </pc:sldMkLst>
+        <pc:spChg chg="mod">
+          <ac:chgData name="Tyrion Bao" userId="86a2b12e41226f78" providerId="LiveId" clId="{4891CA31-0AE7-4ECE-B60E-21685528A7C5}" dt="2026-10-13T12:11:22.777" v="1551" actId="27636"/>
+          <ac:spMkLst>
+            <pc:docMk/>
+            <pc:sldMk cId="843727772" sldId="274"/>
+            <ac:spMk id="2" creationId="{3357BD1C-E5F7-6F26-E954-00CF9CF426C6}"/>
+          </ac:spMkLst>
+        </pc:spChg>
+        <pc:spChg chg="add del mod">
+          <ac:chgData name="Tyrion Bao" userId="86a2b12e41226f78" providerId="LiveId" clId="{4891CA31-0AE7-4ECE-B60E-21685528A7C5}" dt="2026-10-13T11:08:55.483" v="1412" actId="478"/>
+          <ac:spMkLst>
+            <pc:docMk/>
+            <pc:sldMk cId="843727772" sldId="274"/>
+            <ac:spMk id="6" creationId="{B9461C2F-E30F-3930-E17C-831B4831E4AC}"/>
+          </ac:spMkLst>
+        </pc:spChg>
+        <pc:spChg chg="mod">
+          <ac:chgData name="Tyrion Bao" userId="86a2b12e41226f78" providerId="LiveId" clId="{4891CA31-0AE7-4ECE-B60E-21685528A7C5}" dt="2026-10-13T11:24:32.083" v="1458" actId="20577"/>
+          <ac:spMkLst>
+            <pc:docMk/>
+            <pc:sldMk cId="843727772" sldId="274"/>
+            <ac:spMk id="10" creationId="{00CA7FDA-540C-FF9F-33E7-85A3A94C9AF8}"/>
+          </ac:spMkLst>
+        </pc:spChg>
+        <pc:spChg chg="add del">
+          <ac:chgData name="Tyrion Bao" userId="86a2b12e41226f78" providerId="LiveId" clId="{4891CA31-0AE7-4ECE-B60E-21685528A7C5}" dt="2026-10-13T12:20:04.612" v="1557" actId="22"/>
+          <ac:spMkLst>
+            <pc:docMk/>
+            <pc:sldMk cId="843727772" sldId="274"/>
+            <ac:spMk id="12" creationId="{D2E6CBBF-2EB5-9747-DDBC-6F74D74E948A}"/>
+          </ac:spMkLst>
+        </pc:spChg>
+        <pc:picChg chg="add del mod">
+          <ac:chgData name="Tyrion Bao" userId="86a2b12e41226f78" providerId="LiveId" clId="{4891CA31-0AE7-4ECE-B60E-21685528A7C5}" dt="2026-10-13T10:47:56.015" v="1242" actId="478"/>
+          <ac:picMkLst>
+            <pc:docMk/>
+            <pc:sldMk cId="843727772" sldId="274"/>
+            <ac:picMk id="4" creationId="{55B3E492-D0C3-C2EA-0AC1-EE7107EDCD76}"/>
+          </ac:picMkLst>
+        </pc:picChg>
+        <pc:picChg chg="add mod">
+          <ac:chgData name="Tyrion Bao" userId="86a2b12e41226f78" providerId="LiveId" clId="{4891CA31-0AE7-4ECE-B60E-21685528A7C5}" dt="2026-10-13T12:20:11.011" v="1562" actId="1076"/>
+          <ac:picMkLst>
+            <pc:docMk/>
+            <pc:sldMk cId="843727772" sldId="274"/>
+            <ac:picMk id="8" creationId="{E63F0947-F892-DC4A-8D0E-71F730513A7B}"/>
+          </ac:picMkLst>
+        </pc:picChg>
+        <pc:picChg chg="del">
+          <ac:chgData name="Tyrion Bao" userId="86a2b12e41226f78" providerId="LiveId" clId="{4891CA31-0AE7-4ECE-B60E-21685528A7C5}" dt="2026-10-13T11:08:27.173" v="1407" actId="478"/>
+          <ac:picMkLst>
+            <pc:docMk/>
+            <pc:sldMk cId="843727772" sldId="274"/>
+            <ac:picMk id="9" creationId="{B5919E5A-6B67-6F92-5533-7B6ADC0F0C93}"/>
+          </ac:picMkLst>
+        </pc:picChg>
+        <pc:picChg chg="add mod">
+          <ac:chgData name="Tyrion Bao" userId="86a2b12e41226f78" providerId="LiveId" clId="{4891CA31-0AE7-4ECE-B60E-21685528A7C5}" dt="2026-10-13T12:20:14.083" v="1565" actId="1076"/>
+          <ac:picMkLst>
+            <pc:docMk/>
+            <pc:sldMk cId="843727772" sldId="274"/>
+            <ac:picMk id="14" creationId="{F2F36BE0-A1C9-EE2E-025D-785BC9ACC3C5}"/>
+          </ac:picMkLst>
+        </pc:picChg>
+      </pc:sldChg>
+      <pc:sldChg chg="modSp add del mod">
+        <pc:chgData name="Tyrion Bao" userId="86a2b12e41226f78" providerId="LiveId" clId="{4891CA31-0AE7-4ECE-B60E-21685528A7C5}" dt="2026-10-13T11:30:20.408" v="1525" actId="47"/>
+        <pc:sldMkLst>
+          <pc:docMk/>
+          <pc:sldMk cId="4113286488" sldId="275"/>
+        </pc:sldMkLst>
+        <pc:spChg chg="mod">
+          <ac:chgData name="Tyrion Bao" userId="86a2b12e41226f78" providerId="LiveId" clId="{4891CA31-0AE7-4ECE-B60E-21685528A7C5}" dt="2026-10-13T11:09:26.568" v="1420"/>
+          <ac:spMkLst>
+            <pc:docMk/>
+            <pc:sldMk cId="4113286488" sldId="275"/>
+            <ac:spMk id="2" creationId="{81A26CBD-FBB9-ED79-4341-E665E13AD732}"/>
+          </ac:spMkLst>
+        </pc:spChg>
+        <pc:spChg chg="mod">
+          <ac:chgData name="Tyrion Bao" userId="86a2b12e41226f78" providerId="LiveId" clId="{4891CA31-0AE7-4ECE-B60E-21685528A7C5}" dt="2026-10-13T11:30:14.653" v="1524" actId="20577"/>
+          <ac:spMkLst>
+            <pc:docMk/>
+            <pc:sldMk cId="4113286488" sldId="275"/>
+            <ac:spMk id="3" creationId="{3C94A4E1-5D0C-23AA-F43B-F2638E5FAD34}"/>
+          </ac:spMkLst>
+        </pc:spChg>
+      </pc:sldChg>
     </pc:docChg>
   </pc:docChgLst>
 </pc:chgInfo>
+</file>
+
+<file path=ppt/notesMasters/notesMaster1.xml><?xml version="1.0" encoding="utf-8"?>
+<p:notesMaster xmlns:a="http://schemas.openxmlformats.org/drawingml/2006/main" xmlns:r="http://schemas.openxmlformats.org/officeDocument/2006/relationships" xmlns:p="http://schemas.openxmlformats.org/presentationml/2006/main">
+  <p:cSld>
+    <p:bg>
+      <p:bgRef idx="1001">
+        <a:schemeClr val="bg1"/>
+      </p:bgRef>
+    </p:bg>
+    <p:spTree>
+      <p:nvGrpSpPr>
+        <p:cNvPr id="1" name=""/>
+        <p:cNvGrpSpPr/>
+        <p:nvPr/>
+      </p:nvGrpSpPr>
+      <p:grpSpPr>
+        <a:xfrm>
+          <a:off x="0" y="0"/>
+          <a:ext cx="0" cy="0"/>
+          <a:chOff x="0" y="0"/>
+          <a:chExt cx="0" cy="0"/>
+        </a:xfrm>
+      </p:grpSpPr>
+      <p:sp>
+        <p:nvSpPr>
+          <p:cNvPr id="2" name="Header Placeholder 1"/>
+          <p:cNvSpPr>
+            <a:spLocks noGrp="1"/>
+          </p:cNvSpPr>
+          <p:nvPr>
+            <p:ph type="hdr" sz="quarter"/>
+          </p:nvPr>
+        </p:nvSpPr>
+        <p:spPr>
+          <a:xfrm>
+            <a:off x="0" y="0"/>
+            <a:ext cx="2971800" cy="458788"/>
+          </a:xfrm>
+          <a:prstGeom prst="rect">
+            <a:avLst/>
+          </a:prstGeom>
+        </p:spPr>
+        <p:txBody>
+          <a:bodyPr vert="horz" lIns="91440" tIns="45720" rIns="91440" bIns="45720" rtlCol="0"/>
+          <a:lstStyle>
+            <a:lvl1pPr algn="l">
+              <a:defRPr sz="1200"/>
+            </a:lvl1pPr>
+          </a:lstStyle>
+          <a:p>
+            <a:endParaRPr lang="en-US"/>
+          </a:p>
+        </p:txBody>
+      </p:sp>
+      <p:sp>
+        <p:nvSpPr>
+          <p:cNvPr id="3" name="Date Placeholder 2"/>
+          <p:cNvSpPr>
+            <a:spLocks noGrp="1"/>
+          </p:cNvSpPr>
+          <p:nvPr>
+            <p:ph type="dt" idx="1"/>
+          </p:nvPr>
+        </p:nvSpPr>
+        <p:spPr>
+          <a:xfrm>
+            <a:off x="3884613" y="0"/>
+            <a:ext cx="2971800" cy="458788"/>
+          </a:xfrm>
+          <a:prstGeom prst="rect">
+            <a:avLst/>
+          </a:prstGeom>
+        </p:spPr>
+        <p:txBody>
+          <a:bodyPr vert="horz" lIns="91440" tIns="45720" rIns="91440" bIns="45720" rtlCol="0"/>
+          <a:lstStyle>
+            <a:lvl1pPr algn="r">
+              <a:defRPr sz="1200"/>
+            </a:lvl1pPr>
+          </a:lstStyle>
+          <a:p>
+            <a:fld id="{E39C2599-B56F-4716-9BBB-D484E7FFB2C3}" type="datetimeFigureOut">
+              <a:rPr lang="en-US" smtClean="0"/>
+              <a:t>10/13/2026</a:t>
+            </a:fld>
+            <a:endParaRPr lang="en-US"/>
+          </a:p>
+        </p:txBody>
+      </p:sp>
+      <p:sp>
+        <p:nvSpPr>
+          <p:cNvPr id="4" name="Slide Image Placeholder 3"/>
+          <p:cNvSpPr>
+            <a:spLocks noGrp="1" noRot="1" noChangeAspect="1"/>
+          </p:cNvSpPr>
+          <p:nvPr>
+            <p:ph type="sldImg" idx="2"/>
+          </p:nvPr>
+        </p:nvSpPr>
+        <p:spPr>
+          <a:xfrm>
+            <a:off x="685800" y="1143000"/>
+            <a:ext cx="5486400" cy="3086100"/>
+          </a:xfrm>
+          <a:prstGeom prst="rect">
+            <a:avLst/>
+          </a:prstGeom>
+          <a:noFill/>
+          <a:ln w="12700">
+            <a:solidFill>
+              <a:prstClr val="black"/>
+            </a:solidFill>
+          </a:ln>
+        </p:spPr>
+        <p:txBody>
+          <a:bodyPr vert="horz" lIns="91440" tIns="45720" rIns="91440" bIns="45720" rtlCol="0" anchor="ctr"/>
+          <a:lstStyle/>
+          <a:p>
+            <a:endParaRPr lang="en-US"/>
+          </a:p>
+        </p:txBody>
+      </p:sp>
+      <p:sp>
+        <p:nvSpPr>
+          <p:cNvPr id="5" name="Notes Placeholder 4"/>
+          <p:cNvSpPr>
+            <a:spLocks noGrp="1"/>
+          </p:cNvSpPr>
+          <p:nvPr>
+            <p:ph type="body" sz="quarter" idx="3"/>
+          </p:nvPr>
+        </p:nvSpPr>
+        <p:spPr>
+          <a:xfrm>
+            <a:off x="685800" y="4400550"/>
+            <a:ext cx="5486400" cy="3600450"/>
+          </a:xfrm>
+          <a:prstGeom prst="rect">
+            <a:avLst/>
+          </a:prstGeom>
+        </p:spPr>
+        <p:txBody>
+          <a:bodyPr vert="horz" lIns="91440" tIns="45720" rIns="91440" bIns="45720" rtlCol="0"/>
+          <a:lstStyle/>
+          <a:p>
+            <a:pPr lvl="0"/>
+            <a:r>
+              <a:rPr lang="en-US"/>
+              <a:t>Click to edit Master text styles</a:t>
+            </a:r>
+          </a:p>
+          <a:p>
+            <a:pPr lvl="1"/>
+            <a:r>
+              <a:rPr lang="en-US"/>
+              <a:t>Second level</a:t>
+            </a:r>
+          </a:p>
+          <a:p>
+            <a:pPr lvl="2"/>
+            <a:r>
+              <a:rPr lang="en-US"/>
+              <a:t>Third level</a:t>
+            </a:r>
+          </a:p>
+          <a:p>
+            <a:pPr lvl="3"/>
+            <a:r>
+              <a:rPr lang="en-US"/>
+              <a:t>Fourth level</a:t>
+            </a:r>
+          </a:p>
+          <a:p>
+            <a:pPr lvl="4"/>
+            <a:r>
+              <a:rPr lang="en-US"/>
+              <a:t>Fifth level</a:t>
+            </a:r>
+          </a:p>
+        </p:txBody>
+      </p:sp>
+      <p:sp>
+        <p:nvSpPr>
+          <p:cNvPr id="6" name="Footer Placeholder 5"/>
+          <p:cNvSpPr>
+            <a:spLocks noGrp="1"/>
+          </p:cNvSpPr>
+          <p:nvPr>
+            <p:ph type="ftr" sz="quarter" idx="4"/>
+          </p:nvPr>
+        </p:nvSpPr>
+        <p:spPr>
+          <a:xfrm>
+            <a:off x="0" y="8685213"/>
+            <a:ext cx="2971800" cy="458787"/>
+          </a:xfrm>
+          <a:prstGeom prst="rect">
+            <a:avLst/>
+          </a:prstGeom>
+        </p:spPr>
+        <p:txBody>
+          <a:bodyPr vert="horz" lIns="91440" tIns="45720" rIns="91440" bIns="45720" rtlCol="0" anchor="b"/>
+          <a:lstStyle>
+            <a:lvl1pPr algn="l">
+              <a:defRPr sz="1200"/>
+            </a:lvl1pPr>
+          </a:lstStyle>
+          <a:p>
+            <a:endParaRPr lang="en-US"/>
+          </a:p>
+        </p:txBody>
+      </p:sp>
+      <p:sp>
+        <p:nvSpPr>
+          <p:cNvPr id="7" name="Slide Number Placeholder 6"/>
+          <p:cNvSpPr>
+            <a:spLocks noGrp="1"/>
+          </p:cNvSpPr>
+          <p:nvPr>
+            <p:ph type="sldNum" sz="quarter" idx="5"/>
+          </p:nvPr>
+        </p:nvSpPr>
+        <p:spPr>
+          <a:xfrm>
+            <a:off x="3884613" y="8685213"/>
+            <a:ext cx="2971800" cy="458787"/>
+          </a:xfrm>
+          <a:prstGeom prst="rect">
+            <a:avLst/>
+          </a:prstGeom>
+        </p:spPr>
+        <p:txBody>
+          <a:bodyPr vert="horz" lIns="91440" tIns="45720" rIns="91440" bIns="45720" rtlCol="0" anchor="b"/>
+          <a:lstStyle>
+            <a:lvl1pPr algn="r">
+              <a:defRPr sz="1200"/>
+            </a:lvl1pPr>
+          </a:lstStyle>
+          <a:p>
+            <a:fld id="{ED25EEFE-76E0-49D6-89E2-A4AAFBCE03C1}" type="slidenum">
+              <a:rPr lang="en-US" smtClean="0"/>
+              <a:t>‹#›</a:t>
+            </a:fld>
+            <a:endParaRPr lang="en-US"/>
+          </a:p>
+        </p:txBody>
+      </p:sp>
+    </p:spTree>
+    <p:extLst>
+      <p:ext uri="{BB962C8B-B14F-4D97-AF65-F5344CB8AC3E}">
+        <p14:creationId xmlns:p14="http://schemas.microsoft.com/office/powerpoint/2010/main" val="3422929057"/>
+      </p:ext>
+    </p:extLst>
+  </p:cSld>
+  <p:clrMap bg1="lt1" tx1="dk1" bg2="lt2" tx2="dk2" accent1="accent1" accent2="accent2" accent3="accent3" accent4="accent4" accent5="accent5" accent6="accent6" hlink="hlink" folHlink="folHlink"/>
+  <p:notesStyle>
+    <a:lvl1pPr marL="0" algn="l" defTabSz="914400" rtl="0" eaLnBrk="1" latinLnBrk="0" hangingPunct="1">
+      <a:defRPr sz="1200" kern="1200">
+        <a:solidFill>
+          <a:schemeClr val="tx1"/>
+        </a:solidFill>
+        <a:latin typeface="+mn-lt"/>
+        <a:ea typeface="+mn-ea"/>
+        <a:cs typeface="+mn-cs"/>
+      </a:defRPr>
+    </a:lvl1pPr>
+    <a:lvl2pPr marL="457200" algn="l" defTabSz="914400" rtl="0" eaLnBrk="1" latinLnBrk="0" hangingPunct="1">
+      <a:defRPr sz="1200" kern="1200">
+        <a:solidFill>
+          <a:schemeClr val="tx1"/>
+        </a:solidFill>
+        <a:latin typeface="+mn-lt"/>
+        <a:ea typeface="+mn-ea"/>
+        <a:cs typeface="+mn-cs"/>
+      </a:defRPr>
+    </a:lvl2pPr>
+    <a:lvl3pPr marL="914400" algn="l" defTabSz="914400" rtl="0" eaLnBrk="1" latinLnBrk="0" hangingPunct="1">
+      <a:defRPr sz="1200" kern="1200">
+        <a:solidFill>
+          <a:schemeClr val="tx1"/>
+        </a:solidFill>
+        <a:latin typeface="+mn-lt"/>
+        <a:ea typeface="+mn-ea"/>
+        <a:cs typeface="+mn-cs"/>
+      </a:defRPr>
+    </a:lvl3pPr>
+    <a:lvl4pPr marL="1371600" algn="l" defTabSz="914400" rtl="0" eaLnBrk="1" latinLnBrk="0" hangingPunct="1">
+      <a:defRPr sz="1200" kern="1200">
+        <a:solidFill>
+          <a:schemeClr val="tx1"/>
+        </a:solidFill>
+        <a:latin typeface="+mn-lt"/>
+        <a:ea typeface="+mn-ea"/>
+        <a:cs typeface="+mn-cs"/>
+      </a:defRPr>
+    </a:lvl4pPr>
+    <a:lvl5pPr marL="1828800" algn="l" defTabSz="914400" rtl="0" eaLnBrk="1" latinLnBrk="0" hangingPunct="1">
+      <a:defRPr sz="1200" kern="1200">
+        <a:solidFill>
+          <a:schemeClr val="tx1"/>
+        </a:solidFill>
+        <a:latin typeface="+mn-lt"/>
+        <a:ea typeface="+mn-ea"/>
+        <a:cs typeface="+mn-cs"/>
+      </a:defRPr>
+    </a:lvl5pPr>
+    <a:lvl6pPr marL="2286000" algn="l" defTabSz="914400" rtl="0" eaLnBrk="1" latinLnBrk="0" hangingPunct="1">
+      <a:defRPr sz="1200" kern="1200">
+        <a:solidFill>
+          <a:schemeClr val="tx1"/>
+        </a:solidFill>
+        <a:latin typeface="+mn-lt"/>
+        <a:ea typeface="+mn-ea"/>
+        <a:cs typeface="+mn-cs"/>
+      </a:defRPr>
+    </a:lvl6pPr>
+    <a:lvl7pPr marL="2743200" algn="l" defTabSz="914400" rtl="0" eaLnBrk="1" latinLnBrk="0" hangingPunct="1">
+      <a:defRPr sz="1200" kern="1200">
+        <a:solidFill>
+          <a:schemeClr val="tx1"/>
+        </a:solidFill>
+        <a:latin typeface="+mn-lt"/>
+        <a:ea typeface="+mn-ea"/>
+        <a:cs typeface="+mn-cs"/>
+      </a:defRPr>
+    </a:lvl7pPr>
+    <a:lvl8pPr marL="3200400" algn="l" defTabSz="914400" rtl="0" eaLnBrk="1" latinLnBrk="0" hangingPunct="1">
+      <a:defRPr sz="1200" kern="1200">
+        <a:solidFill>
+          <a:schemeClr val="tx1"/>
+        </a:solidFill>
+        <a:latin typeface="+mn-lt"/>
+        <a:ea typeface="+mn-ea"/>
+        <a:cs typeface="+mn-cs"/>
+      </a:defRPr>
+    </a:lvl8pPr>
+    <a:lvl9pPr marL="3657600" algn="l" defTabSz="914400" rtl="0" eaLnBrk="1" latinLnBrk="0" hangingPunct="1">
+      <a:defRPr sz="1200" kern="1200">
+        <a:solidFill>
+          <a:schemeClr val="tx1"/>
+        </a:solidFill>
+        <a:latin typeface="+mn-lt"/>
+        <a:ea typeface="+mn-ea"/>
+        <a:cs typeface="+mn-cs"/>
+      </a:defRPr>
+    </a:lvl9pPr>
+  </p:notesStyle>
+</p:notesMaster>
+</file>
+
+<file path=ppt/notesSlides/notesSlide1.xml><?xml version="1.0" encoding="utf-8"?>
+<p:notes xmlns:a="http://schemas.openxmlformats.org/drawingml/2006/main" xmlns:r="http://schemas.openxmlformats.org/officeDocument/2006/relationships" xmlns:p="http://schemas.openxmlformats.org/presentationml/2006/main">
+  <p:cSld>
+    <p:spTree>
+      <p:nvGrpSpPr>
+        <p:cNvPr id="1" name=""/>
+        <p:cNvGrpSpPr/>
+        <p:nvPr/>
+      </p:nvGrpSpPr>
+      <p:grpSpPr>
+        <a:xfrm>
+          <a:off x="0" y="0"/>
+          <a:ext cx="0" cy="0"/>
+          <a:chOff x="0" y="0"/>
+          <a:chExt cx="0" cy="0"/>
+        </a:xfrm>
+      </p:grpSpPr>
+      <p:sp>
+        <p:nvSpPr>
+          <p:cNvPr id="2" name="Slide Image Placeholder 1"/>
+          <p:cNvSpPr>
+            <a:spLocks noGrp="1" noRot="1" noChangeAspect="1"/>
+          </p:cNvSpPr>
+          <p:nvPr>
+            <p:ph type="sldImg"/>
+          </p:nvPr>
+        </p:nvSpPr>
+        <p:spPr/>
+        <p:txBody>
+          <a:bodyPr/>
+          <a:lstStyle/>
+          <a:p>
+            <a:endParaRPr lang="en-US"/>
+          </a:p>
+        </p:txBody>
+      </p:sp>
+      <p:sp>
+        <p:nvSpPr>
+          <p:cNvPr id="3" name="Notes Placeholder 2"/>
+          <p:cNvSpPr>
+            <a:spLocks noGrp="1"/>
+          </p:cNvSpPr>
+          <p:nvPr>
+            <p:ph type="body" idx="1"/>
+          </p:nvPr>
+        </p:nvSpPr>
+        <p:spPr/>
+        <p:txBody>
+          <a:bodyPr/>
+          <a:lstStyle/>
+          <a:p>
+            <a:endParaRPr lang="en-US" dirty="0"/>
+          </a:p>
+        </p:txBody>
+      </p:sp>
+      <p:sp>
+        <p:nvSpPr>
+          <p:cNvPr id="4" name="Slide Number Placeholder 3"/>
+          <p:cNvSpPr>
+            <a:spLocks noGrp="1"/>
+          </p:cNvSpPr>
+          <p:nvPr>
+            <p:ph type="sldNum" sz="quarter" idx="5"/>
+          </p:nvPr>
+        </p:nvSpPr>
+        <p:spPr/>
+        <p:txBody>
+          <a:bodyPr/>
+          <a:lstStyle/>
+          <a:p>
+            <a:fld id="{ED25EEFE-76E0-49D6-89E2-A4AAFBCE03C1}" type="slidenum">
+              <a:rPr lang="en-US" smtClean="0"/>
+              <a:t>7</a:t>
+            </a:fld>
+            <a:endParaRPr lang="en-US"/>
+          </a:p>
+        </p:txBody>
+      </p:sp>
+    </p:spTree>
+    <p:extLst>
+      <p:ext uri="{BB962C8B-B14F-4D97-AF65-F5344CB8AC3E}">
+        <p14:creationId xmlns:p14="http://schemas.microsoft.com/office/powerpoint/2010/main" val="1988268134"/>
+      </p:ext>
+    </p:extLst>
+  </p:cSld>
+  <p:clrMapOvr>
+    <a:masterClrMapping/>
+  </p:clrMapOvr>
+</p:notes>
 </file>
 
 <file path=ppt/slideLayouts/slideLayout1.xml><?xml version="1.0" encoding="utf-8"?>
@@ -496,7 +1433,7 @@
           <a:p>
             <a:fld id="{9B10F84E-4F92-482B-9E59-E7E052490FE2}" type="datetimeFigureOut">
               <a:rPr lang="zh-CN" altLang="en-US" smtClean="0"/>
-              <a:t>2026/10/9</a:t>
+              <a:t>2026/10/10</a:t>
             </a:fld>
             <a:endParaRPr lang="zh-CN" altLang="en-US"/>
           </a:p>
@@ -694,7 +1631,7 @@
           <a:p>
             <a:fld id="{9B10F84E-4F92-482B-9E59-E7E052490FE2}" type="datetimeFigureOut">
               <a:rPr lang="zh-CN" altLang="en-US" smtClean="0"/>
-              <a:t>2026/10/9</a:t>
+              <a:t>2026/10/10</a:t>
             </a:fld>
             <a:endParaRPr lang="zh-CN" altLang="en-US"/>
           </a:p>
@@ -902,7 +1839,7 @@
           <a:p>
             <a:fld id="{9B10F84E-4F92-482B-9E59-E7E052490FE2}" type="datetimeFigureOut">
               <a:rPr lang="zh-CN" altLang="en-US" smtClean="0"/>
-              <a:t>2026/10/9</a:t>
+              <a:t>2026/10/10</a:t>
             </a:fld>
             <a:endParaRPr lang="zh-CN" altLang="en-US"/>
           </a:p>
@@ -1100,7 +2037,7 @@
           <a:p>
             <a:fld id="{9B10F84E-4F92-482B-9E59-E7E052490FE2}" type="datetimeFigureOut">
               <a:rPr lang="zh-CN" altLang="en-US" smtClean="0"/>
-              <a:t>2026/10/9</a:t>
+              <a:t>2026/10/10</a:t>
             </a:fld>
             <a:endParaRPr lang="zh-CN" altLang="en-US"/>
           </a:p>
@@ -1375,7 +2312,7 @@
           <a:p>
             <a:fld id="{9B10F84E-4F92-482B-9E59-E7E052490FE2}" type="datetimeFigureOut">
               <a:rPr lang="zh-CN" altLang="en-US" smtClean="0"/>
-              <a:t>2026/10/9</a:t>
+              <a:t>2026/10/10</a:t>
             </a:fld>
             <a:endParaRPr lang="zh-CN" altLang="en-US"/>
           </a:p>
@@ -1640,7 +2577,7 @@
           <a:p>
             <a:fld id="{9B10F84E-4F92-482B-9E59-E7E052490FE2}" type="datetimeFigureOut">
               <a:rPr lang="zh-CN" altLang="en-US" smtClean="0"/>
-              <a:t>2026/10/9</a:t>
+              <a:t>2026/10/10</a:t>
             </a:fld>
             <a:endParaRPr lang="zh-CN" altLang="en-US"/>
           </a:p>
@@ -2052,7 +2989,7 @@
           <a:p>
             <a:fld id="{9B10F84E-4F92-482B-9E59-E7E052490FE2}" type="datetimeFigureOut">
               <a:rPr lang="zh-CN" altLang="en-US" smtClean="0"/>
-              <a:t>2026/10/9</a:t>
+              <a:t>2026/10/10</a:t>
             </a:fld>
             <a:endParaRPr lang="zh-CN" altLang="en-US"/>
           </a:p>
@@ -2193,7 +3130,7 @@
           <a:p>
             <a:fld id="{9B10F84E-4F92-482B-9E59-E7E052490FE2}" type="datetimeFigureOut">
               <a:rPr lang="zh-CN" altLang="en-US" smtClean="0"/>
-              <a:t>2026/10/9</a:t>
+              <a:t>2026/10/10</a:t>
             </a:fld>
             <a:endParaRPr lang="zh-CN" altLang="en-US"/>
           </a:p>
@@ -2306,7 +3243,7 @@
           <a:p>
             <a:fld id="{9B10F84E-4F92-482B-9E59-E7E052490FE2}" type="datetimeFigureOut">
               <a:rPr lang="zh-CN" altLang="en-US" smtClean="0"/>
-              <a:t>2026/10/9</a:t>
+              <a:t>2026/10/10</a:t>
             </a:fld>
             <a:endParaRPr lang="zh-CN" altLang="en-US"/>
           </a:p>
@@ -2617,7 +3554,7 @@
           <a:p>
             <a:fld id="{9B10F84E-4F92-482B-9E59-E7E052490FE2}" type="datetimeFigureOut">
               <a:rPr lang="zh-CN" altLang="en-US" smtClean="0"/>
-              <a:t>2026/10/9</a:t>
+              <a:t>2026/10/10</a:t>
             </a:fld>
             <a:endParaRPr lang="zh-CN" altLang="en-US"/>
           </a:p>
@@ -2905,7 +3842,7 @@
           <a:p>
             <a:fld id="{9B10F84E-4F92-482B-9E59-E7E052490FE2}" type="datetimeFigureOut">
               <a:rPr lang="zh-CN" altLang="en-US" smtClean="0"/>
-              <a:t>2026/10/9</a:t>
+              <a:t>2026/10/10</a:t>
             </a:fld>
             <a:endParaRPr lang="zh-CN" altLang="en-US"/>
           </a:p>
@@ -3146,7 +4083,7 @@
           <a:p>
             <a:fld id="{9B10F84E-4F92-482B-9E59-E7E052490FE2}" type="datetimeFigureOut">
               <a:rPr lang="zh-CN" altLang="en-US" smtClean="0"/>
-              <a:t>2026/10/9</a:t>
+              <a:t>2026/10/10</a:t>
             </a:fld>
             <a:endParaRPr lang="zh-CN" altLang="en-US"/>
           </a:p>
@@ -3582,7 +4519,7 @@
         <p:spPr/>
         <p:txBody>
           <a:bodyPr>
-            <a:normAutofit fontScale="90000"/>
+            <a:normAutofit/>
           </a:bodyPr>
           <a:lstStyle/>
           <a:p>
@@ -3592,7 +4529,7 @@
             </a:r>
             <a:r>
               <a:rPr lang="en-US" altLang="zh-CN" dirty="0"/>
-              <a:t>-Vulkan-Android Renderer</a:t>
+              <a:t>-Renderer</a:t>
             </a:r>
             <a:br>
               <a:rPr lang="en-US" altLang="zh-CN" dirty="0"/>
@@ -3655,6 +4592,541 @@
     <p:extLst>
       <p:ext uri="{BB962C8B-B14F-4D97-AF65-F5344CB8AC3E}">
         <p14:creationId xmlns:p14="http://schemas.microsoft.com/office/powerpoint/2010/main" val="3812720094"/>
+      </p:ext>
+    </p:extLst>
+  </p:cSld>
+  <p:clrMapOvr>
+    <a:masterClrMapping/>
+  </p:clrMapOvr>
+</p:sld>
+</file>
+
+<file path=ppt/slides/slide10.xml><?xml version="1.0" encoding="utf-8"?>
+<p:sld xmlns:a="http://schemas.openxmlformats.org/drawingml/2006/main" xmlns:r="http://schemas.openxmlformats.org/officeDocument/2006/relationships" xmlns:p="http://schemas.openxmlformats.org/presentationml/2006/main">
+  <p:cSld>
+    <p:spTree>
+      <p:nvGrpSpPr>
+        <p:cNvPr id="1" name="">
+          <a:extLst>
+            <a:ext uri="{FF2B5EF4-FFF2-40B4-BE49-F238E27FC236}">
+              <a16:creationId xmlns:a16="http://schemas.microsoft.com/office/drawing/2014/main" id="{995292A7-A398-8E9B-1662-A912A1000B95}"/>
+            </a:ext>
+          </a:extLst>
+        </p:cNvPr>
+        <p:cNvGrpSpPr/>
+        <p:nvPr/>
+      </p:nvGrpSpPr>
+      <p:grpSpPr>
+        <a:xfrm>
+          <a:off x="0" y="0"/>
+          <a:ext cx="0" cy="0"/>
+          <a:chOff x="0" y="0"/>
+          <a:chExt cx="0" cy="0"/>
+        </a:xfrm>
+      </p:grpSpPr>
+      <p:sp>
+        <p:nvSpPr>
+          <p:cNvPr id="2" name="标题 1">
+            <a:extLst>
+              <a:ext uri="{FF2B5EF4-FFF2-40B4-BE49-F238E27FC236}">
+                <a16:creationId xmlns:a16="http://schemas.microsoft.com/office/drawing/2014/main" id="{A07AE7C9-8F03-CDB0-D027-363093275095}"/>
+              </a:ext>
+            </a:extLst>
+          </p:cNvPr>
+          <p:cNvSpPr>
+            <a:spLocks noGrp="1"/>
+          </p:cNvSpPr>
+          <p:nvPr>
+            <p:ph type="title"/>
+          </p:nvPr>
+        </p:nvSpPr>
+        <p:spPr/>
+        <p:txBody>
+          <a:bodyPr/>
+          <a:lstStyle/>
+          <a:p>
+            <a:r>
+              <a:rPr lang="en-US" altLang="zh-CN" dirty="0"/>
+              <a:t>MCP for Blender</a:t>
+            </a:r>
+            <a:endParaRPr lang="zh-CN" altLang="en-US" dirty="0"/>
+          </a:p>
+        </p:txBody>
+      </p:sp>
+      <p:pic>
+        <p:nvPicPr>
+          <p:cNvPr id="7" name="Picture 6">
+            <a:extLst>
+              <a:ext uri="{FF2B5EF4-FFF2-40B4-BE49-F238E27FC236}">
+                <a16:creationId xmlns:a16="http://schemas.microsoft.com/office/drawing/2014/main" id="{15623197-5A4C-2FF6-5850-E1A8517A291F}"/>
+              </a:ext>
+            </a:extLst>
+          </p:cNvPr>
+          <p:cNvPicPr>
+            <a:picLocks noChangeAspect="1"/>
+          </p:cNvPicPr>
+          <p:nvPr/>
+        </p:nvPicPr>
+        <p:blipFill>
+          <a:blip r:embed="rId2"/>
+          <a:stretch>
+            <a:fillRect/>
+          </a:stretch>
+        </p:blipFill>
+        <p:spPr>
+          <a:xfrm>
+            <a:off x="424320" y="1201324"/>
+            <a:ext cx="5633580" cy="5037940"/>
+          </a:xfrm>
+          <a:prstGeom prst="rect">
+            <a:avLst/>
+          </a:prstGeom>
+        </p:spPr>
+      </p:pic>
+      <p:pic>
+        <p:nvPicPr>
+          <p:cNvPr id="11" name="Picture 10">
+            <a:extLst>
+              <a:ext uri="{FF2B5EF4-FFF2-40B4-BE49-F238E27FC236}">
+                <a16:creationId xmlns:a16="http://schemas.microsoft.com/office/drawing/2014/main" id="{58EEFE3E-A182-F32B-2720-1B55C6E98940}"/>
+              </a:ext>
+            </a:extLst>
+          </p:cNvPr>
+          <p:cNvPicPr>
+            <a:picLocks noChangeAspect="1"/>
+          </p:cNvPicPr>
+          <p:nvPr/>
+        </p:nvPicPr>
+        <p:blipFill>
+          <a:blip r:embed="rId3"/>
+          <a:stretch>
+            <a:fillRect/>
+          </a:stretch>
+        </p:blipFill>
+        <p:spPr>
+          <a:xfrm>
+            <a:off x="6216694" y="1201324"/>
+            <a:ext cx="3867648" cy="2814085"/>
+          </a:xfrm>
+          <a:prstGeom prst="rect">
+            <a:avLst/>
+          </a:prstGeom>
+        </p:spPr>
+      </p:pic>
+      <p:pic>
+        <p:nvPicPr>
+          <p:cNvPr id="15" name="Picture 14">
+            <a:extLst>
+              <a:ext uri="{FF2B5EF4-FFF2-40B4-BE49-F238E27FC236}">
+                <a16:creationId xmlns:a16="http://schemas.microsoft.com/office/drawing/2014/main" id="{7CB3A017-B718-300C-41CD-D9CCEF9CF140}"/>
+              </a:ext>
+            </a:extLst>
+          </p:cNvPr>
+          <p:cNvPicPr>
+            <a:picLocks noChangeAspect="1"/>
+          </p:cNvPicPr>
+          <p:nvPr/>
+        </p:nvPicPr>
+        <p:blipFill>
+          <a:blip r:embed="rId4"/>
+          <a:stretch>
+            <a:fillRect/>
+          </a:stretch>
+        </p:blipFill>
+        <p:spPr>
+          <a:xfrm>
+            <a:off x="6216694" y="4015409"/>
+            <a:ext cx="5813342" cy="1958008"/>
+          </a:xfrm>
+          <a:prstGeom prst="rect">
+            <a:avLst/>
+          </a:prstGeom>
+        </p:spPr>
+      </p:pic>
+    </p:spTree>
+    <p:extLst>
+      <p:ext uri="{BB962C8B-B14F-4D97-AF65-F5344CB8AC3E}">
+        <p14:creationId xmlns:p14="http://schemas.microsoft.com/office/powerpoint/2010/main" val="2124816499"/>
+      </p:ext>
+    </p:extLst>
+  </p:cSld>
+  <p:clrMapOvr>
+    <a:masterClrMapping/>
+  </p:clrMapOvr>
+</p:sld>
+</file>
+
+<file path=ppt/slides/slide11.xml><?xml version="1.0" encoding="utf-8"?>
+<p:sld xmlns:a="http://schemas.openxmlformats.org/drawingml/2006/main" xmlns:r="http://schemas.openxmlformats.org/officeDocument/2006/relationships" xmlns:p="http://schemas.openxmlformats.org/presentationml/2006/main">
+  <p:cSld>
+    <p:spTree>
+      <p:nvGrpSpPr>
+        <p:cNvPr id="1" name="">
+          <a:extLst>
+            <a:ext uri="{FF2B5EF4-FFF2-40B4-BE49-F238E27FC236}">
+              <a16:creationId xmlns:a16="http://schemas.microsoft.com/office/drawing/2014/main" id="{C4CB5C94-CC69-5322-F19F-AB5D61AC138E}"/>
+            </a:ext>
+          </a:extLst>
+        </p:cNvPr>
+        <p:cNvGrpSpPr/>
+        <p:nvPr/>
+      </p:nvGrpSpPr>
+      <p:grpSpPr>
+        <a:xfrm>
+          <a:off x="0" y="0"/>
+          <a:ext cx="0" cy="0"/>
+          <a:chOff x="0" y="0"/>
+          <a:chExt cx="0" cy="0"/>
+        </a:xfrm>
+      </p:grpSpPr>
+      <p:sp>
+        <p:nvSpPr>
+          <p:cNvPr id="2" name="标题 1">
+            <a:extLst>
+              <a:ext uri="{FF2B5EF4-FFF2-40B4-BE49-F238E27FC236}">
+                <a16:creationId xmlns:a16="http://schemas.microsoft.com/office/drawing/2014/main" id="{4449A65D-BCA9-EBDD-F495-8AA66AF2882D}"/>
+              </a:ext>
+            </a:extLst>
+          </p:cNvPr>
+          <p:cNvSpPr>
+            <a:spLocks noGrp="1"/>
+          </p:cNvSpPr>
+          <p:nvPr>
+            <p:ph type="title"/>
+          </p:nvPr>
+        </p:nvSpPr>
+        <p:spPr/>
+        <p:txBody>
+          <a:bodyPr/>
+          <a:lstStyle/>
+          <a:p>
+            <a:r>
+              <a:rPr lang="en-US" altLang="zh-CN" dirty="0"/>
+              <a:t>GLTF/GLB extension</a:t>
+            </a:r>
+            <a:endParaRPr lang="zh-CN" altLang="en-US" dirty="0"/>
+          </a:p>
+        </p:txBody>
+      </p:sp>
+      <p:pic>
+        <p:nvPicPr>
+          <p:cNvPr id="4" name="Picture 3">
+            <a:extLst>
+              <a:ext uri="{FF2B5EF4-FFF2-40B4-BE49-F238E27FC236}">
+                <a16:creationId xmlns:a16="http://schemas.microsoft.com/office/drawing/2014/main" id="{049434F6-E4A4-20BD-E2F4-BAA18285ED8E}"/>
+              </a:ext>
+            </a:extLst>
+          </p:cNvPr>
+          <p:cNvPicPr>
+            <a:picLocks noChangeAspect="1"/>
+          </p:cNvPicPr>
+          <p:nvPr/>
+        </p:nvPicPr>
+        <p:blipFill>
+          <a:blip r:embed="rId2"/>
+          <a:stretch>
+            <a:fillRect/>
+          </a:stretch>
+        </p:blipFill>
+        <p:spPr>
+          <a:xfrm>
+            <a:off x="4081652" y="1496341"/>
+            <a:ext cx="4495833" cy="4252944"/>
+          </a:xfrm>
+          <a:prstGeom prst="rect">
+            <a:avLst/>
+          </a:prstGeom>
+        </p:spPr>
+      </p:pic>
+    </p:spTree>
+    <p:extLst>
+      <p:ext uri="{BB962C8B-B14F-4D97-AF65-F5344CB8AC3E}">
+        <p14:creationId xmlns:p14="http://schemas.microsoft.com/office/powerpoint/2010/main" val="1140172268"/>
+      </p:ext>
+    </p:extLst>
+  </p:cSld>
+  <p:clrMapOvr>
+    <a:masterClrMapping/>
+  </p:clrMapOvr>
+</p:sld>
+</file>
+
+<file path=ppt/slides/slide12.xml><?xml version="1.0" encoding="utf-8"?>
+<p:sld xmlns:a="http://schemas.openxmlformats.org/drawingml/2006/main" xmlns:r="http://schemas.openxmlformats.org/officeDocument/2006/relationships" xmlns:p="http://schemas.openxmlformats.org/presentationml/2006/main">
+  <p:cSld>
+    <p:spTree>
+      <p:nvGrpSpPr>
+        <p:cNvPr id="1" name="">
+          <a:extLst>
+            <a:ext uri="{FF2B5EF4-FFF2-40B4-BE49-F238E27FC236}">
+              <a16:creationId xmlns:a16="http://schemas.microsoft.com/office/drawing/2014/main" id="{156660F6-F363-FD77-5D1E-98DC0379C139}"/>
+            </a:ext>
+          </a:extLst>
+        </p:cNvPr>
+        <p:cNvGrpSpPr/>
+        <p:nvPr/>
+      </p:nvGrpSpPr>
+      <p:grpSpPr>
+        <a:xfrm>
+          <a:off x="0" y="0"/>
+          <a:ext cx="0" cy="0"/>
+          <a:chOff x="0" y="0"/>
+          <a:chExt cx="0" cy="0"/>
+        </a:xfrm>
+      </p:grpSpPr>
+      <p:sp>
+        <p:nvSpPr>
+          <p:cNvPr id="2" name="标题 1">
+            <a:extLst>
+              <a:ext uri="{FF2B5EF4-FFF2-40B4-BE49-F238E27FC236}">
+                <a16:creationId xmlns:a16="http://schemas.microsoft.com/office/drawing/2014/main" id="{908AD7D4-E292-EA64-F0D4-B2512616F071}"/>
+              </a:ext>
+            </a:extLst>
+          </p:cNvPr>
+          <p:cNvSpPr>
+            <a:spLocks noGrp="1"/>
+          </p:cNvSpPr>
+          <p:nvPr>
+            <p:ph type="title"/>
+          </p:nvPr>
+        </p:nvSpPr>
+        <p:spPr/>
+        <p:txBody>
+          <a:bodyPr/>
+          <a:lstStyle/>
+          <a:p>
+            <a:r>
+              <a:rPr lang="en-US" altLang="zh-CN" dirty="0"/>
+              <a:t>Android OS/ADB/APK</a:t>
+            </a:r>
+            <a:endParaRPr lang="zh-CN" altLang="en-US" dirty="0"/>
+          </a:p>
+        </p:txBody>
+      </p:sp>
+      <p:pic>
+        <p:nvPicPr>
+          <p:cNvPr id="5" name="Picture 4">
+            <a:extLst>
+              <a:ext uri="{FF2B5EF4-FFF2-40B4-BE49-F238E27FC236}">
+                <a16:creationId xmlns:a16="http://schemas.microsoft.com/office/drawing/2014/main" id="{D5731147-B5A1-F0B0-2687-A47A37792A7A}"/>
+              </a:ext>
+            </a:extLst>
+          </p:cNvPr>
+          <p:cNvPicPr>
+            <a:picLocks noChangeAspect="1"/>
+          </p:cNvPicPr>
+          <p:nvPr/>
+        </p:nvPicPr>
+        <p:blipFill>
+          <a:blip r:embed="rId2"/>
+          <a:stretch>
+            <a:fillRect/>
+          </a:stretch>
+        </p:blipFill>
+        <p:spPr>
+          <a:xfrm>
+            <a:off x="90153" y="1374692"/>
+            <a:ext cx="5320193" cy="3351365"/>
+          </a:xfrm>
+          <a:prstGeom prst="rect">
+            <a:avLst/>
+          </a:prstGeom>
+        </p:spPr>
+      </p:pic>
+    </p:spTree>
+    <p:extLst>
+      <p:ext uri="{BB962C8B-B14F-4D97-AF65-F5344CB8AC3E}">
+        <p14:creationId xmlns:p14="http://schemas.microsoft.com/office/powerpoint/2010/main" val="2948105093"/>
+      </p:ext>
+    </p:extLst>
+  </p:cSld>
+  <p:clrMapOvr>
+    <a:masterClrMapping/>
+  </p:clrMapOvr>
+</p:sld>
+</file>
+
+<file path=ppt/slides/slide13.xml><?xml version="1.0" encoding="utf-8"?>
+<p:sld xmlns:a="http://schemas.openxmlformats.org/drawingml/2006/main" xmlns:r="http://schemas.openxmlformats.org/officeDocument/2006/relationships" xmlns:p="http://schemas.openxmlformats.org/presentationml/2006/main">
+  <p:cSld>
+    <p:spTree>
+      <p:nvGrpSpPr>
+        <p:cNvPr id="1" name=""/>
+        <p:cNvGrpSpPr/>
+        <p:nvPr/>
+      </p:nvGrpSpPr>
+      <p:grpSpPr>
+        <a:xfrm>
+          <a:off x="0" y="0"/>
+          <a:ext cx="0" cy="0"/>
+          <a:chOff x="0" y="0"/>
+          <a:chExt cx="0" cy="0"/>
+        </a:xfrm>
+      </p:grpSpPr>
+      <p:sp>
+        <p:nvSpPr>
+          <p:cNvPr id="2" name="标题 1">
+            <a:extLst>
+              <a:ext uri="{FF2B5EF4-FFF2-40B4-BE49-F238E27FC236}">
+                <a16:creationId xmlns:a16="http://schemas.microsoft.com/office/drawing/2014/main" id="{1631EA1C-1B4C-8E94-51C2-D8E2E04625BA}"/>
+              </a:ext>
+            </a:extLst>
+          </p:cNvPr>
+          <p:cNvSpPr>
+            <a:spLocks noGrp="1"/>
+          </p:cNvSpPr>
+          <p:nvPr>
+            <p:ph type="title"/>
+          </p:nvPr>
+        </p:nvSpPr>
+        <p:spPr/>
+        <p:txBody>
+          <a:bodyPr/>
+          <a:lstStyle/>
+          <a:p>
+            <a:r>
+              <a:rPr lang="en-US" altLang="zh-CN" dirty="0"/>
+              <a:t>Personal notes</a:t>
+            </a:r>
+            <a:endParaRPr lang="zh-CN" altLang="en-US" dirty="0"/>
+          </a:p>
+        </p:txBody>
+      </p:sp>
+      <p:sp>
+        <p:nvSpPr>
+          <p:cNvPr id="3" name="内容占位符 2">
+            <a:extLst>
+              <a:ext uri="{FF2B5EF4-FFF2-40B4-BE49-F238E27FC236}">
+                <a16:creationId xmlns:a16="http://schemas.microsoft.com/office/drawing/2014/main" id="{D864FF2B-5D3B-E95E-834D-1B30DB2A2B6B}"/>
+              </a:ext>
+            </a:extLst>
+          </p:cNvPr>
+          <p:cNvSpPr>
+            <a:spLocks noGrp="1"/>
+          </p:cNvSpPr>
+          <p:nvPr>
+            <p:ph idx="1"/>
+          </p:nvPr>
+        </p:nvSpPr>
+        <p:spPr/>
+        <p:txBody>
+          <a:bodyPr/>
+          <a:lstStyle/>
+          <a:p>
+            <a:r>
+              <a:rPr lang="en-US" altLang="zh-CN" dirty="0"/>
+              <a:t>About AI usage in 3d engineering</a:t>
+            </a:r>
+          </a:p>
+          <a:p>
+            <a:r>
+              <a:rPr lang="en-US" altLang="zh-CN" dirty="0"/>
+              <a:t>About low layer engineering</a:t>
+            </a:r>
+          </a:p>
+          <a:p>
+            <a:r>
+              <a:rPr lang="en-US" altLang="zh-CN" dirty="0"/>
+              <a:t>About math (linear algebra) inside 3d rendering</a:t>
+            </a:r>
+          </a:p>
+          <a:p>
+            <a:r>
+              <a:rPr lang="en-US" altLang="zh-CN" dirty="0"/>
+              <a:t>About my personal career plan</a:t>
+            </a:r>
+            <a:endParaRPr lang="zh-CN" altLang="en-US" dirty="0"/>
+          </a:p>
+        </p:txBody>
+      </p:sp>
+    </p:spTree>
+    <p:extLst>
+      <p:ext uri="{BB962C8B-B14F-4D97-AF65-F5344CB8AC3E}">
+        <p14:creationId xmlns:p14="http://schemas.microsoft.com/office/powerpoint/2010/main" val="3127194409"/>
+      </p:ext>
+    </p:extLst>
+  </p:cSld>
+  <p:clrMapOvr>
+    <a:masterClrMapping/>
+  </p:clrMapOvr>
+</p:sld>
+</file>
+
+<file path=ppt/slides/slide14.xml><?xml version="1.0" encoding="utf-8"?>
+<p:sld xmlns:a="http://schemas.openxmlformats.org/drawingml/2006/main" xmlns:r="http://schemas.openxmlformats.org/officeDocument/2006/relationships" xmlns:p="http://schemas.openxmlformats.org/presentationml/2006/main">
+  <p:cSld>
+    <p:spTree>
+      <p:nvGrpSpPr>
+        <p:cNvPr id="1" name=""/>
+        <p:cNvGrpSpPr/>
+        <p:nvPr/>
+      </p:nvGrpSpPr>
+      <p:grpSpPr>
+        <a:xfrm>
+          <a:off x="0" y="0"/>
+          <a:ext cx="0" cy="0"/>
+          <a:chOff x="0" y="0"/>
+          <a:chExt cx="0" cy="0"/>
+        </a:xfrm>
+      </p:grpSpPr>
+      <p:sp>
+        <p:nvSpPr>
+          <p:cNvPr id="2" name="标题 1">
+            <a:extLst>
+              <a:ext uri="{FF2B5EF4-FFF2-40B4-BE49-F238E27FC236}">
+                <a16:creationId xmlns:a16="http://schemas.microsoft.com/office/drawing/2014/main" id="{493A2EF7-200C-22DA-3C40-B6F90972A172}"/>
+              </a:ext>
+            </a:extLst>
+          </p:cNvPr>
+          <p:cNvSpPr>
+            <a:spLocks noGrp="1"/>
+          </p:cNvSpPr>
+          <p:nvPr>
+            <p:ph type="ctrTitle"/>
+          </p:nvPr>
+        </p:nvSpPr>
+        <p:spPr/>
+        <p:txBody>
+          <a:bodyPr/>
+          <a:lstStyle/>
+          <a:p>
+            <a:r>
+              <a:rPr lang="en-US" altLang="zh-CN" dirty="0"/>
+              <a:t>Thanks</a:t>
+            </a:r>
+            <a:endParaRPr lang="zh-CN" altLang="en-US" dirty="0"/>
+          </a:p>
+        </p:txBody>
+      </p:sp>
+      <p:sp>
+        <p:nvSpPr>
+          <p:cNvPr id="3" name="副标题 2">
+            <a:extLst>
+              <a:ext uri="{FF2B5EF4-FFF2-40B4-BE49-F238E27FC236}">
+                <a16:creationId xmlns:a16="http://schemas.microsoft.com/office/drawing/2014/main" id="{3FCD6C58-D537-7B4D-F070-8B16911322A8}"/>
+              </a:ext>
+            </a:extLst>
+          </p:cNvPr>
+          <p:cNvSpPr>
+            <a:spLocks noGrp="1"/>
+          </p:cNvSpPr>
+          <p:nvPr>
+            <p:ph type="subTitle" idx="1"/>
+          </p:nvPr>
+        </p:nvSpPr>
+        <p:spPr/>
+        <p:txBody>
+          <a:bodyPr/>
+          <a:lstStyle/>
+          <a:p>
+            <a:endParaRPr lang="zh-CN" altLang="en-US" dirty="0"/>
+          </a:p>
+        </p:txBody>
+      </p:sp>
+    </p:spTree>
+    <p:extLst>
+      <p:ext uri="{BB962C8B-B14F-4D97-AF65-F5344CB8AC3E}">
+        <p14:creationId xmlns:p14="http://schemas.microsoft.com/office/powerpoint/2010/main" val="2396252889"/>
       </p:ext>
     </p:extLst>
   </p:cSld>
@@ -3884,7 +5356,7 @@
           <p:cNvPr id="2" name="标题 1">
             <a:extLst>
               <a:ext uri="{FF2B5EF4-FFF2-40B4-BE49-F238E27FC236}">
-                <a16:creationId xmlns:a16="http://schemas.microsoft.com/office/drawing/2014/main" id="{5A6A0DDF-6AE1-2597-B37F-5E53B7B0AAAE}"/>
+                <a16:creationId xmlns:a16="http://schemas.microsoft.com/office/drawing/2014/main" id="{DF18CD9C-0DB6-ED86-B2ED-A5071F21E7C7}"/>
               </a:ext>
             </a:extLst>
           </p:cNvPr>
@@ -3902,7 +5374,7 @@
           <a:p>
             <a:r>
               <a:rPr lang="en-US" altLang="zh-CN" dirty="0"/>
-              <a:t>Core Feature</a:t>
+              <a:t>Detailed Analysis by category</a:t>
             </a:r>
             <a:endParaRPr lang="zh-CN" altLang="en-US" dirty="0"/>
           </a:p>
@@ -3913,7 +5385,7 @@
           <p:cNvPr id="3" name="内容占位符 2">
             <a:extLst>
               <a:ext uri="{FF2B5EF4-FFF2-40B4-BE49-F238E27FC236}">
-                <a16:creationId xmlns:a16="http://schemas.microsoft.com/office/drawing/2014/main" id="{0A57FAFE-46D3-5E6C-7993-DDE70DEF6DCD}"/>
+                <a16:creationId xmlns:a16="http://schemas.microsoft.com/office/drawing/2014/main" id="{2413A87A-A300-E5BC-D77E-E5ACD4FA9EBD}"/>
               </a:ext>
             </a:extLst>
           </p:cNvPr>
@@ -3929,14 +5401,35 @@
           <a:bodyPr/>
           <a:lstStyle/>
           <a:p>
-            <a:endParaRPr lang="zh-CN" altLang="en-US"/>
+            <a:r>
+              <a:rPr lang="en-US" altLang="zh-CN" dirty="0"/>
+              <a:t>Visual analysis</a:t>
+            </a:r>
+          </a:p>
+          <a:p>
+            <a:r>
+              <a:rPr lang="en-US" altLang="zh-CN" dirty="0"/>
+              <a:t>Performance analysis</a:t>
+            </a:r>
+          </a:p>
+          <a:p>
+            <a:r>
+              <a:rPr lang="en-US" altLang="zh-CN" dirty="0"/>
+              <a:t>Workflow analysis</a:t>
+            </a:r>
+          </a:p>
+          <a:p>
+            <a:pPr marL="0" indent="0">
+              <a:buNone/>
+            </a:pPr>
+            <a:endParaRPr lang="en-US" altLang="zh-CN" dirty="0"/>
           </a:p>
         </p:txBody>
       </p:sp>
     </p:spTree>
     <p:extLst>
       <p:ext uri="{BB962C8B-B14F-4D97-AF65-F5344CB8AC3E}">
-        <p14:creationId xmlns:p14="http://schemas.microsoft.com/office/powerpoint/2010/main" val="2182435635"/>
+        <p14:creationId xmlns:p14="http://schemas.microsoft.com/office/powerpoint/2010/main" val="3986438202"/>
       </p:ext>
     </p:extLst>
   </p:cSld>
@@ -3968,7 +5461,7 @@
           <p:cNvPr id="2" name="标题 1">
             <a:extLst>
               <a:ext uri="{FF2B5EF4-FFF2-40B4-BE49-F238E27FC236}">
-                <a16:creationId xmlns:a16="http://schemas.microsoft.com/office/drawing/2014/main" id="{DF18CD9C-0DB6-ED86-B2ED-A5071F21E7C7}"/>
+                <a16:creationId xmlns:a16="http://schemas.microsoft.com/office/drawing/2014/main" id="{9C52CD5E-0479-C15D-685C-53C96A9A2573}"/>
               </a:ext>
             </a:extLst>
           </p:cNvPr>
@@ -3979,75 +5472,124 @@
             <p:ph type="title"/>
           </p:nvPr>
         </p:nvSpPr>
-        <p:spPr/>
+        <p:spPr>
+          <a:xfrm>
+            <a:off x="838200" y="345247"/>
+            <a:ext cx="10515600" cy="1325563"/>
+          </a:xfrm>
+        </p:spPr>
         <p:txBody>
           <a:bodyPr/>
           <a:lstStyle/>
           <a:p>
             <a:r>
               <a:rPr lang="en-US" altLang="zh-CN" dirty="0"/>
-              <a:t>Detailed Analysis by category</a:t>
-            </a:r>
-            <a:endParaRPr lang="zh-CN" altLang="en-US" dirty="0"/>
-          </a:p>
-        </p:txBody>
-      </p:sp>
-      <p:sp>
-        <p:nvSpPr>
-          <p:cNvPr id="3" name="内容占位符 2">
-            <a:extLst>
-              <a:ext uri="{FF2B5EF4-FFF2-40B4-BE49-F238E27FC236}">
-                <a16:creationId xmlns:a16="http://schemas.microsoft.com/office/drawing/2014/main" id="{2413A87A-A300-E5BC-D77E-E5ACD4FA9EBD}"/>
-              </a:ext>
-            </a:extLst>
-          </p:cNvPr>
-          <p:cNvSpPr>
-            <a:spLocks noGrp="1"/>
-          </p:cNvSpPr>
+              <a:t>Visual analysis – plant animation</a:t>
+            </a:r>
+          </a:p>
+        </p:txBody>
+      </p:sp>
+      <p:pic>
+        <p:nvPicPr>
+          <p:cNvPr id="9" name="Content Placeholder 8">
+            <a:extLst>
+              <a:ext uri="{FF2B5EF4-FFF2-40B4-BE49-F238E27FC236}">
+                <a16:creationId xmlns:a16="http://schemas.microsoft.com/office/drawing/2014/main" id="{01B64DD8-E036-628D-36EA-25272E6644B1}"/>
+              </a:ext>
+            </a:extLst>
+          </p:cNvPr>
+          <p:cNvPicPr>
+            <a:picLocks noGrp="1" noChangeAspect="1"/>
+          </p:cNvPicPr>
           <p:nvPr>
             <p:ph idx="1"/>
           </p:nvPr>
-        </p:nvSpPr>
-        <p:spPr/>
-        <p:txBody>
-          <a:bodyPr/>
-          <a:lstStyle/>
-          <a:p>
-            <a:r>
-              <a:rPr lang="en-US" altLang="zh-CN" dirty="0"/>
-              <a:t>Visual analysis</a:t>
-            </a:r>
-          </a:p>
-          <a:p>
-            <a:r>
-              <a:rPr lang="en-US" altLang="zh-CN" dirty="0"/>
-              <a:t>Functional analysis</a:t>
-            </a:r>
-          </a:p>
-          <a:p>
-            <a:r>
-              <a:rPr lang="en-US" altLang="zh-CN" dirty="0"/>
-              <a:t>Performance analysis</a:t>
-            </a:r>
-          </a:p>
-          <a:p>
-            <a:r>
-              <a:rPr lang="en-US" altLang="zh-CN" dirty="0"/>
-              <a:t>AI integration analysis</a:t>
-            </a:r>
-          </a:p>
-          <a:p>
-            <a:r>
-              <a:rPr lang="en-US" altLang="zh-CN" dirty="0"/>
-              <a:t>Teamwork analysis</a:t>
-            </a:r>
+        </p:nvPicPr>
+        <p:blipFill>
+          <a:blip r:embed="rId2"/>
+          <a:stretch>
+            <a:fillRect/>
+          </a:stretch>
+        </p:blipFill>
+        <p:spPr>
+          <a:xfrm>
+            <a:off x="838200" y="2828534"/>
+            <a:ext cx="6315121" cy="2943247"/>
+          </a:xfrm>
+          <a:prstGeom prst="rect">
+            <a:avLst/>
+          </a:prstGeom>
+        </p:spPr>
+      </p:pic>
+      <p:sp>
+        <p:nvSpPr>
+          <p:cNvPr id="10" name="标题 1">
+            <a:extLst>
+              <a:ext uri="{FF2B5EF4-FFF2-40B4-BE49-F238E27FC236}">
+                <a16:creationId xmlns:a16="http://schemas.microsoft.com/office/drawing/2014/main" id="{63364981-20CC-598C-717F-99096FB5CF8F}"/>
+              </a:ext>
+            </a:extLst>
+          </p:cNvPr>
+          <p:cNvSpPr txBox="1">
+            <a:spLocks/>
+          </p:cNvSpPr>
+          <p:nvPr/>
+        </p:nvSpPr>
+        <p:spPr>
+          <a:xfrm>
+            <a:off x="838200" y="1372291"/>
+            <a:ext cx="10515600" cy="1325563"/>
+          </a:xfrm>
+          <a:prstGeom prst="rect">
+            <a:avLst/>
+          </a:prstGeom>
+        </p:spPr>
+        <p:txBody>
+          <a:bodyPr vert="horz" lIns="91440" tIns="45720" rIns="91440" bIns="45720" rtlCol="0" anchor="ctr">
+            <a:normAutofit/>
+          </a:bodyPr>
+          <a:lstStyle>
+            <a:lvl1pPr algn="l" defTabSz="914400" rtl="0" eaLnBrk="1" latinLnBrk="0" hangingPunct="1">
+              <a:lnSpc>
+                <a:spcPct val="90000"/>
+              </a:lnSpc>
+              <a:spcBef>
+                <a:spcPct val="0"/>
+              </a:spcBef>
+              <a:buNone/>
+              <a:defRPr sz="4400" kern="1200">
+                <a:solidFill>
+                  <a:schemeClr val="tx1"/>
+                </a:solidFill>
+                <a:latin typeface="+mj-lt"/>
+                <a:ea typeface="+mj-ea"/>
+                <a:cs typeface="+mj-cs"/>
+              </a:defRPr>
+            </a:lvl1pPr>
+          </a:lstStyle>
+          <a:p>
+            <a:r>
+              <a:rPr lang="en-US" b="1" dirty="0"/>
+              <a:t>Hierarchical GPU Vertex Shader Wind</a:t>
+            </a:r>
+            <a:r>
+              <a:rPr lang="en-US" dirty="0"/>
+              <a:t> </a:t>
+            </a:r>
+          </a:p>
+          <a:p>
+            <a:r>
+              <a:rPr lang="en-US" sz="3200" dirty="0"/>
+              <a:t>using encoded vertex attributes</a:t>
+            </a:r>
+            <a:endParaRPr lang="en-US" altLang="zh-CN" sz="3200" dirty="0"/>
           </a:p>
         </p:txBody>
       </p:sp>
     </p:spTree>
     <p:extLst>
       <p:ext uri="{BB962C8B-B14F-4D97-AF65-F5344CB8AC3E}">
-        <p14:creationId xmlns:p14="http://schemas.microsoft.com/office/powerpoint/2010/main" val="3986438202"/>
+        <p14:creationId xmlns:p14="http://schemas.microsoft.com/office/powerpoint/2010/main" val="1949254824"/>
       </p:ext>
     </p:extLst>
   </p:cSld>
@@ -4062,7 +5604,13 @@
   <p:cSld>
     <p:spTree>
       <p:nvGrpSpPr>
-        <p:cNvPr id="1" name=""/>
+        <p:cNvPr id="1" name="">
+          <a:extLst>
+            <a:ext uri="{FF2B5EF4-FFF2-40B4-BE49-F238E27FC236}">
+              <a16:creationId xmlns:a16="http://schemas.microsoft.com/office/drawing/2014/main" id="{57367C6D-4834-19BE-E31F-089210F40C55}"/>
+            </a:ext>
+          </a:extLst>
+        </p:cNvPr>
         <p:cNvGrpSpPr/>
         <p:nvPr/>
       </p:nvGrpSpPr>
@@ -4079,7 +5627,7 @@
           <p:cNvPr id="2" name="标题 1">
             <a:extLst>
               <a:ext uri="{FF2B5EF4-FFF2-40B4-BE49-F238E27FC236}">
-                <a16:creationId xmlns:a16="http://schemas.microsoft.com/office/drawing/2014/main" id="{9C52CD5E-0479-C15D-685C-53C96A9A2573}"/>
+                <a16:creationId xmlns:a16="http://schemas.microsoft.com/office/drawing/2014/main" id="{3357BD1C-E5F7-6F26-E954-00CF9CF426C6}"/>
               </a:ext>
             </a:extLst>
           </p:cNvPr>
@@ -4090,62 +5638,148 @@
             <p:ph type="title"/>
           </p:nvPr>
         </p:nvSpPr>
-        <p:spPr/>
-        <p:txBody>
-          <a:bodyPr/>
+        <p:spPr>
+          <a:xfrm>
+            <a:off x="838200" y="345247"/>
+            <a:ext cx="10515600" cy="2576857"/>
+          </a:xfrm>
+        </p:spPr>
+        <p:txBody>
+          <a:bodyPr>
+            <a:normAutofit/>
+          </a:bodyPr>
           <a:lstStyle/>
           <a:p>
             <a:r>
               <a:rPr lang="en-US" altLang="zh-CN" dirty="0"/>
-              <a:t>Teamwork analysis</a:t>
-            </a:r>
-            <a:endParaRPr lang="zh-CN" altLang="en-US" dirty="0"/>
-          </a:p>
-        </p:txBody>
-      </p:sp>
-      <p:sp>
-        <p:nvSpPr>
-          <p:cNvPr id="3" name="内容占位符 2">
-            <a:extLst>
-              <a:ext uri="{FF2B5EF4-FFF2-40B4-BE49-F238E27FC236}">
-                <a16:creationId xmlns:a16="http://schemas.microsoft.com/office/drawing/2014/main" id="{76C5F6CF-1048-44CE-5671-5D14C8C22D4E}"/>
-              </a:ext>
-            </a:extLst>
-          </p:cNvPr>
-          <p:cNvSpPr>
-            <a:spLocks noGrp="1"/>
-          </p:cNvSpPr>
-          <p:nvPr>
-            <p:ph idx="1"/>
-          </p:nvPr>
-        </p:nvSpPr>
-        <p:spPr/>
-        <p:txBody>
-          <a:bodyPr/>
-          <a:lstStyle/>
-          <a:p>
-            <a:r>
+              <a:t>Visual analysis – plant scatter</a:t>
+            </a:r>
+            <a:br>
               <a:rPr lang="en-US" altLang="zh-CN" dirty="0"/>
-              <a:t>One button click from blender to </a:t>
-            </a:r>
-            <a:r>
-              <a:rPr lang="en-US" altLang="zh-CN" dirty="0" err="1"/>
-              <a:t>renderable</a:t>
+            </a:br>
+            <a:r>
+              <a:rPr lang="en-US" b="1" dirty="0"/>
+              <a:t>Ecotone Gradient Scatterer with Variable-Radius Poisson Disk Sampling and Noise-Modulated Density</a:t>
             </a:r>
             <a:endParaRPr lang="en-US" altLang="zh-CN" dirty="0"/>
           </a:p>
-          <a:p>
-            <a:r>
-              <a:rPr lang="en-US" altLang="zh-CN" dirty="0"/>
-              <a:t>AI-native rendering engine</a:t>
-            </a:r>
-          </a:p>
-        </p:txBody>
-      </p:sp>
+        </p:txBody>
+      </p:sp>
+      <p:sp>
+        <p:nvSpPr>
+          <p:cNvPr id="10" name="标题 1">
+            <a:extLst>
+              <a:ext uri="{FF2B5EF4-FFF2-40B4-BE49-F238E27FC236}">
+                <a16:creationId xmlns:a16="http://schemas.microsoft.com/office/drawing/2014/main" id="{00CA7FDA-540C-FF9F-33E7-85A3A94C9AF8}"/>
+              </a:ext>
+            </a:extLst>
+          </p:cNvPr>
+          <p:cNvSpPr txBox="1">
+            <a:spLocks/>
+          </p:cNvSpPr>
+          <p:nvPr/>
+        </p:nvSpPr>
+        <p:spPr>
+          <a:xfrm>
+            <a:off x="838200" y="1372291"/>
+            <a:ext cx="10515600" cy="1325563"/>
+          </a:xfrm>
+          <a:prstGeom prst="rect">
+            <a:avLst/>
+          </a:prstGeom>
+        </p:spPr>
+        <p:txBody>
+          <a:bodyPr vert="horz" lIns="91440" tIns="45720" rIns="91440" bIns="45720" rtlCol="0" anchor="ctr">
+            <a:normAutofit/>
+          </a:bodyPr>
+          <a:lstStyle>
+            <a:lvl1pPr algn="l" defTabSz="914400" rtl="0" eaLnBrk="1" latinLnBrk="0" hangingPunct="1">
+              <a:lnSpc>
+                <a:spcPct val="90000"/>
+              </a:lnSpc>
+              <a:spcBef>
+                <a:spcPct val="0"/>
+              </a:spcBef>
+              <a:buNone/>
+              <a:defRPr sz="4400" kern="1200">
+                <a:solidFill>
+                  <a:schemeClr val="tx1"/>
+                </a:solidFill>
+                <a:latin typeface="+mj-lt"/>
+                <a:ea typeface="+mj-ea"/>
+                <a:cs typeface="+mj-cs"/>
+              </a:defRPr>
+            </a:lvl1pPr>
+          </a:lstStyle>
+          <a:p>
+            <a:endParaRPr lang="en-US" sz="2400" dirty="0"/>
+          </a:p>
+        </p:txBody>
+      </p:sp>
+      <p:pic>
+        <p:nvPicPr>
+          <p:cNvPr id="8" name="Picture 7">
+            <a:extLst>
+              <a:ext uri="{FF2B5EF4-FFF2-40B4-BE49-F238E27FC236}">
+                <a16:creationId xmlns:a16="http://schemas.microsoft.com/office/drawing/2014/main" id="{E63F0947-F892-DC4A-8D0E-71F730513A7B}"/>
+              </a:ext>
+            </a:extLst>
+          </p:cNvPr>
+          <p:cNvPicPr>
+            <a:picLocks noChangeAspect="1"/>
+          </p:cNvPicPr>
+          <p:nvPr/>
+        </p:nvPicPr>
+        <p:blipFill>
+          <a:blip r:embed="rId2"/>
+          <a:stretch>
+            <a:fillRect/>
+          </a:stretch>
+        </p:blipFill>
+        <p:spPr>
+          <a:xfrm>
+            <a:off x="5970598" y="2978686"/>
+            <a:ext cx="5210926" cy="3098582"/>
+          </a:xfrm>
+          <a:prstGeom prst="rect">
+            <a:avLst/>
+          </a:prstGeom>
+        </p:spPr>
+      </p:pic>
+      <p:pic>
+        <p:nvPicPr>
+          <p:cNvPr id="14" name="Picture 13">
+            <a:extLst>
+              <a:ext uri="{FF2B5EF4-FFF2-40B4-BE49-F238E27FC236}">
+                <a16:creationId xmlns:a16="http://schemas.microsoft.com/office/drawing/2014/main" id="{F2F36BE0-A1C9-EE2E-025D-785BC9ACC3C5}"/>
+              </a:ext>
+            </a:extLst>
+          </p:cNvPr>
+          <p:cNvPicPr>
+            <a:picLocks noChangeAspect="1"/>
+          </p:cNvPicPr>
+          <p:nvPr/>
+        </p:nvPicPr>
+        <p:blipFill>
+          <a:blip r:embed="rId3"/>
+          <a:stretch>
+            <a:fillRect/>
+          </a:stretch>
+        </p:blipFill>
+        <p:spPr>
+          <a:xfrm>
+            <a:off x="333352" y="2978686"/>
+            <a:ext cx="5272317" cy="2888557"/>
+          </a:xfrm>
+          <a:prstGeom prst="rect">
+            <a:avLst/>
+          </a:prstGeom>
+        </p:spPr>
+      </p:pic>
     </p:spTree>
     <p:extLst>
       <p:ext uri="{BB962C8B-B14F-4D97-AF65-F5344CB8AC3E}">
-        <p14:creationId xmlns:p14="http://schemas.microsoft.com/office/powerpoint/2010/main" val="1949254824"/>
+        <p14:creationId xmlns:p14="http://schemas.microsoft.com/office/powerpoint/2010/main" val="843727772"/>
       </p:ext>
     </p:extLst>
   </p:cSld>
@@ -4160,7 +5794,13 @@
   <p:cSld>
     <p:spTree>
       <p:nvGrpSpPr>
-        <p:cNvPr id="1" name=""/>
+        <p:cNvPr id="1" name="">
+          <a:extLst>
+            <a:ext uri="{FF2B5EF4-FFF2-40B4-BE49-F238E27FC236}">
+              <a16:creationId xmlns:a16="http://schemas.microsoft.com/office/drawing/2014/main" id="{D8CF2B23-A668-89F8-E563-C5C02D61355D}"/>
+            </a:ext>
+          </a:extLst>
+        </p:cNvPr>
         <p:cNvGrpSpPr/>
         <p:nvPr/>
       </p:nvGrpSpPr>
@@ -4177,7 +5817,7 @@
           <p:cNvPr id="2" name="标题 1">
             <a:extLst>
               <a:ext uri="{FF2B5EF4-FFF2-40B4-BE49-F238E27FC236}">
-                <a16:creationId xmlns:a16="http://schemas.microsoft.com/office/drawing/2014/main" id="{95665380-229C-8A34-832A-ED2E12BF40D0}"/>
+                <a16:creationId xmlns:a16="http://schemas.microsoft.com/office/drawing/2014/main" id="{09E2114C-741A-544B-6F85-EB2F790F1920}"/>
               </a:ext>
             </a:extLst>
           </p:cNvPr>
@@ -4193,11 +5833,14 @@
           <a:bodyPr/>
           <a:lstStyle/>
           <a:p>
+            <a:pPr marL="228600" indent="-228600">
+              <a:buFont typeface="Arial" panose="020B0604020202020204" pitchFamily="34" charset="0"/>
+              <a:buChar char="•"/>
+            </a:pPr>
             <a:r>
               <a:rPr lang="en-US" altLang="zh-CN" dirty="0"/>
-              <a:t>Other technologies used</a:t>
-            </a:r>
-            <a:endParaRPr lang="zh-CN" altLang="en-US" dirty="0"/>
+              <a:t>Performance analysis - Plant</a:t>
+            </a:r>
           </a:p>
         </p:txBody>
       </p:sp>
@@ -4206,7 +5849,7 @@
           <p:cNvPr id="3" name="内容占位符 2">
             <a:extLst>
               <a:ext uri="{FF2B5EF4-FFF2-40B4-BE49-F238E27FC236}">
-                <a16:creationId xmlns:a16="http://schemas.microsoft.com/office/drawing/2014/main" id="{1CDD36FB-14EB-E63C-DB13-5B0DFEF0AE1D}"/>
+                <a16:creationId xmlns:a16="http://schemas.microsoft.com/office/drawing/2014/main" id="{319AD4AA-A236-D115-96E6-B2F9ED260A75}"/>
               </a:ext>
             </a:extLst>
           </p:cNvPr>
@@ -4217,52 +5860,25 @@
             <p:ph idx="1"/>
           </p:nvPr>
         </p:nvSpPr>
-        <p:spPr/>
-        <p:txBody>
-          <a:bodyPr/>
+        <p:spPr>
+          <a:xfrm>
+            <a:off x="326335" y="1547329"/>
+            <a:ext cx="4881769" cy="460375"/>
+          </a:xfrm>
+        </p:spPr>
+        <p:txBody>
+          <a:bodyPr>
+            <a:normAutofit lnSpcReduction="10000"/>
+          </a:bodyPr>
           <a:lstStyle/>
           <a:p>
+            <a:pPr marL="0" indent="0">
+              <a:buNone/>
+            </a:pPr>
             <a:r>
               <a:rPr lang="en-US" altLang="zh-CN" dirty="0"/>
-              <a:t>MCP for blender/Blender</a:t>
-            </a:r>
-          </a:p>
-          <a:p>
-            <a:r>
-              <a:rPr lang="en-US" altLang="zh-CN" dirty="0"/>
-              <a:t>GLTF file format</a:t>
-            </a:r>
-          </a:p>
-          <a:p>
-            <a:r>
-              <a:rPr lang="en-US" altLang="zh-CN" dirty="0" err="1"/>
-              <a:t>WebGPU</a:t>
-            </a:r>
-            <a:r>
-              <a:rPr lang="en-US" altLang="zh-CN" dirty="0"/>
-              <a:t> standard</a:t>
-            </a:r>
-          </a:p>
-          <a:p>
-            <a:r>
-              <a:rPr lang="en-US" altLang="zh-CN" dirty="0"/>
-              <a:t>Android ADB debugging/Android OS/Android APK structure</a:t>
-            </a:r>
-          </a:p>
-          <a:p>
-            <a:r>
-              <a:rPr lang="en-US" altLang="zh-CN" dirty="0"/>
-              <a:t>Rust programming language for </a:t>
-            </a:r>
-            <a:r>
-              <a:rPr lang="en-US" altLang="zh-CN" dirty="0" err="1"/>
-              <a:t>WebGPU</a:t>
-            </a:r>
-            <a:r>
-              <a:rPr lang="en-US" altLang="zh-CN"/>
-              <a:t> </a:t>
-            </a:r>
-            <a:endParaRPr lang="en-US" altLang="zh-CN" dirty="0"/>
+              <a:t>Foliage Card optimization </a:t>
+            </a:r>
           </a:p>
           <a:p>
             <a:pPr marL="0" indent="0">
@@ -4271,14 +5887,1467 @@
             <a:endParaRPr lang="en-US" altLang="zh-CN" dirty="0"/>
           </a:p>
           <a:p>
-            <a:endParaRPr lang="zh-CN" altLang="en-US" dirty="0"/>
-          </a:p>
-        </p:txBody>
-      </p:sp>
+            <a:pPr marL="0" indent="0">
+              <a:buNone/>
+            </a:pPr>
+            <a:endParaRPr lang="en-US" altLang="zh-CN" dirty="0"/>
+          </a:p>
+        </p:txBody>
+      </p:sp>
+      <p:pic>
+        <p:nvPicPr>
+          <p:cNvPr id="9" name="Picture 8">
+            <a:extLst>
+              <a:ext uri="{FF2B5EF4-FFF2-40B4-BE49-F238E27FC236}">
+                <a16:creationId xmlns:a16="http://schemas.microsoft.com/office/drawing/2014/main" id="{CE0C8902-F7D5-5D1D-AB5F-5F52C363D314}"/>
+              </a:ext>
+            </a:extLst>
+          </p:cNvPr>
+          <p:cNvPicPr>
+            <a:picLocks noChangeAspect="1"/>
+          </p:cNvPicPr>
+          <p:nvPr/>
+        </p:nvPicPr>
+        <p:blipFill>
+          <a:blip r:embed="rId3"/>
+          <a:stretch>
+            <a:fillRect/>
+          </a:stretch>
+        </p:blipFill>
+        <p:spPr>
+          <a:xfrm>
+            <a:off x="382412" y="2137884"/>
+            <a:ext cx="4959871" cy="2016887"/>
+          </a:xfrm>
+          <a:prstGeom prst="rect">
+            <a:avLst/>
+          </a:prstGeom>
+        </p:spPr>
+      </p:pic>
+      <p:sp>
+        <p:nvSpPr>
+          <p:cNvPr id="10" name="内容占位符 2">
+            <a:extLst>
+              <a:ext uri="{FF2B5EF4-FFF2-40B4-BE49-F238E27FC236}">
+                <a16:creationId xmlns:a16="http://schemas.microsoft.com/office/drawing/2014/main" id="{95DD8A95-94AF-0BF2-ADA4-498CD2578109}"/>
+              </a:ext>
+            </a:extLst>
+          </p:cNvPr>
+          <p:cNvSpPr txBox="1">
+            <a:spLocks/>
+          </p:cNvSpPr>
+          <p:nvPr/>
+        </p:nvSpPr>
+        <p:spPr>
+          <a:xfrm>
+            <a:off x="382412" y="4285987"/>
+            <a:ext cx="4881769" cy="460375"/>
+          </a:xfrm>
+          <a:prstGeom prst="rect">
+            <a:avLst/>
+          </a:prstGeom>
+        </p:spPr>
+        <p:txBody>
+          <a:bodyPr vert="horz" lIns="91440" tIns="45720" rIns="91440" bIns="45720" rtlCol="0">
+            <a:normAutofit fontScale="85000" lnSpcReduction="10000"/>
+          </a:bodyPr>
+          <a:lstStyle>
+            <a:lvl1pPr marL="228600" indent="-228600" algn="l" defTabSz="914400" rtl="0" eaLnBrk="1" latinLnBrk="0" hangingPunct="1">
+              <a:lnSpc>
+                <a:spcPct val="90000"/>
+              </a:lnSpc>
+              <a:spcBef>
+                <a:spcPts val="1000"/>
+              </a:spcBef>
+              <a:buFont typeface="Arial" panose="020B0604020202020204" pitchFamily="34" charset="0"/>
+              <a:buChar char="•"/>
+              <a:defRPr sz="2800" kern="1200">
+                <a:solidFill>
+                  <a:schemeClr val="tx1"/>
+                </a:solidFill>
+                <a:latin typeface="+mn-lt"/>
+                <a:ea typeface="+mn-ea"/>
+                <a:cs typeface="+mn-cs"/>
+              </a:defRPr>
+            </a:lvl1pPr>
+            <a:lvl2pPr marL="685800" indent="-228600" algn="l" defTabSz="914400" rtl="0" eaLnBrk="1" latinLnBrk="0" hangingPunct="1">
+              <a:lnSpc>
+                <a:spcPct val="90000"/>
+              </a:lnSpc>
+              <a:spcBef>
+                <a:spcPts val="500"/>
+              </a:spcBef>
+              <a:buFont typeface="Arial" panose="020B0604020202020204" pitchFamily="34" charset="0"/>
+              <a:buChar char="•"/>
+              <a:defRPr sz="2400" kern="1200">
+                <a:solidFill>
+                  <a:schemeClr val="tx1"/>
+                </a:solidFill>
+                <a:latin typeface="+mn-lt"/>
+                <a:ea typeface="+mn-ea"/>
+                <a:cs typeface="+mn-cs"/>
+              </a:defRPr>
+            </a:lvl2pPr>
+            <a:lvl3pPr marL="1143000" indent="-228600" algn="l" defTabSz="914400" rtl="0" eaLnBrk="1" latinLnBrk="0" hangingPunct="1">
+              <a:lnSpc>
+                <a:spcPct val="90000"/>
+              </a:lnSpc>
+              <a:spcBef>
+                <a:spcPts val="500"/>
+              </a:spcBef>
+              <a:buFont typeface="Arial" panose="020B0604020202020204" pitchFamily="34" charset="0"/>
+              <a:buChar char="•"/>
+              <a:defRPr sz="2000" kern="1200">
+                <a:solidFill>
+                  <a:schemeClr val="tx1"/>
+                </a:solidFill>
+                <a:latin typeface="+mn-lt"/>
+                <a:ea typeface="+mn-ea"/>
+                <a:cs typeface="+mn-cs"/>
+              </a:defRPr>
+            </a:lvl3pPr>
+            <a:lvl4pPr marL="1600200" indent="-228600" algn="l" defTabSz="914400" rtl="0" eaLnBrk="1" latinLnBrk="0" hangingPunct="1">
+              <a:lnSpc>
+                <a:spcPct val="90000"/>
+              </a:lnSpc>
+              <a:spcBef>
+                <a:spcPts val="500"/>
+              </a:spcBef>
+              <a:buFont typeface="Arial" panose="020B0604020202020204" pitchFamily="34" charset="0"/>
+              <a:buChar char="•"/>
+              <a:defRPr sz="1800" kern="1200">
+                <a:solidFill>
+                  <a:schemeClr val="tx1"/>
+                </a:solidFill>
+                <a:latin typeface="+mn-lt"/>
+                <a:ea typeface="+mn-ea"/>
+                <a:cs typeface="+mn-cs"/>
+              </a:defRPr>
+            </a:lvl4pPr>
+            <a:lvl5pPr marL="2057400" indent="-228600" algn="l" defTabSz="914400" rtl="0" eaLnBrk="1" latinLnBrk="0" hangingPunct="1">
+              <a:lnSpc>
+                <a:spcPct val="90000"/>
+              </a:lnSpc>
+              <a:spcBef>
+                <a:spcPts val="500"/>
+              </a:spcBef>
+              <a:buFont typeface="Arial" panose="020B0604020202020204" pitchFamily="34" charset="0"/>
+              <a:buChar char="•"/>
+              <a:defRPr sz="1800" kern="1200">
+                <a:solidFill>
+                  <a:schemeClr val="tx1"/>
+                </a:solidFill>
+                <a:latin typeface="+mn-lt"/>
+                <a:ea typeface="+mn-ea"/>
+                <a:cs typeface="+mn-cs"/>
+              </a:defRPr>
+            </a:lvl5pPr>
+            <a:lvl6pPr marL="2514600" indent="-228600" algn="l" defTabSz="914400" rtl="0" eaLnBrk="1" latinLnBrk="0" hangingPunct="1">
+              <a:lnSpc>
+                <a:spcPct val="90000"/>
+              </a:lnSpc>
+              <a:spcBef>
+                <a:spcPts val="500"/>
+              </a:spcBef>
+              <a:buFont typeface="Arial" panose="020B0604020202020204" pitchFamily="34" charset="0"/>
+              <a:buChar char="•"/>
+              <a:defRPr sz="1800" kern="1200">
+                <a:solidFill>
+                  <a:schemeClr val="tx1"/>
+                </a:solidFill>
+                <a:latin typeface="+mn-lt"/>
+                <a:ea typeface="+mn-ea"/>
+                <a:cs typeface="+mn-cs"/>
+              </a:defRPr>
+            </a:lvl6pPr>
+            <a:lvl7pPr marL="2971800" indent="-228600" algn="l" defTabSz="914400" rtl="0" eaLnBrk="1" latinLnBrk="0" hangingPunct="1">
+              <a:lnSpc>
+                <a:spcPct val="90000"/>
+              </a:lnSpc>
+              <a:spcBef>
+                <a:spcPts val="500"/>
+              </a:spcBef>
+              <a:buFont typeface="Arial" panose="020B0604020202020204" pitchFamily="34" charset="0"/>
+              <a:buChar char="•"/>
+              <a:defRPr sz="1800" kern="1200">
+                <a:solidFill>
+                  <a:schemeClr val="tx1"/>
+                </a:solidFill>
+                <a:latin typeface="+mn-lt"/>
+                <a:ea typeface="+mn-ea"/>
+                <a:cs typeface="+mn-cs"/>
+              </a:defRPr>
+            </a:lvl7pPr>
+            <a:lvl8pPr marL="3429000" indent="-228600" algn="l" defTabSz="914400" rtl="0" eaLnBrk="1" latinLnBrk="0" hangingPunct="1">
+              <a:lnSpc>
+                <a:spcPct val="90000"/>
+              </a:lnSpc>
+              <a:spcBef>
+                <a:spcPts val="500"/>
+              </a:spcBef>
+              <a:buFont typeface="Arial" panose="020B0604020202020204" pitchFamily="34" charset="0"/>
+              <a:buChar char="•"/>
+              <a:defRPr sz="1800" kern="1200">
+                <a:solidFill>
+                  <a:schemeClr val="tx1"/>
+                </a:solidFill>
+                <a:latin typeface="+mn-lt"/>
+                <a:ea typeface="+mn-ea"/>
+                <a:cs typeface="+mn-cs"/>
+              </a:defRPr>
+            </a:lvl8pPr>
+            <a:lvl9pPr marL="3886200" indent="-228600" algn="l" defTabSz="914400" rtl="0" eaLnBrk="1" latinLnBrk="0" hangingPunct="1">
+              <a:lnSpc>
+                <a:spcPct val="90000"/>
+              </a:lnSpc>
+              <a:spcBef>
+                <a:spcPts val="500"/>
+              </a:spcBef>
+              <a:buFont typeface="Arial" panose="020B0604020202020204" pitchFamily="34" charset="0"/>
+              <a:buChar char="•"/>
+              <a:defRPr sz="1800" kern="1200">
+                <a:solidFill>
+                  <a:schemeClr val="tx1"/>
+                </a:solidFill>
+                <a:latin typeface="+mn-lt"/>
+                <a:ea typeface="+mn-ea"/>
+                <a:cs typeface="+mn-cs"/>
+              </a:defRPr>
+            </a:lvl9pPr>
+          </a:lstStyle>
+          <a:p>
+            <a:pPr marL="0" indent="0">
+              <a:buNone/>
+            </a:pPr>
+            <a:r>
+              <a:rPr lang="en-US" dirty="0"/>
+              <a:t>Screen-Size-Based</a:t>
+            </a:r>
+            <a:r>
+              <a:rPr lang="en-US" b="1" dirty="0"/>
+              <a:t> </a:t>
+            </a:r>
+            <a:r>
+              <a:rPr lang="en-US" altLang="zh-CN" dirty="0"/>
+              <a:t>LOD selection</a:t>
+            </a:r>
+          </a:p>
+        </p:txBody>
+      </p:sp>
+      <p:sp>
+        <p:nvSpPr>
+          <p:cNvPr id="11" name="内容占位符 2">
+            <a:extLst>
+              <a:ext uri="{FF2B5EF4-FFF2-40B4-BE49-F238E27FC236}">
+                <a16:creationId xmlns:a16="http://schemas.microsoft.com/office/drawing/2014/main" id="{7385F1EA-A542-3CF4-3490-CB75144606FE}"/>
+              </a:ext>
+            </a:extLst>
+          </p:cNvPr>
+          <p:cNvSpPr txBox="1">
+            <a:spLocks/>
+          </p:cNvSpPr>
+          <p:nvPr/>
+        </p:nvSpPr>
+        <p:spPr>
+          <a:xfrm>
+            <a:off x="5567570" y="1533456"/>
+            <a:ext cx="4881769" cy="460375"/>
+          </a:xfrm>
+          <a:prstGeom prst="rect">
+            <a:avLst/>
+          </a:prstGeom>
+        </p:spPr>
+        <p:txBody>
+          <a:bodyPr vert="horz" lIns="91440" tIns="45720" rIns="91440" bIns="45720" rtlCol="0">
+            <a:normAutofit lnSpcReduction="10000"/>
+          </a:bodyPr>
+          <a:lstStyle>
+            <a:lvl1pPr marL="228600" indent="-228600" algn="l" defTabSz="914400" rtl="0" eaLnBrk="1" latinLnBrk="0" hangingPunct="1">
+              <a:lnSpc>
+                <a:spcPct val="90000"/>
+              </a:lnSpc>
+              <a:spcBef>
+                <a:spcPts val="1000"/>
+              </a:spcBef>
+              <a:buFont typeface="Arial" panose="020B0604020202020204" pitchFamily="34" charset="0"/>
+              <a:buChar char="•"/>
+              <a:defRPr sz="2800" kern="1200">
+                <a:solidFill>
+                  <a:schemeClr val="tx1"/>
+                </a:solidFill>
+                <a:latin typeface="+mn-lt"/>
+                <a:ea typeface="+mn-ea"/>
+                <a:cs typeface="+mn-cs"/>
+              </a:defRPr>
+            </a:lvl1pPr>
+            <a:lvl2pPr marL="685800" indent="-228600" algn="l" defTabSz="914400" rtl="0" eaLnBrk="1" latinLnBrk="0" hangingPunct="1">
+              <a:lnSpc>
+                <a:spcPct val="90000"/>
+              </a:lnSpc>
+              <a:spcBef>
+                <a:spcPts val="500"/>
+              </a:spcBef>
+              <a:buFont typeface="Arial" panose="020B0604020202020204" pitchFamily="34" charset="0"/>
+              <a:buChar char="•"/>
+              <a:defRPr sz="2400" kern="1200">
+                <a:solidFill>
+                  <a:schemeClr val="tx1"/>
+                </a:solidFill>
+                <a:latin typeface="+mn-lt"/>
+                <a:ea typeface="+mn-ea"/>
+                <a:cs typeface="+mn-cs"/>
+              </a:defRPr>
+            </a:lvl2pPr>
+            <a:lvl3pPr marL="1143000" indent="-228600" algn="l" defTabSz="914400" rtl="0" eaLnBrk="1" latinLnBrk="0" hangingPunct="1">
+              <a:lnSpc>
+                <a:spcPct val="90000"/>
+              </a:lnSpc>
+              <a:spcBef>
+                <a:spcPts val="500"/>
+              </a:spcBef>
+              <a:buFont typeface="Arial" panose="020B0604020202020204" pitchFamily="34" charset="0"/>
+              <a:buChar char="•"/>
+              <a:defRPr sz="2000" kern="1200">
+                <a:solidFill>
+                  <a:schemeClr val="tx1"/>
+                </a:solidFill>
+                <a:latin typeface="+mn-lt"/>
+                <a:ea typeface="+mn-ea"/>
+                <a:cs typeface="+mn-cs"/>
+              </a:defRPr>
+            </a:lvl3pPr>
+            <a:lvl4pPr marL="1600200" indent="-228600" algn="l" defTabSz="914400" rtl="0" eaLnBrk="1" latinLnBrk="0" hangingPunct="1">
+              <a:lnSpc>
+                <a:spcPct val="90000"/>
+              </a:lnSpc>
+              <a:spcBef>
+                <a:spcPts val="500"/>
+              </a:spcBef>
+              <a:buFont typeface="Arial" panose="020B0604020202020204" pitchFamily="34" charset="0"/>
+              <a:buChar char="•"/>
+              <a:defRPr sz="1800" kern="1200">
+                <a:solidFill>
+                  <a:schemeClr val="tx1"/>
+                </a:solidFill>
+                <a:latin typeface="+mn-lt"/>
+                <a:ea typeface="+mn-ea"/>
+                <a:cs typeface="+mn-cs"/>
+              </a:defRPr>
+            </a:lvl4pPr>
+            <a:lvl5pPr marL="2057400" indent="-228600" algn="l" defTabSz="914400" rtl="0" eaLnBrk="1" latinLnBrk="0" hangingPunct="1">
+              <a:lnSpc>
+                <a:spcPct val="90000"/>
+              </a:lnSpc>
+              <a:spcBef>
+                <a:spcPts val="500"/>
+              </a:spcBef>
+              <a:buFont typeface="Arial" panose="020B0604020202020204" pitchFamily="34" charset="0"/>
+              <a:buChar char="•"/>
+              <a:defRPr sz="1800" kern="1200">
+                <a:solidFill>
+                  <a:schemeClr val="tx1"/>
+                </a:solidFill>
+                <a:latin typeface="+mn-lt"/>
+                <a:ea typeface="+mn-ea"/>
+                <a:cs typeface="+mn-cs"/>
+              </a:defRPr>
+            </a:lvl5pPr>
+            <a:lvl6pPr marL="2514600" indent="-228600" algn="l" defTabSz="914400" rtl="0" eaLnBrk="1" latinLnBrk="0" hangingPunct="1">
+              <a:lnSpc>
+                <a:spcPct val="90000"/>
+              </a:lnSpc>
+              <a:spcBef>
+                <a:spcPts val="500"/>
+              </a:spcBef>
+              <a:buFont typeface="Arial" panose="020B0604020202020204" pitchFamily="34" charset="0"/>
+              <a:buChar char="•"/>
+              <a:defRPr sz="1800" kern="1200">
+                <a:solidFill>
+                  <a:schemeClr val="tx1"/>
+                </a:solidFill>
+                <a:latin typeface="+mn-lt"/>
+                <a:ea typeface="+mn-ea"/>
+                <a:cs typeface="+mn-cs"/>
+              </a:defRPr>
+            </a:lvl6pPr>
+            <a:lvl7pPr marL="2971800" indent="-228600" algn="l" defTabSz="914400" rtl="0" eaLnBrk="1" latinLnBrk="0" hangingPunct="1">
+              <a:lnSpc>
+                <a:spcPct val="90000"/>
+              </a:lnSpc>
+              <a:spcBef>
+                <a:spcPts val="500"/>
+              </a:spcBef>
+              <a:buFont typeface="Arial" panose="020B0604020202020204" pitchFamily="34" charset="0"/>
+              <a:buChar char="•"/>
+              <a:defRPr sz="1800" kern="1200">
+                <a:solidFill>
+                  <a:schemeClr val="tx1"/>
+                </a:solidFill>
+                <a:latin typeface="+mn-lt"/>
+                <a:ea typeface="+mn-ea"/>
+                <a:cs typeface="+mn-cs"/>
+              </a:defRPr>
+            </a:lvl7pPr>
+            <a:lvl8pPr marL="3429000" indent="-228600" algn="l" defTabSz="914400" rtl="0" eaLnBrk="1" latinLnBrk="0" hangingPunct="1">
+              <a:lnSpc>
+                <a:spcPct val="90000"/>
+              </a:lnSpc>
+              <a:spcBef>
+                <a:spcPts val="500"/>
+              </a:spcBef>
+              <a:buFont typeface="Arial" panose="020B0604020202020204" pitchFamily="34" charset="0"/>
+              <a:buChar char="•"/>
+              <a:defRPr sz="1800" kern="1200">
+                <a:solidFill>
+                  <a:schemeClr val="tx1"/>
+                </a:solidFill>
+                <a:latin typeface="+mn-lt"/>
+                <a:ea typeface="+mn-ea"/>
+                <a:cs typeface="+mn-cs"/>
+              </a:defRPr>
+            </a:lvl8pPr>
+            <a:lvl9pPr marL="3886200" indent="-228600" algn="l" defTabSz="914400" rtl="0" eaLnBrk="1" latinLnBrk="0" hangingPunct="1">
+              <a:lnSpc>
+                <a:spcPct val="90000"/>
+              </a:lnSpc>
+              <a:spcBef>
+                <a:spcPts val="500"/>
+              </a:spcBef>
+              <a:buFont typeface="Arial" panose="020B0604020202020204" pitchFamily="34" charset="0"/>
+              <a:buChar char="•"/>
+              <a:defRPr sz="1800" kern="1200">
+                <a:solidFill>
+                  <a:schemeClr val="tx1"/>
+                </a:solidFill>
+                <a:latin typeface="+mn-lt"/>
+                <a:ea typeface="+mn-ea"/>
+                <a:cs typeface="+mn-cs"/>
+              </a:defRPr>
+            </a:lvl9pPr>
+          </a:lstStyle>
+          <a:p>
+            <a:pPr marL="0" indent="0">
+              <a:buFont typeface="Arial" panose="020B0604020202020204" pitchFamily="34" charset="0"/>
+              <a:buNone/>
+            </a:pPr>
+            <a:endParaRPr lang="en-US" altLang="zh-CN" dirty="0"/>
+          </a:p>
+          <a:p>
+            <a:pPr marL="0" indent="0">
+              <a:buFont typeface="Arial" panose="020B0604020202020204" pitchFamily="34" charset="0"/>
+              <a:buNone/>
+            </a:pPr>
+            <a:endParaRPr lang="en-US" altLang="zh-CN" dirty="0"/>
+          </a:p>
+          <a:p>
+            <a:pPr marL="0" indent="0">
+              <a:buFont typeface="Arial" panose="020B0604020202020204" pitchFamily="34" charset="0"/>
+              <a:buNone/>
+            </a:pPr>
+            <a:endParaRPr lang="en-US" altLang="zh-CN" dirty="0"/>
+          </a:p>
+        </p:txBody>
+      </p:sp>
+      <p:pic>
+        <p:nvPicPr>
+          <p:cNvPr id="14" name="Picture 13">
+            <a:extLst>
+              <a:ext uri="{FF2B5EF4-FFF2-40B4-BE49-F238E27FC236}">
+                <a16:creationId xmlns:a16="http://schemas.microsoft.com/office/drawing/2014/main" id="{F4D88FF5-D639-D542-A7FB-D976FD47590B}"/>
+              </a:ext>
+            </a:extLst>
+          </p:cNvPr>
+          <p:cNvPicPr>
+            <a:picLocks noChangeAspect="1"/>
+          </p:cNvPicPr>
+          <p:nvPr/>
+        </p:nvPicPr>
+        <p:blipFill>
+          <a:blip r:embed="rId4"/>
+          <a:stretch>
+            <a:fillRect/>
+          </a:stretch>
+        </p:blipFill>
+        <p:spPr>
+          <a:xfrm>
+            <a:off x="382412" y="4746362"/>
+            <a:ext cx="3395870" cy="1843710"/>
+          </a:xfrm>
+          <a:prstGeom prst="rect">
+            <a:avLst/>
+          </a:prstGeom>
+        </p:spPr>
+      </p:pic>
+      <p:sp>
+        <p:nvSpPr>
+          <p:cNvPr id="16" name="内容占位符 2">
+            <a:extLst>
+              <a:ext uri="{FF2B5EF4-FFF2-40B4-BE49-F238E27FC236}">
+                <a16:creationId xmlns:a16="http://schemas.microsoft.com/office/drawing/2014/main" id="{39559C9E-5E24-3455-298C-A4023740F75B}"/>
+              </a:ext>
+            </a:extLst>
+          </p:cNvPr>
+          <p:cNvSpPr txBox="1">
+            <a:spLocks/>
+          </p:cNvSpPr>
+          <p:nvPr/>
+        </p:nvSpPr>
+        <p:spPr>
+          <a:xfrm>
+            <a:off x="5567571" y="1547329"/>
+            <a:ext cx="3531704" cy="510071"/>
+          </a:xfrm>
+          <a:prstGeom prst="rect">
+            <a:avLst/>
+          </a:prstGeom>
+        </p:spPr>
+        <p:txBody>
+          <a:bodyPr vert="horz" lIns="91440" tIns="45720" rIns="91440" bIns="45720" rtlCol="0">
+            <a:normAutofit fontScale="25000" lnSpcReduction="20000"/>
+          </a:bodyPr>
+          <a:lstStyle>
+            <a:lvl1pPr marL="228600" indent="-228600" algn="l" defTabSz="914400" rtl="0" eaLnBrk="1" latinLnBrk="0" hangingPunct="1">
+              <a:lnSpc>
+                <a:spcPct val="90000"/>
+              </a:lnSpc>
+              <a:spcBef>
+                <a:spcPts val="1000"/>
+              </a:spcBef>
+              <a:buFont typeface="Arial" panose="020B0604020202020204" pitchFamily="34" charset="0"/>
+              <a:buChar char="•"/>
+              <a:defRPr sz="2800" kern="1200">
+                <a:solidFill>
+                  <a:schemeClr val="tx1"/>
+                </a:solidFill>
+                <a:latin typeface="+mn-lt"/>
+                <a:ea typeface="+mn-ea"/>
+                <a:cs typeface="+mn-cs"/>
+              </a:defRPr>
+            </a:lvl1pPr>
+            <a:lvl2pPr marL="685800" indent="-228600" algn="l" defTabSz="914400" rtl="0" eaLnBrk="1" latinLnBrk="0" hangingPunct="1">
+              <a:lnSpc>
+                <a:spcPct val="90000"/>
+              </a:lnSpc>
+              <a:spcBef>
+                <a:spcPts val="500"/>
+              </a:spcBef>
+              <a:buFont typeface="Arial" panose="020B0604020202020204" pitchFamily="34" charset="0"/>
+              <a:buChar char="•"/>
+              <a:defRPr sz="2400" kern="1200">
+                <a:solidFill>
+                  <a:schemeClr val="tx1"/>
+                </a:solidFill>
+                <a:latin typeface="+mn-lt"/>
+                <a:ea typeface="+mn-ea"/>
+                <a:cs typeface="+mn-cs"/>
+              </a:defRPr>
+            </a:lvl2pPr>
+            <a:lvl3pPr marL="1143000" indent="-228600" algn="l" defTabSz="914400" rtl="0" eaLnBrk="1" latinLnBrk="0" hangingPunct="1">
+              <a:lnSpc>
+                <a:spcPct val="90000"/>
+              </a:lnSpc>
+              <a:spcBef>
+                <a:spcPts val="500"/>
+              </a:spcBef>
+              <a:buFont typeface="Arial" panose="020B0604020202020204" pitchFamily="34" charset="0"/>
+              <a:buChar char="•"/>
+              <a:defRPr sz="2000" kern="1200">
+                <a:solidFill>
+                  <a:schemeClr val="tx1"/>
+                </a:solidFill>
+                <a:latin typeface="+mn-lt"/>
+                <a:ea typeface="+mn-ea"/>
+                <a:cs typeface="+mn-cs"/>
+              </a:defRPr>
+            </a:lvl3pPr>
+            <a:lvl4pPr marL="1600200" indent="-228600" algn="l" defTabSz="914400" rtl="0" eaLnBrk="1" latinLnBrk="0" hangingPunct="1">
+              <a:lnSpc>
+                <a:spcPct val="90000"/>
+              </a:lnSpc>
+              <a:spcBef>
+                <a:spcPts val="500"/>
+              </a:spcBef>
+              <a:buFont typeface="Arial" panose="020B0604020202020204" pitchFamily="34" charset="0"/>
+              <a:buChar char="•"/>
+              <a:defRPr sz="1800" kern="1200">
+                <a:solidFill>
+                  <a:schemeClr val="tx1"/>
+                </a:solidFill>
+                <a:latin typeface="+mn-lt"/>
+                <a:ea typeface="+mn-ea"/>
+                <a:cs typeface="+mn-cs"/>
+              </a:defRPr>
+            </a:lvl4pPr>
+            <a:lvl5pPr marL="2057400" indent="-228600" algn="l" defTabSz="914400" rtl="0" eaLnBrk="1" latinLnBrk="0" hangingPunct="1">
+              <a:lnSpc>
+                <a:spcPct val="90000"/>
+              </a:lnSpc>
+              <a:spcBef>
+                <a:spcPts val="500"/>
+              </a:spcBef>
+              <a:buFont typeface="Arial" panose="020B0604020202020204" pitchFamily="34" charset="0"/>
+              <a:buChar char="•"/>
+              <a:defRPr sz="1800" kern="1200">
+                <a:solidFill>
+                  <a:schemeClr val="tx1"/>
+                </a:solidFill>
+                <a:latin typeface="+mn-lt"/>
+                <a:ea typeface="+mn-ea"/>
+                <a:cs typeface="+mn-cs"/>
+              </a:defRPr>
+            </a:lvl5pPr>
+            <a:lvl6pPr marL="2514600" indent="-228600" algn="l" defTabSz="914400" rtl="0" eaLnBrk="1" latinLnBrk="0" hangingPunct="1">
+              <a:lnSpc>
+                <a:spcPct val="90000"/>
+              </a:lnSpc>
+              <a:spcBef>
+                <a:spcPts val="500"/>
+              </a:spcBef>
+              <a:buFont typeface="Arial" panose="020B0604020202020204" pitchFamily="34" charset="0"/>
+              <a:buChar char="•"/>
+              <a:defRPr sz="1800" kern="1200">
+                <a:solidFill>
+                  <a:schemeClr val="tx1"/>
+                </a:solidFill>
+                <a:latin typeface="+mn-lt"/>
+                <a:ea typeface="+mn-ea"/>
+                <a:cs typeface="+mn-cs"/>
+              </a:defRPr>
+            </a:lvl6pPr>
+            <a:lvl7pPr marL="2971800" indent="-228600" algn="l" defTabSz="914400" rtl="0" eaLnBrk="1" latinLnBrk="0" hangingPunct="1">
+              <a:lnSpc>
+                <a:spcPct val="90000"/>
+              </a:lnSpc>
+              <a:spcBef>
+                <a:spcPts val="500"/>
+              </a:spcBef>
+              <a:buFont typeface="Arial" panose="020B0604020202020204" pitchFamily="34" charset="0"/>
+              <a:buChar char="•"/>
+              <a:defRPr sz="1800" kern="1200">
+                <a:solidFill>
+                  <a:schemeClr val="tx1"/>
+                </a:solidFill>
+                <a:latin typeface="+mn-lt"/>
+                <a:ea typeface="+mn-ea"/>
+                <a:cs typeface="+mn-cs"/>
+              </a:defRPr>
+            </a:lvl7pPr>
+            <a:lvl8pPr marL="3429000" indent="-228600" algn="l" defTabSz="914400" rtl="0" eaLnBrk="1" latinLnBrk="0" hangingPunct="1">
+              <a:lnSpc>
+                <a:spcPct val="90000"/>
+              </a:lnSpc>
+              <a:spcBef>
+                <a:spcPts val="500"/>
+              </a:spcBef>
+              <a:buFont typeface="Arial" panose="020B0604020202020204" pitchFamily="34" charset="0"/>
+              <a:buChar char="•"/>
+              <a:defRPr sz="1800" kern="1200">
+                <a:solidFill>
+                  <a:schemeClr val="tx1"/>
+                </a:solidFill>
+                <a:latin typeface="+mn-lt"/>
+                <a:ea typeface="+mn-ea"/>
+                <a:cs typeface="+mn-cs"/>
+              </a:defRPr>
+            </a:lvl8pPr>
+            <a:lvl9pPr marL="3886200" indent="-228600" algn="l" defTabSz="914400" rtl="0" eaLnBrk="1" latinLnBrk="0" hangingPunct="1">
+              <a:lnSpc>
+                <a:spcPct val="90000"/>
+              </a:lnSpc>
+              <a:spcBef>
+                <a:spcPts val="500"/>
+              </a:spcBef>
+              <a:buFont typeface="Arial" panose="020B0604020202020204" pitchFamily="34" charset="0"/>
+              <a:buChar char="•"/>
+              <a:defRPr sz="1800" kern="1200">
+                <a:solidFill>
+                  <a:schemeClr val="tx1"/>
+                </a:solidFill>
+                <a:latin typeface="+mn-lt"/>
+                <a:ea typeface="+mn-ea"/>
+                <a:cs typeface="+mn-cs"/>
+              </a:defRPr>
+            </a:lvl9pPr>
+          </a:lstStyle>
+          <a:p>
+            <a:pPr marL="0" indent="0">
+              <a:buNone/>
+            </a:pPr>
+            <a:r>
+              <a:rPr lang="en-US" sz="8600" dirty="0"/>
+              <a:t>Model LOD preprocessing</a:t>
+            </a:r>
+          </a:p>
+          <a:p>
+            <a:pPr marL="0" indent="0">
+              <a:buNone/>
+            </a:pPr>
+            <a:endParaRPr lang="en-US" altLang="zh-CN" dirty="0"/>
+          </a:p>
+        </p:txBody>
+      </p:sp>
+      <p:sp>
+        <p:nvSpPr>
+          <p:cNvPr id="18" name="内容占位符 2">
+            <a:extLst>
+              <a:ext uri="{FF2B5EF4-FFF2-40B4-BE49-F238E27FC236}">
+                <a16:creationId xmlns:a16="http://schemas.microsoft.com/office/drawing/2014/main" id="{A5429B54-E4D7-4ABD-D755-C303090F161D}"/>
+              </a:ext>
+            </a:extLst>
+          </p:cNvPr>
+          <p:cNvSpPr txBox="1">
+            <a:spLocks/>
+          </p:cNvSpPr>
+          <p:nvPr/>
+        </p:nvSpPr>
+        <p:spPr>
+          <a:xfrm>
+            <a:off x="5567570" y="1993831"/>
+            <a:ext cx="6242018" cy="1798845"/>
+          </a:xfrm>
+          <a:prstGeom prst="rect">
+            <a:avLst/>
+          </a:prstGeom>
+        </p:spPr>
+        <p:txBody>
+          <a:bodyPr vert="horz" lIns="91440" tIns="45720" rIns="91440" bIns="45720" rtlCol="0">
+            <a:normAutofit fontScale="62500" lnSpcReduction="20000"/>
+          </a:bodyPr>
+          <a:lstStyle>
+            <a:lvl1pPr marL="228600" indent="-228600" algn="l" defTabSz="914400" rtl="0" eaLnBrk="1" latinLnBrk="0" hangingPunct="1">
+              <a:lnSpc>
+                <a:spcPct val="90000"/>
+              </a:lnSpc>
+              <a:spcBef>
+                <a:spcPts val="1000"/>
+              </a:spcBef>
+              <a:buFont typeface="Arial" panose="020B0604020202020204" pitchFamily="34" charset="0"/>
+              <a:buChar char="•"/>
+              <a:defRPr sz="2800" kern="1200">
+                <a:solidFill>
+                  <a:schemeClr val="tx1"/>
+                </a:solidFill>
+                <a:latin typeface="+mn-lt"/>
+                <a:ea typeface="+mn-ea"/>
+                <a:cs typeface="+mn-cs"/>
+              </a:defRPr>
+            </a:lvl1pPr>
+            <a:lvl2pPr marL="685800" indent="-228600" algn="l" defTabSz="914400" rtl="0" eaLnBrk="1" latinLnBrk="0" hangingPunct="1">
+              <a:lnSpc>
+                <a:spcPct val="90000"/>
+              </a:lnSpc>
+              <a:spcBef>
+                <a:spcPts val="500"/>
+              </a:spcBef>
+              <a:buFont typeface="Arial" panose="020B0604020202020204" pitchFamily="34" charset="0"/>
+              <a:buChar char="•"/>
+              <a:defRPr sz="2400" kern="1200">
+                <a:solidFill>
+                  <a:schemeClr val="tx1"/>
+                </a:solidFill>
+                <a:latin typeface="+mn-lt"/>
+                <a:ea typeface="+mn-ea"/>
+                <a:cs typeface="+mn-cs"/>
+              </a:defRPr>
+            </a:lvl2pPr>
+            <a:lvl3pPr marL="1143000" indent="-228600" algn="l" defTabSz="914400" rtl="0" eaLnBrk="1" latinLnBrk="0" hangingPunct="1">
+              <a:lnSpc>
+                <a:spcPct val="90000"/>
+              </a:lnSpc>
+              <a:spcBef>
+                <a:spcPts val="500"/>
+              </a:spcBef>
+              <a:buFont typeface="Arial" panose="020B0604020202020204" pitchFamily="34" charset="0"/>
+              <a:buChar char="•"/>
+              <a:defRPr sz="2000" kern="1200">
+                <a:solidFill>
+                  <a:schemeClr val="tx1"/>
+                </a:solidFill>
+                <a:latin typeface="+mn-lt"/>
+                <a:ea typeface="+mn-ea"/>
+                <a:cs typeface="+mn-cs"/>
+              </a:defRPr>
+            </a:lvl3pPr>
+            <a:lvl4pPr marL="1600200" indent="-228600" algn="l" defTabSz="914400" rtl="0" eaLnBrk="1" latinLnBrk="0" hangingPunct="1">
+              <a:lnSpc>
+                <a:spcPct val="90000"/>
+              </a:lnSpc>
+              <a:spcBef>
+                <a:spcPts val="500"/>
+              </a:spcBef>
+              <a:buFont typeface="Arial" panose="020B0604020202020204" pitchFamily="34" charset="0"/>
+              <a:buChar char="•"/>
+              <a:defRPr sz="1800" kern="1200">
+                <a:solidFill>
+                  <a:schemeClr val="tx1"/>
+                </a:solidFill>
+                <a:latin typeface="+mn-lt"/>
+                <a:ea typeface="+mn-ea"/>
+                <a:cs typeface="+mn-cs"/>
+              </a:defRPr>
+            </a:lvl4pPr>
+            <a:lvl5pPr marL="2057400" indent="-228600" algn="l" defTabSz="914400" rtl="0" eaLnBrk="1" latinLnBrk="0" hangingPunct="1">
+              <a:lnSpc>
+                <a:spcPct val="90000"/>
+              </a:lnSpc>
+              <a:spcBef>
+                <a:spcPts val="500"/>
+              </a:spcBef>
+              <a:buFont typeface="Arial" panose="020B0604020202020204" pitchFamily="34" charset="0"/>
+              <a:buChar char="•"/>
+              <a:defRPr sz="1800" kern="1200">
+                <a:solidFill>
+                  <a:schemeClr val="tx1"/>
+                </a:solidFill>
+                <a:latin typeface="+mn-lt"/>
+                <a:ea typeface="+mn-ea"/>
+                <a:cs typeface="+mn-cs"/>
+              </a:defRPr>
+            </a:lvl5pPr>
+            <a:lvl6pPr marL="2514600" indent="-228600" algn="l" defTabSz="914400" rtl="0" eaLnBrk="1" latinLnBrk="0" hangingPunct="1">
+              <a:lnSpc>
+                <a:spcPct val="90000"/>
+              </a:lnSpc>
+              <a:spcBef>
+                <a:spcPts val="500"/>
+              </a:spcBef>
+              <a:buFont typeface="Arial" panose="020B0604020202020204" pitchFamily="34" charset="0"/>
+              <a:buChar char="•"/>
+              <a:defRPr sz="1800" kern="1200">
+                <a:solidFill>
+                  <a:schemeClr val="tx1"/>
+                </a:solidFill>
+                <a:latin typeface="+mn-lt"/>
+                <a:ea typeface="+mn-ea"/>
+                <a:cs typeface="+mn-cs"/>
+              </a:defRPr>
+            </a:lvl6pPr>
+            <a:lvl7pPr marL="2971800" indent="-228600" algn="l" defTabSz="914400" rtl="0" eaLnBrk="1" latinLnBrk="0" hangingPunct="1">
+              <a:lnSpc>
+                <a:spcPct val="90000"/>
+              </a:lnSpc>
+              <a:spcBef>
+                <a:spcPts val="500"/>
+              </a:spcBef>
+              <a:buFont typeface="Arial" panose="020B0604020202020204" pitchFamily="34" charset="0"/>
+              <a:buChar char="•"/>
+              <a:defRPr sz="1800" kern="1200">
+                <a:solidFill>
+                  <a:schemeClr val="tx1"/>
+                </a:solidFill>
+                <a:latin typeface="+mn-lt"/>
+                <a:ea typeface="+mn-ea"/>
+                <a:cs typeface="+mn-cs"/>
+              </a:defRPr>
+            </a:lvl7pPr>
+            <a:lvl8pPr marL="3429000" indent="-228600" algn="l" defTabSz="914400" rtl="0" eaLnBrk="1" latinLnBrk="0" hangingPunct="1">
+              <a:lnSpc>
+                <a:spcPct val="90000"/>
+              </a:lnSpc>
+              <a:spcBef>
+                <a:spcPts val="500"/>
+              </a:spcBef>
+              <a:buFont typeface="Arial" panose="020B0604020202020204" pitchFamily="34" charset="0"/>
+              <a:buChar char="•"/>
+              <a:defRPr sz="1800" kern="1200">
+                <a:solidFill>
+                  <a:schemeClr val="tx1"/>
+                </a:solidFill>
+                <a:latin typeface="+mn-lt"/>
+                <a:ea typeface="+mn-ea"/>
+                <a:cs typeface="+mn-cs"/>
+              </a:defRPr>
+            </a:lvl8pPr>
+            <a:lvl9pPr marL="3886200" indent="-228600" algn="l" defTabSz="914400" rtl="0" eaLnBrk="1" latinLnBrk="0" hangingPunct="1">
+              <a:lnSpc>
+                <a:spcPct val="90000"/>
+              </a:lnSpc>
+              <a:spcBef>
+                <a:spcPts val="500"/>
+              </a:spcBef>
+              <a:buFont typeface="Arial" panose="020B0604020202020204" pitchFamily="34" charset="0"/>
+              <a:buChar char="•"/>
+              <a:defRPr sz="1800" kern="1200">
+                <a:solidFill>
+                  <a:schemeClr val="tx1"/>
+                </a:solidFill>
+                <a:latin typeface="+mn-lt"/>
+                <a:ea typeface="+mn-ea"/>
+                <a:cs typeface="+mn-cs"/>
+              </a:defRPr>
+            </a:lvl9pPr>
+          </a:lstStyle>
+          <a:p>
+            <a:r>
+              <a:rPr lang="en-US" dirty="0"/>
+              <a:t>LOD-1- original</a:t>
+            </a:r>
+            <a:endParaRPr lang="en-US" sz="8800" dirty="0"/>
+          </a:p>
+          <a:p>
+            <a:r>
+              <a:rPr lang="en-US" dirty="0"/>
+              <a:t>LOD0 -Material consolidation</a:t>
+            </a:r>
+            <a:endParaRPr lang="en-US" sz="8800" dirty="0"/>
+          </a:p>
+          <a:p>
+            <a:r>
+              <a:rPr lang="en-US" dirty="0"/>
+              <a:t>LOD1 - trunk decimate modifier+ Leaf card reduction + Scale for silhouette compensation</a:t>
+            </a:r>
+            <a:endParaRPr lang="en-US" sz="8800" dirty="0"/>
+          </a:p>
+          <a:p>
+            <a:r>
+              <a:rPr lang="en-US" dirty="0"/>
+              <a:t>LOD2 -LOD1 with higher intensity</a:t>
+            </a:r>
+            <a:endParaRPr lang="en-US" sz="8800" dirty="0"/>
+          </a:p>
+          <a:p>
+            <a:r>
+              <a:rPr lang="en-US" dirty="0"/>
+              <a:t>LOD3 –Crossing billboard imposter</a:t>
+            </a:r>
+            <a:endParaRPr lang="en-US" sz="8800" dirty="0"/>
+          </a:p>
+          <a:p>
+            <a:pPr marL="0" indent="0">
+              <a:buNone/>
+            </a:pPr>
+            <a:endParaRPr lang="en-US" sz="8600" dirty="0"/>
+          </a:p>
+          <a:p>
+            <a:pPr marL="0" indent="0">
+              <a:buNone/>
+            </a:pPr>
+            <a:endParaRPr lang="en-US" altLang="zh-CN" dirty="0"/>
+          </a:p>
+        </p:txBody>
+      </p:sp>
+      <p:pic>
+        <p:nvPicPr>
+          <p:cNvPr id="20" name="Picture 19">
+            <a:extLst>
+              <a:ext uri="{FF2B5EF4-FFF2-40B4-BE49-F238E27FC236}">
+                <a16:creationId xmlns:a16="http://schemas.microsoft.com/office/drawing/2014/main" id="{7D05E34A-723E-FADB-4FB0-EBC9CBFA457D}"/>
+              </a:ext>
+            </a:extLst>
+          </p:cNvPr>
+          <p:cNvPicPr>
+            <a:picLocks noChangeAspect="1"/>
+          </p:cNvPicPr>
+          <p:nvPr/>
+        </p:nvPicPr>
+        <p:blipFill>
+          <a:blip r:embed="rId5"/>
+          <a:stretch>
+            <a:fillRect/>
+          </a:stretch>
+        </p:blipFill>
+        <p:spPr>
+          <a:xfrm>
+            <a:off x="5489468" y="3792676"/>
+            <a:ext cx="1928185" cy="882010"/>
+          </a:xfrm>
+          <a:prstGeom prst="rect">
+            <a:avLst/>
+          </a:prstGeom>
+        </p:spPr>
+      </p:pic>
+      <p:sp>
+        <p:nvSpPr>
+          <p:cNvPr id="22" name="内容占位符 2">
+            <a:extLst>
+              <a:ext uri="{FF2B5EF4-FFF2-40B4-BE49-F238E27FC236}">
+                <a16:creationId xmlns:a16="http://schemas.microsoft.com/office/drawing/2014/main" id="{9E8541F7-321F-8AC6-847E-F35247FFA7CB}"/>
+              </a:ext>
+            </a:extLst>
+          </p:cNvPr>
+          <p:cNvSpPr txBox="1">
+            <a:spLocks/>
+          </p:cNvSpPr>
+          <p:nvPr/>
+        </p:nvSpPr>
+        <p:spPr>
+          <a:xfrm>
+            <a:off x="5342283" y="4865342"/>
+            <a:ext cx="3531704" cy="510071"/>
+          </a:xfrm>
+          <a:prstGeom prst="rect">
+            <a:avLst/>
+          </a:prstGeom>
+        </p:spPr>
+        <p:txBody>
+          <a:bodyPr vert="horz" lIns="91440" tIns="45720" rIns="91440" bIns="45720" rtlCol="0">
+            <a:normAutofit fontScale="40000" lnSpcReduction="20000"/>
+          </a:bodyPr>
+          <a:lstStyle>
+            <a:lvl1pPr marL="228600" indent="-228600" algn="l" defTabSz="914400" rtl="0" eaLnBrk="1" latinLnBrk="0" hangingPunct="1">
+              <a:lnSpc>
+                <a:spcPct val="90000"/>
+              </a:lnSpc>
+              <a:spcBef>
+                <a:spcPts val="1000"/>
+              </a:spcBef>
+              <a:buFont typeface="Arial" panose="020B0604020202020204" pitchFamily="34" charset="0"/>
+              <a:buChar char="•"/>
+              <a:defRPr sz="2800" kern="1200">
+                <a:solidFill>
+                  <a:schemeClr val="tx1"/>
+                </a:solidFill>
+                <a:latin typeface="+mn-lt"/>
+                <a:ea typeface="+mn-ea"/>
+                <a:cs typeface="+mn-cs"/>
+              </a:defRPr>
+            </a:lvl1pPr>
+            <a:lvl2pPr marL="685800" indent="-228600" algn="l" defTabSz="914400" rtl="0" eaLnBrk="1" latinLnBrk="0" hangingPunct="1">
+              <a:lnSpc>
+                <a:spcPct val="90000"/>
+              </a:lnSpc>
+              <a:spcBef>
+                <a:spcPts val="500"/>
+              </a:spcBef>
+              <a:buFont typeface="Arial" panose="020B0604020202020204" pitchFamily="34" charset="0"/>
+              <a:buChar char="•"/>
+              <a:defRPr sz="2400" kern="1200">
+                <a:solidFill>
+                  <a:schemeClr val="tx1"/>
+                </a:solidFill>
+                <a:latin typeface="+mn-lt"/>
+                <a:ea typeface="+mn-ea"/>
+                <a:cs typeface="+mn-cs"/>
+              </a:defRPr>
+            </a:lvl2pPr>
+            <a:lvl3pPr marL="1143000" indent="-228600" algn="l" defTabSz="914400" rtl="0" eaLnBrk="1" latinLnBrk="0" hangingPunct="1">
+              <a:lnSpc>
+                <a:spcPct val="90000"/>
+              </a:lnSpc>
+              <a:spcBef>
+                <a:spcPts val="500"/>
+              </a:spcBef>
+              <a:buFont typeface="Arial" panose="020B0604020202020204" pitchFamily="34" charset="0"/>
+              <a:buChar char="•"/>
+              <a:defRPr sz="2000" kern="1200">
+                <a:solidFill>
+                  <a:schemeClr val="tx1"/>
+                </a:solidFill>
+                <a:latin typeface="+mn-lt"/>
+                <a:ea typeface="+mn-ea"/>
+                <a:cs typeface="+mn-cs"/>
+              </a:defRPr>
+            </a:lvl3pPr>
+            <a:lvl4pPr marL="1600200" indent="-228600" algn="l" defTabSz="914400" rtl="0" eaLnBrk="1" latinLnBrk="0" hangingPunct="1">
+              <a:lnSpc>
+                <a:spcPct val="90000"/>
+              </a:lnSpc>
+              <a:spcBef>
+                <a:spcPts val="500"/>
+              </a:spcBef>
+              <a:buFont typeface="Arial" panose="020B0604020202020204" pitchFamily="34" charset="0"/>
+              <a:buChar char="•"/>
+              <a:defRPr sz="1800" kern="1200">
+                <a:solidFill>
+                  <a:schemeClr val="tx1"/>
+                </a:solidFill>
+                <a:latin typeface="+mn-lt"/>
+                <a:ea typeface="+mn-ea"/>
+                <a:cs typeface="+mn-cs"/>
+              </a:defRPr>
+            </a:lvl4pPr>
+            <a:lvl5pPr marL="2057400" indent="-228600" algn="l" defTabSz="914400" rtl="0" eaLnBrk="1" latinLnBrk="0" hangingPunct="1">
+              <a:lnSpc>
+                <a:spcPct val="90000"/>
+              </a:lnSpc>
+              <a:spcBef>
+                <a:spcPts val="500"/>
+              </a:spcBef>
+              <a:buFont typeface="Arial" panose="020B0604020202020204" pitchFamily="34" charset="0"/>
+              <a:buChar char="•"/>
+              <a:defRPr sz="1800" kern="1200">
+                <a:solidFill>
+                  <a:schemeClr val="tx1"/>
+                </a:solidFill>
+                <a:latin typeface="+mn-lt"/>
+                <a:ea typeface="+mn-ea"/>
+                <a:cs typeface="+mn-cs"/>
+              </a:defRPr>
+            </a:lvl5pPr>
+            <a:lvl6pPr marL="2514600" indent="-228600" algn="l" defTabSz="914400" rtl="0" eaLnBrk="1" latinLnBrk="0" hangingPunct="1">
+              <a:lnSpc>
+                <a:spcPct val="90000"/>
+              </a:lnSpc>
+              <a:spcBef>
+                <a:spcPts val="500"/>
+              </a:spcBef>
+              <a:buFont typeface="Arial" panose="020B0604020202020204" pitchFamily="34" charset="0"/>
+              <a:buChar char="•"/>
+              <a:defRPr sz="1800" kern="1200">
+                <a:solidFill>
+                  <a:schemeClr val="tx1"/>
+                </a:solidFill>
+                <a:latin typeface="+mn-lt"/>
+                <a:ea typeface="+mn-ea"/>
+                <a:cs typeface="+mn-cs"/>
+              </a:defRPr>
+            </a:lvl6pPr>
+            <a:lvl7pPr marL="2971800" indent="-228600" algn="l" defTabSz="914400" rtl="0" eaLnBrk="1" latinLnBrk="0" hangingPunct="1">
+              <a:lnSpc>
+                <a:spcPct val="90000"/>
+              </a:lnSpc>
+              <a:spcBef>
+                <a:spcPts val="500"/>
+              </a:spcBef>
+              <a:buFont typeface="Arial" panose="020B0604020202020204" pitchFamily="34" charset="0"/>
+              <a:buChar char="•"/>
+              <a:defRPr sz="1800" kern="1200">
+                <a:solidFill>
+                  <a:schemeClr val="tx1"/>
+                </a:solidFill>
+                <a:latin typeface="+mn-lt"/>
+                <a:ea typeface="+mn-ea"/>
+                <a:cs typeface="+mn-cs"/>
+              </a:defRPr>
+            </a:lvl7pPr>
+            <a:lvl8pPr marL="3429000" indent="-228600" algn="l" defTabSz="914400" rtl="0" eaLnBrk="1" latinLnBrk="0" hangingPunct="1">
+              <a:lnSpc>
+                <a:spcPct val="90000"/>
+              </a:lnSpc>
+              <a:spcBef>
+                <a:spcPts val="500"/>
+              </a:spcBef>
+              <a:buFont typeface="Arial" panose="020B0604020202020204" pitchFamily="34" charset="0"/>
+              <a:buChar char="•"/>
+              <a:defRPr sz="1800" kern="1200">
+                <a:solidFill>
+                  <a:schemeClr val="tx1"/>
+                </a:solidFill>
+                <a:latin typeface="+mn-lt"/>
+                <a:ea typeface="+mn-ea"/>
+                <a:cs typeface="+mn-cs"/>
+              </a:defRPr>
+            </a:lvl8pPr>
+            <a:lvl9pPr marL="3886200" indent="-228600" algn="l" defTabSz="914400" rtl="0" eaLnBrk="1" latinLnBrk="0" hangingPunct="1">
+              <a:lnSpc>
+                <a:spcPct val="90000"/>
+              </a:lnSpc>
+              <a:spcBef>
+                <a:spcPts val="500"/>
+              </a:spcBef>
+              <a:buFont typeface="Arial" panose="020B0604020202020204" pitchFamily="34" charset="0"/>
+              <a:buChar char="•"/>
+              <a:defRPr sz="1800" kern="1200">
+                <a:solidFill>
+                  <a:schemeClr val="tx1"/>
+                </a:solidFill>
+                <a:latin typeface="+mn-lt"/>
+                <a:ea typeface="+mn-ea"/>
+                <a:cs typeface="+mn-cs"/>
+              </a:defRPr>
+            </a:lvl9pPr>
+          </a:lstStyle>
+          <a:p>
+            <a:pPr marL="0" indent="0">
+              <a:buNone/>
+            </a:pPr>
+            <a:r>
+              <a:rPr lang="en-US" sz="8600" dirty="0"/>
+              <a:t>FURTHER PLAN:</a:t>
+            </a:r>
+          </a:p>
+          <a:p>
+            <a:pPr marL="0" indent="0">
+              <a:buNone/>
+            </a:pPr>
+            <a:endParaRPr lang="en-US" sz="8600" dirty="0"/>
+          </a:p>
+          <a:p>
+            <a:pPr marL="0" indent="0">
+              <a:buNone/>
+            </a:pPr>
+            <a:endParaRPr lang="en-US" altLang="zh-CN" dirty="0"/>
+          </a:p>
+        </p:txBody>
+      </p:sp>
+      <p:sp>
+        <p:nvSpPr>
+          <p:cNvPr id="24" name="内容占位符 2">
+            <a:extLst>
+              <a:ext uri="{FF2B5EF4-FFF2-40B4-BE49-F238E27FC236}">
+                <a16:creationId xmlns:a16="http://schemas.microsoft.com/office/drawing/2014/main" id="{AA80C8C9-13B2-2C87-1E0E-6AFF692CFAF3}"/>
+              </a:ext>
+            </a:extLst>
+          </p:cNvPr>
+          <p:cNvSpPr txBox="1">
+            <a:spLocks/>
+          </p:cNvSpPr>
+          <p:nvPr/>
+        </p:nvSpPr>
+        <p:spPr>
+          <a:xfrm>
+            <a:off x="5342282" y="5385257"/>
+            <a:ext cx="5560944" cy="1107618"/>
+          </a:xfrm>
+          <a:prstGeom prst="rect">
+            <a:avLst/>
+          </a:prstGeom>
+        </p:spPr>
+        <p:txBody>
+          <a:bodyPr vert="horz" lIns="91440" tIns="45720" rIns="91440" bIns="45720" rtlCol="0">
+            <a:normAutofit fontScale="25000" lnSpcReduction="20000"/>
+          </a:bodyPr>
+          <a:lstStyle>
+            <a:lvl1pPr marL="228600" indent="-228600" algn="l" defTabSz="914400" rtl="0" eaLnBrk="1" latinLnBrk="0" hangingPunct="1">
+              <a:lnSpc>
+                <a:spcPct val="90000"/>
+              </a:lnSpc>
+              <a:spcBef>
+                <a:spcPts val="1000"/>
+              </a:spcBef>
+              <a:buFont typeface="Arial" panose="020B0604020202020204" pitchFamily="34" charset="0"/>
+              <a:buChar char="•"/>
+              <a:defRPr sz="2800" kern="1200">
+                <a:solidFill>
+                  <a:schemeClr val="tx1"/>
+                </a:solidFill>
+                <a:latin typeface="+mn-lt"/>
+                <a:ea typeface="+mn-ea"/>
+                <a:cs typeface="+mn-cs"/>
+              </a:defRPr>
+            </a:lvl1pPr>
+            <a:lvl2pPr marL="685800" indent="-228600" algn="l" defTabSz="914400" rtl="0" eaLnBrk="1" latinLnBrk="0" hangingPunct="1">
+              <a:lnSpc>
+                <a:spcPct val="90000"/>
+              </a:lnSpc>
+              <a:spcBef>
+                <a:spcPts val="500"/>
+              </a:spcBef>
+              <a:buFont typeface="Arial" panose="020B0604020202020204" pitchFamily="34" charset="0"/>
+              <a:buChar char="•"/>
+              <a:defRPr sz="2400" kern="1200">
+                <a:solidFill>
+                  <a:schemeClr val="tx1"/>
+                </a:solidFill>
+                <a:latin typeface="+mn-lt"/>
+                <a:ea typeface="+mn-ea"/>
+                <a:cs typeface="+mn-cs"/>
+              </a:defRPr>
+            </a:lvl2pPr>
+            <a:lvl3pPr marL="1143000" indent="-228600" algn="l" defTabSz="914400" rtl="0" eaLnBrk="1" latinLnBrk="0" hangingPunct="1">
+              <a:lnSpc>
+                <a:spcPct val="90000"/>
+              </a:lnSpc>
+              <a:spcBef>
+                <a:spcPts val="500"/>
+              </a:spcBef>
+              <a:buFont typeface="Arial" panose="020B0604020202020204" pitchFamily="34" charset="0"/>
+              <a:buChar char="•"/>
+              <a:defRPr sz="2000" kern="1200">
+                <a:solidFill>
+                  <a:schemeClr val="tx1"/>
+                </a:solidFill>
+                <a:latin typeface="+mn-lt"/>
+                <a:ea typeface="+mn-ea"/>
+                <a:cs typeface="+mn-cs"/>
+              </a:defRPr>
+            </a:lvl3pPr>
+            <a:lvl4pPr marL="1600200" indent="-228600" algn="l" defTabSz="914400" rtl="0" eaLnBrk="1" latinLnBrk="0" hangingPunct="1">
+              <a:lnSpc>
+                <a:spcPct val="90000"/>
+              </a:lnSpc>
+              <a:spcBef>
+                <a:spcPts val="500"/>
+              </a:spcBef>
+              <a:buFont typeface="Arial" panose="020B0604020202020204" pitchFamily="34" charset="0"/>
+              <a:buChar char="•"/>
+              <a:defRPr sz="1800" kern="1200">
+                <a:solidFill>
+                  <a:schemeClr val="tx1"/>
+                </a:solidFill>
+                <a:latin typeface="+mn-lt"/>
+                <a:ea typeface="+mn-ea"/>
+                <a:cs typeface="+mn-cs"/>
+              </a:defRPr>
+            </a:lvl4pPr>
+            <a:lvl5pPr marL="2057400" indent="-228600" algn="l" defTabSz="914400" rtl="0" eaLnBrk="1" latinLnBrk="0" hangingPunct="1">
+              <a:lnSpc>
+                <a:spcPct val="90000"/>
+              </a:lnSpc>
+              <a:spcBef>
+                <a:spcPts val="500"/>
+              </a:spcBef>
+              <a:buFont typeface="Arial" panose="020B0604020202020204" pitchFamily="34" charset="0"/>
+              <a:buChar char="•"/>
+              <a:defRPr sz="1800" kern="1200">
+                <a:solidFill>
+                  <a:schemeClr val="tx1"/>
+                </a:solidFill>
+                <a:latin typeface="+mn-lt"/>
+                <a:ea typeface="+mn-ea"/>
+                <a:cs typeface="+mn-cs"/>
+              </a:defRPr>
+            </a:lvl5pPr>
+            <a:lvl6pPr marL="2514600" indent="-228600" algn="l" defTabSz="914400" rtl="0" eaLnBrk="1" latinLnBrk="0" hangingPunct="1">
+              <a:lnSpc>
+                <a:spcPct val="90000"/>
+              </a:lnSpc>
+              <a:spcBef>
+                <a:spcPts val="500"/>
+              </a:spcBef>
+              <a:buFont typeface="Arial" panose="020B0604020202020204" pitchFamily="34" charset="0"/>
+              <a:buChar char="•"/>
+              <a:defRPr sz="1800" kern="1200">
+                <a:solidFill>
+                  <a:schemeClr val="tx1"/>
+                </a:solidFill>
+                <a:latin typeface="+mn-lt"/>
+                <a:ea typeface="+mn-ea"/>
+                <a:cs typeface="+mn-cs"/>
+              </a:defRPr>
+            </a:lvl6pPr>
+            <a:lvl7pPr marL="2971800" indent="-228600" algn="l" defTabSz="914400" rtl="0" eaLnBrk="1" latinLnBrk="0" hangingPunct="1">
+              <a:lnSpc>
+                <a:spcPct val="90000"/>
+              </a:lnSpc>
+              <a:spcBef>
+                <a:spcPts val="500"/>
+              </a:spcBef>
+              <a:buFont typeface="Arial" panose="020B0604020202020204" pitchFamily="34" charset="0"/>
+              <a:buChar char="•"/>
+              <a:defRPr sz="1800" kern="1200">
+                <a:solidFill>
+                  <a:schemeClr val="tx1"/>
+                </a:solidFill>
+                <a:latin typeface="+mn-lt"/>
+                <a:ea typeface="+mn-ea"/>
+                <a:cs typeface="+mn-cs"/>
+              </a:defRPr>
+            </a:lvl7pPr>
+            <a:lvl8pPr marL="3429000" indent="-228600" algn="l" defTabSz="914400" rtl="0" eaLnBrk="1" latinLnBrk="0" hangingPunct="1">
+              <a:lnSpc>
+                <a:spcPct val="90000"/>
+              </a:lnSpc>
+              <a:spcBef>
+                <a:spcPts val="500"/>
+              </a:spcBef>
+              <a:buFont typeface="Arial" panose="020B0604020202020204" pitchFamily="34" charset="0"/>
+              <a:buChar char="•"/>
+              <a:defRPr sz="1800" kern="1200">
+                <a:solidFill>
+                  <a:schemeClr val="tx1"/>
+                </a:solidFill>
+                <a:latin typeface="+mn-lt"/>
+                <a:ea typeface="+mn-ea"/>
+                <a:cs typeface="+mn-cs"/>
+              </a:defRPr>
+            </a:lvl8pPr>
+            <a:lvl9pPr marL="3886200" indent="-228600" algn="l" defTabSz="914400" rtl="0" eaLnBrk="1" latinLnBrk="0" hangingPunct="1">
+              <a:lnSpc>
+                <a:spcPct val="90000"/>
+              </a:lnSpc>
+              <a:spcBef>
+                <a:spcPts val="500"/>
+              </a:spcBef>
+              <a:buFont typeface="Arial" panose="020B0604020202020204" pitchFamily="34" charset="0"/>
+              <a:buChar char="•"/>
+              <a:defRPr sz="1800" kern="1200">
+                <a:solidFill>
+                  <a:schemeClr val="tx1"/>
+                </a:solidFill>
+                <a:latin typeface="+mn-lt"/>
+                <a:ea typeface="+mn-ea"/>
+                <a:cs typeface="+mn-cs"/>
+              </a:defRPr>
+            </a:lvl9pPr>
+          </a:lstStyle>
+          <a:p>
+            <a:pPr marL="0" indent="0">
+              <a:buNone/>
+            </a:pPr>
+            <a:r>
+              <a:rPr lang="en-US" sz="7200" dirty="0"/>
+              <a:t>card bounding hulls to eliminate transparent pixel waste, hardware instanced rendering, spherical canopy normal transfers for soft lighting, dithered screen-door LOD cross-fading, octahedral impostors, and vertex/texture memory quantization.</a:t>
+            </a:r>
+          </a:p>
+          <a:p>
+            <a:pPr marL="0" indent="0">
+              <a:buNone/>
+            </a:pPr>
+            <a:endParaRPr lang="en-US" sz="8600" dirty="0"/>
+          </a:p>
+          <a:p>
+            <a:pPr marL="0" indent="0">
+              <a:buNone/>
+            </a:pPr>
+            <a:endParaRPr lang="en-US" altLang="zh-CN" dirty="0"/>
+          </a:p>
+        </p:txBody>
+      </p:sp>
+      <p:pic>
+        <p:nvPicPr>
+          <p:cNvPr id="26" name="Picture 25">
+            <a:extLst>
+              <a:ext uri="{FF2B5EF4-FFF2-40B4-BE49-F238E27FC236}">
+                <a16:creationId xmlns:a16="http://schemas.microsoft.com/office/drawing/2014/main" id="{E2BA4C4A-3318-92FB-A6AC-8C9578BC9D31}"/>
+              </a:ext>
+            </a:extLst>
+          </p:cNvPr>
+          <p:cNvPicPr>
+            <a:picLocks noChangeAspect="1"/>
+          </p:cNvPicPr>
+          <p:nvPr/>
+        </p:nvPicPr>
+        <p:blipFill>
+          <a:blip r:embed="rId6"/>
+          <a:stretch>
+            <a:fillRect/>
+          </a:stretch>
+        </p:blipFill>
+        <p:spPr>
+          <a:xfrm>
+            <a:off x="5489468" y="4669353"/>
+            <a:ext cx="3030948" cy="2107321"/>
+          </a:xfrm>
+          <a:prstGeom prst="rect">
+            <a:avLst/>
+          </a:prstGeom>
+        </p:spPr>
+      </p:pic>
+      <p:pic>
+        <p:nvPicPr>
+          <p:cNvPr id="28" name="Picture 27">
+            <a:extLst>
+              <a:ext uri="{FF2B5EF4-FFF2-40B4-BE49-F238E27FC236}">
+                <a16:creationId xmlns:a16="http://schemas.microsoft.com/office/drawing/2014/main" id="{BAA5E4C8-CCD6-984E-AA74-D5985DD7A53C}"/>
+              </a:ext>
+            </a:extLst>
+          </p:cNvPr>
+          <p:cNvPicPr>
+            <a:picLocks noChangeAspect="1"/>
+          </p:cNvPicPr>
+          <p:nvPr/>
+        </p:nvPicPr>
+        <p:blipFill>
+          <a:blip r:embed="rId7"/>
+          <a:stretch>
+            <a:fillRect/>
+          </a:stretch>
+        </p:blipFill>
+        <p:spPr>
+          <a:xfrm>
+            <a:off x="8520416" y="4669353"/>
+            <a:ext cx="3012388" cy="2107321"/>
+          </a:xfrm>
+          <a:prstGeom prst="rect">
+            <a:avLst/>
+          </a:prstGeom>
+        </p:spPr>
+      </p:pic>
     </p:spTree>
     <p:extLst>
       <p:ext uri="{BB962C8B-B14F-4D97-AF65-F5344CB8AC3E}">
-        <p14:creationId xmlns:p14="http://schemas.microsoft.com/office/powerpoint/2010/main" val="943744701"/>
+        <p14:creationId xmlns:p14="http://schemas.microsoft.com/office/powerpoint/2010/main" val="2556202693"/>
       </p:ext>
     </p:extLst>
   </p:cSld>
@@ -4293,7 +7362,13 @@
   <p:cSld>
     <p:spTree>
       <p:nvGrpSpPr>
-        <p:cNvPr id="1" name=""/>
+        <p:cNvPr id="1" name="">
+          <a:extLst>
+            <a:ext uri="{FF2B5EF4-FFF2-40B4-BE49-F238E27FC236}">
+              <a16:creationId xmlns:a16="http://schemas.microsoft.com/office/drawing/2014/main" id="{9008F6D3-3BFC-F7E0-AA10-95AE449798DA}"/>
+            </a:ext>
+          </a:extLst>
+        </p:cNvPr>
         <p:cNvGrpSpPr/>
         <p:nvPr/>
       </p:nvGrpSpPr>
@@ -4310,7 +7385,7 @@
           <p:cNvPr id="2" name="标题 1">
             <a:extLst>
               <a:ext uri="{FF2B5EF4-FFF2-40B4-BE49-F238E27FC236}">
-                <a16:creationId xmlns:a16="http://schemas.microsoft.com/office/drawing/2014/main" id="{1631EA1C-1B4C-8E94-51C2-D8E2E04625BA}"/>
+                <a16:creationId xmlns:a16="http://schemas.microsoft.com/office/drawing/2014/main" id="{844C9FA9-FA19-708A-4CEF-5F4F2C7A886B}"/>
               </a:ext>
             </a:extLst>
           </p:cNvPr>
@@ -4328,7 +7403,7 @@
           <a:p>
             <a:r>
               <a:rPr lang="en-US" altLang="zh-CN" dirty="0"/>
-              <a:t>Personal note in the end</a:t>
+              <a:t>Workflow analysis</a:t>
             </a:r>
             <a:endParaRPr lang="zh-CN" altLang="en-US" dirty="0"/>
           </a:p>
@@ -4339,7 +7414,7 @@
           <p:cNvPr id="3" name="内容占位符 2">
             <a:extLst>
               <a:ext uri="{FF2B5EF4-FFF2-40B4-BE49-F238E27FC236}">
-                <a16:creationId xmlns:a16="http://schemas.microsoft.com/office/drawing/2014/main" id="{D864FF2B-5D3B-E95E-834D-1B30DB2A2B6B}"/>
+                <a16:creationId xmlns:a16="http://schemas.microsoft.com/office/drawing/2014/main" id="{EFED4855-22EE-1D16-3C28-2EDE28D17550}"/>
               </a:ext>
             </a:extLst>
           </p:cNvPr>
@@ -4357,28 +7432,55 @@
           <a:p>
             <a:r>
               <a:rPr lang="en-US" altLang="zh-CN" dirty="0"/>
-              <a:t>One of my goal is to deeply utilize AI during rendering engineering. While understanding matters from an academic viewpoint so I can perform necessary customization when necessary and provide accurate consulting services.</a:t>
-            </a:r>
-          </a:p>
-          <a:p>
+              <a:t>Quick pipeline from </a:t>
+            </a:r>
+            <a:r>
+              <a:rPr lang="en-US" altLang="zh-CN" dirty="0" err="1"/>
+              <a:t>gltf</a:t>
+            </a:r>
             <a:r>
               <a:rPr lang="en-US" altLang="zh-CN" dirty="0"/>
-              <a:t>My career goal will lean towards low level rendering engine optimization or client-facing consulting because of my language advantage</a:t>
-            </a:r>
+              <a:t> to </a:t>
+            </a:r>
+            <a:r>
+              <a:rPr lang="en-US" altLang="zh-CN" dirty="0" err="1"/>
+              <a:t>renderable</a:t>
+            </a:r>
+            <a:endParaRPr lang="en-US" altLang="zh-CN" dirty="0"/>
           </a:p>
           <a:p>
             <a:r>
               <a:rPr lang="en-US" altLang="zh-CN" dirty="0"/>
-              <a:t>I define myself as a render engineer who is fully capable of using unity/UE/Kanzi or build customized rendering pipeline to maximize the potential of any hardware</a:t>
-            </a:r>
-            <a:endParaRPr lang="zh-CN" altLang="en-US" dirty="0"/>
+              <a:t>Good for elite engineering team to make finer customization and edge-case debugging </a:t>
+            </a:r>
+          </a:p>
+          <a:p>
+            <a:r>
+              <a:rPr lang="en-US" altLang="zh-CN" dirty="0"/>
+              <a:t>Compatible with traditional git management</a:t>
+            </a:r>
+          </a:p>
+          <a:p>
+            <a:r>
+              <a:rPr lang="en-US" altLang="zh-CN" dirty="0"/>
+              <a:t>Good for developing a professional rendering team instead of generalists</a:t>
+            </a:r>
+          </a:p>
+          <a:p>
+            <a:r>
+              <a:rPr lang="en-US" altLang="zh-CN" dirty="0"/>
+              <a:t>Move fast, deliver quick and precise solution, source code fully controllable and explainable</a:t>
+            </a:r>
+          </a:p>
+          <a:p>
+            <a:endParaRPr lang="en-US" altLang="zh-CN" dirty="0"/>
           </a:p>
         </p:txBody>
       </p:sp>
     </p:spTree>
     <p:extLst>
       <p:ext uri="{BB962C8B-B14F-4D97-AF65-F5344CB8AC3E}">
-        <p14:creationId xmlns:p14="http://schemas.microsoft.com/office/powerpoint/2010/main" val="3127194409"/>
+        <p14:creationId xmlns:p14="http://schemas.microsoft.com/office/powerpoint/2010/main" val="2530839382"/>
       </p:ext>
     </p:extLst>
   </p:cSld>
@@ -4410,15 +7512,15 @@
           <p:cNvPr id="2" name="标题 1">
             <a:extLst>
               <a:ext uri="{FF2B5EF4-FFF2-40B4-BE49-F238E27FC236}">
-                <a16:creationId xmlns:a16="http://schemas.microsoft.com/office/drawing/2014/main" id="{493A2EF7-200C-22DA-3C40-B6F90972A172}"/>
-              </a:ext>
-            </a:extLst>
-          </p:cNvPr>
-          <p:cNvSpPr>
-            <a:spLocks noGrp="1"/>
-          </p:cNvSpPr>
-          <p:nvPr>
-            <p:ph type="ctrTitle"/>
+                <a16:creationId xmlns:a16="http://schemas.microsoft.com/office/drawing/2014/main" id="{95665380-229C-8A34-832A-ED2E12BF40D0}"/>
+              </a:ext>
+            </a:extLst>
+          </p:cNvPr>
+          <p:cNvSpPr>
+            <a:spLocks noGrp="1"/>
+          </p:cNvSpPr>
+          <p:nvPr>
+            <p:ph type="title"/>
           </p:nvPr>
         </p:nvSpPr>
         <p:spPr/>
@@ -4428,7 +7530,7 @@
           <a:p>
             <a:r>
               <a:rPr lang="en-US" altLang="zh-CN" dirty="0"/>
-              <a:t>Thanks!</a:t>
+              <a:t>Other Technologies Used</a:t>
             </a:r>
             <a:endParaRPr lang="zh-CN" altLang="en-US" dirty="0"/>
           </a:p>
@@ -4436,33 +7538,280 @@
       </p:sp>
       <p:sp>
         <p:nvSpPr>
-          <p:cNvPr id="3" name="副标题 2">
-            <a:extLst>
-              <a:ext uri="{FF2B5EF4-FFF2-40B4-BE49-F238E27FC236}">
-                <a16:creationId xmlns:a16="http://schemas.microsoft.com/office/drawing/2014/main" id="{3FCD6C58-D537-7B4D-F070-8B16911322A8}"/>
-              </a:ext>
-            </a:extLst>
-          </p:cNvPr>
-          <p:cNvSpPr>
-            <a:spLocks noGrp="1"/>
-          </p:cNvSpPr>
-          <p:nvPr>
-            <p:ph type="subTitle" idx="1"/>
-          </p:nvPr>
-        </p:nvSpPr>
-        <p:spPr/>
-        <p:txBody>
-          <a:bodyPr/>
+          <p:cNvPr id="3" name="内容占位符 2">
+            <a:extLst>
+              <a:ext uri="{FF2B5EF4-FFF2-40B4-BE49-F238E27FC236}">
+                <a16:creationId xmlns:a16="http://schemas.microsoft.com/office/drawing/2014/main" id="{1CDD36FB-14EB-E63C-DB13-5B0DFEF0AE1D}"/>
+              </a:ext>
+            </a:extLst>
+          </p:cNvPr>
+          <p:cNvSpPr>
+            <a:spLocks noGrp="1"/>
+          </p:cNvSpPr>
+          <p:nvPr>
+            <p:ph idx="1"/>
+          </p:nvPr>
+        </p:nvSpPr>
+        <p:spPr>
+          <a:xfrm>
+            <a:off x="838200" y="1396041"/>
+            <a:ext cx="10515600" cy="4351338"/>
+          </a:xfrm>
+        </p:spPr>
+        <p:txBody>
+          <a:bodyPr>
+            <a:normAutofit/>
+          </a:bodyPr>
           <a:lstStyle/>
           <a:p>
+            <a:r>
+              <a:rPr lang="en-US" altLang="zh-CN" dirty="0"/>
+              <a:t>MCP for blender</a:t>
+            </a:r>
+          </a:p>
+          <a:p>
+            <a:r>
+              <a:rPr lang="en-US" altLang="zh-CN" dirty="0"/>
+              <a:t>GLTF/GLB file extension</a:t>
+            </a:r>
+          </a:p>
+          <a:p>
+            <a:r>
+              <a:rPr lang="en-US" altLang="zh-CN" dirty="0"/>
+              <a:t>Android OS/ ADB debugging/ APK file extension/ Cross compiling</a:t>
+            </a:r>
+          </a:p>
+          <a:p>
+            <a:r>
+              <a:rPr lang="en-US" altLang="zh-CN" dirty="0"/>
+              <a:t>Rust programming language</a:t>
+            </a:r>
+          </a:p>
+          <a:p>
+            <a:r>
+              <a:rPr lang="en-US" altLang="zh-CN" dirty="0" err="1"/>
+              <a:t>Botaniq</a:t>
+            </a:r>
+            <a:r>
+              <a:rPr lang="en-US" altLang="zh-CN" dirty="0"/>
+              <a:t> blender plugin for plant resources</a:t>
+            </a:r>
+          </a:p>
+          <a:p>
+            <a:pPr marL="0" indent="0">
+              <a:buNone/>
+            </a:pPr>
+            <a:endParaRPr lang="en-US" altLang="zh-CN" dirty="0"/>
+          </a:p>
+          <a:p>
             <a:endParaRPr lang="zh-CN" altLang="en-US" dirty="0"/>
+          </a:p>
+        </p:txBody>
+      </p:sp>
+      <p:sp>
+        <p:nvSpPr>
+          <p:cNvPr id="4" name="内容占位符 2">
+            <a:extLst>
+              <a:ext uri="{FF2B5EF4-FFF2-40B4-BE49-F238E27FC236}">
+                <a16:creationId xmlns:a16="http://schemas.microsoft.com/office/drawing/2014/main" id="{76C5F6CF-1048-44CE-5671-5D14C8C22D4E}"/>
+              </a:ext>
+            </a:extLst>
+          </p:cNvPr>
+          <p:cNvSpPr txBox="1">
+            <a:spLocks/>
+          </p:cNvSpPr>
+          <p:nvPr/>
+        </p:nvSpPr>
+        <p:spPr>
+          <a:xfrm>
+            <a:off x="1126435" y="4146412"/>
+            <a:ext cx="4842013" cy="2796071"/>
+          </a:xfrm>
+          <a:prstGeom prst="rect">
+            <a:avLst/>
+          </a:prstGeom>
+        </p:spPr>
+        <p:txBody>
+          <a:bodyPr vert="horz" lIns="91440" tIns="45720" rIns="91440" bIns="45720" rtlCol="0">
+            <a:normAutofit/>
+          </a:bodyPr>
+          <a:lstStyle>
+            <a:lvl1pPr marL="228600" indent="-228600" algn="l" defTabSz="914400" rtl="0" eaLnBrk="1" latinLnBrk="0" hangingPunct="1">
+              <a:lnSpc>
+                <a:spcPct val="90000"/>
+              </a:lnSpc>
+              <a:spcBef>
+                <a:spcPts val="1000"/>
+              </a:spcBef>
+              <a:buFont typeface="Arial" panose="020B0604020202020204" pitchFamily="34" charset="0"/>
+              <a:buChar char="•"/>
+              <a:defRPr sz="2800" kern="1200">
+                <a:solidFill>
+                  <a:schemeClr val="tx1"/>
+                </a:solidFill>
+                <a:latin typeface="+mn-lt"/>
+                <a:ea typeface="+mn-ea"/>
+                <a:cs typeface="+mn-cs"/>
+              </a:defRPr>
+            </a:lvl1pPr>
+            <a:lvl2pPr marL="685800" indent="-228600" algn="l" defTabSz="914400" rtl="0" eaLnBrk="1" latinLnBrk="0" hangingPunct="1">
+              <a:lnSpc>
+                <a:spcPct val="90000"/>
+              </a:lnSpc>
+              <a:spcBef>
+                <a:spcPts val="500"/>
+              </a:spcBef>
+              <a:buFont typeface="Arial" panose="020B0604020202020204" pitchFamily="34" charset="0"/>
+              <a:buChar char="•"/>
+              <a:defRPr sz="2400" kern="1200">
+                <a:solidFill>
+                  <a:schemeClr val="tx1"/>
+                </a:solidFill>
+                <a:latin typeface="+mn-lt"/>
+                <a:ea typeface="+mn-ea"/>
+                <a:cs typeface="+mn-cs"/>
+              </a:defRPr>
+            </a:lvl2pPr>
+            <a:lvl3pPr marL="1143000" indent="-228600" algn="l" defTabSz="914400" rtl="0" eaLnBrk="1" latinLnBrk="0" hangingPunct="1">
+              <a:lnSpc>
+                <a:spcPct val="90000"/>
+              </a:lnSpc>
+              <a:spcBef>
+                <a:spcPts val="500"/>
+              </a:spcBef>
+              <a:buFont typeface="Arial" panose="020B0604020202020204" pitchFamily="34" charset="0"/>
+              <a:buChar char="•"/>
+              <a:defRPr sz="2000" kern="1200">
+                <a:solidFill>
+                  <a:schemeClr val="tx1"/>
+                </a:solidFill>
+                <a:latin typeface="+mn-lt"/>
+                <a:ea typeface="+mn-ea"/>
+                <a:cs typeface="+mn-cs"/>
+              </a:defRPr>
+            </a:lvl3pPr>
+            <a:lvl4pPr marL="1600200" indent="-228600" algn="l" defTabSz="914400" rtl="0" eaLnBrk="1" latinLnBrk="0" hangingPunct="1">
+              <a:lnSpc>
+                <a:spcPct val="90000"/>
+              </a:lnSpc>
+              <a:spcBef>
+                <a:spcPts val="500"/>
+              </a:spcBef>
+              <a:buFont typeface="Arial" panose="020B0604020202020204" pitchFamily="34" charset="0"/>
+              <a:buChar char="•"/>
+              <a:defRPr sz="1800" kern="1200">
+                <a:solidFill>
+                  <a:schemeClr val="tx1"/>
+                </a:solidFill>
+                <a:latin typeface="+mn-lt"/>
+                <a:ea typeface="+mn-ea"/>
+                <a:cs typeface="+mn-cs"/>
+              </a:defRPr>
+            </a:lvl4pPr>
+            <a:lvl5pPr marL="2057400" indent="-228600" algn="l" defTabSz="914400" rtl="0" eaLnBrk="1" latinLnBrk="0" hangingPunct="1">
+              <a:lnSpc>
+                <a:spcPct val="90000"/>
+              </a:lnSpc>
+              <a:spcBef>
+                <a:spcPts val="500"/>
+              </a:spcBef>
+              <a:buFont typeface="Arial" panose="020B0604020202020204" pitchFamily="34" charset="0"/>
+              <a:buChar char="•"/>
+              <a:defRPr sz="1800" kern="1200">
+                <a:solidFill>
+                  <a:schemeClr val="tx1"/>
+                </a:solidFill>
+                <a:latin typeface="+mn-lt"/>
+                <a:ea typeface="+mn-ea"/>
+                <a:cs typeface="+mn-cs"/>
+              </a:defRPr>
+            </a:lvl5pPr>
+            <a:lvl6pPr marL="2514600" indent="-228600" algn="l" defTabSz="914400" rtl="0" eaLnBrk="1" latinLnBrk="0" hangingPunct="1">
+              <a:lnSpc>
+                <a:spcPct val="90000"/>
+              </a:lnSpc>
+              <a:spcBef>
+                <a:spcPts val="500"/>
+              </a:spcBef>
+              <a:buFont typeface="Arial" panose="020B0604020202020204" pitchFamily="34" charset="0"/>
+              <a:buChar char="•"/>
+              <a:defRPr sz="1800" kern="1200">
+                <a:solidFill>
+                  <a:schemeClr val="tx1"/>
+                </a:solidFill>
+                <a:latin typeface="+mn-lt"/>
+                <a:ea typeface="+mn-ea"/>
+                <a:cs typeface="+mn-cs"/>
+              </a:defRPr>
+            </a:lvl6pPr>
+            <a:lvl7pPr marL="2971800" indent="-228600" algn="l" defTabSz="914400" rtl="0" eaLnBrk="1" latinLnBrk="0" hangingPunct="1">
+              <a:lnSpc>
+                <a:spcPct val="90000"/>
+              </a:lnSpc>
+              <a:spcBef>
+                <a:spcPts val="500"/>
+              </a:spcBef>
+              <a:buFont typeface="Arial" panose="020B0604020202020204" pitchFamily="34" charset="0"/>
+              <a:buChar char="•"/>
+              <a:defRPr sz="1800" kern="1200">
+                <a:solidFill>
+                  <a:schemeClr val="tx1"/>
+                </a:solidFill>
+                <a:latin typeface="+mn-lt"/>
+                <a:ea typeface="+mn-ea"/>
+                <a:cs typeface="+mn-cs"/>
+              </a:defRPr>
+            </a:lvl7pPr>
+            <a:lvl8pPr marL="3429000" indent="-228600" algn="l" defTabSz="914400" rtl="0" eaLnBrk="1" latinLnBrk="0" hangingPunct="1">
+              <a:lnSpc>
+                <a:spcPct val="90000"/>
+              </a:lnSpc>
+              <a:spcBef>
+                <a:spcPts val="500"/>
+              </a:spcBef>
+              <a:buFont typeface="Arial" panose="020B0604020202020204" pitchFamily="34" charset="0"/>
+              <a:buChar char="•"/>
+              <a:defRPr sz="1800" kern="1200">
+                <a:solidFill>
+                  <a:schemeClr val="tx1"/>
+                </a:solidFill>
+                <a:latin typeface="+mn-lt"/>
+                <a:ea typeface="+mn-ea"/>
+                <a:cs typeface="+mn-cs"/>
+              </a:defRPr>
+            </a:lvl8pPr>
+            <a:lvl9pPr marL="3886200" indent="-228600" algn="l" defTabSz="914400" rtl="0" eaLnBrk="1" latinLnBrk="0" hangingPunct="1">
+              <a:lnSpc>
+                <a:spcPct val="90000"/>
+              </a:lnSpc>
+              <a:spcBef>
+                <a:spcPts val="500"/>
+              </a:spcBef>
+              <a:buFont typeface="Arial" panose="020B0604020202020204" pitchFamily="34" charset="0"/>
+              <a:buChar char="•"/>
+              <a:defRPr sz="1800" kern="1200">
+                <a:solidFill>
+                  <a:schemeClr val="tx1"/>
+                </a:solidFill>
+                <a:latin typeface="+mn-lt"/>
+                <a:ea typeface="+mn-ea"/>
+                <a:cs typeface="+mn-cs"/>
+              </a:defRPr>
+            </a:lvl9pPr>
+          </a:lstStyle>
+          <a:p>
+            <a:pPr marL="0" indent="0">
+              <a:buFont typeface="Arial" panose="020B0604020202020204" pitchFamily="34" charset="0"/>
+              <a:buNone/>
+            </a:pPr>
+            <a:endParaRPr lang="en-US" altLang="zh-CN" dirty="0"/>
           </a:p>
         </p:txBody>
       </p:sp>
     </p:spTree>
     <p:extLst>
       <p:ext uri="{BB962C8B-B14F-4D97-AF65-F5344CB8AC3E}">
-        <p14:creationId xmlns:p14="http://schemas.microsoft.com/office/powerpoint/2010/main" val="2396252889"/>
+        <p14:creationId xmlns:p14="http://schemas.microsoft.com/office/powerpoint/2010/main" val="943744701"/>
       </p:ext>
     </p:extLst>
   </p:cSld>
@@ -4765,4 +8114,299 @@
     </a:ext>
   </a:extLst>
 </a:theme>
+</file>
+
+<file path=ppt/theme/theme2.xml><?xml version="1.0" encoding="utf-8"?>
+<a:theme xmlns:a="http://schemas.openxmlformats.org/drawingml/2006/main" name="Office Theme">
+  <a:themeElements>
+    <a:clrScheme name="Office">
+      <a:dk1>
+        <a:sysClr val="windowText" lastClr="000000"/>
+      </a:dk1>
+      <a:lt1>
+        <a:sysClr val="window" lastClr="FFFFFF"/>
+      </a:lt1>
+      <a:dk2>
+        <a:srgbClr val="44546A"/>
+      </a:dk2>
+      <a:lt2>
+        <a:srgbClr val="E7E6E6"/>
+      </a:lt2>
+      <a:accent1>
+        <a:srgbClr val="4472C4"/>
+      </a:accent1>
+      <a:accent2>
+        <a:srgbClr val="ED7D31"/>
+      </a:accent2>
+      <a:accent3>
+        <a:srgbClr val="A5A5A5"/>
+      </a:accent3>
+      <a:accent4>
+        <a:srgbClr val="FFC000"/>
+      </a:accent4>
+      <a:accent5>
+        <a:srgbClr val="5B9BD5"/>
+      </a:accent5>
+      <a:accent6>
+        <a:srgbClr val="70AD47"/>
+      </a:accent6>
+      <a:hlink>
+        <a:srgbClr val="0563C1"/>
+      </a:hlink>
+      <a:folHlink>
+        <a:srgbClr val="954F72"/>
+      </a:folHlink>
+    </a:clrScheme>
+    <a:fontScheme name="Office">
+      <a:majorFont>
+        <a:latin typeface="Calibri Light" panose="020F0302020204030204"/>
+        <a:ea typeface=""/>
+        <a:cs typeface=""/>
+        <a:font script="Jpan" typeface="游ゴシック Light"/>
+        <a:font script="Hang" typeface="맑은 고딕"/>
+        <a:font script="Hans" typeface="等线 Light"/>
+        <a:font script="Hant" typeface="新細明體"/>
+        <a:font script="Arab" typeface="Times New Roman"/>
+        <a:font script="Hebr" typeface="Times New Roman"/>
+        <a:font script="Thai" typeface="Angsana New"/>
+        <a:font script="Ethi" typeface="Nyala"/>
+        <a:font script="Beng" typeface="Vrinda"/>
+        <a:font script="Gujr" typeface="Shruti"/>
+        <a:font script="Khmr" typeface="MoolBoran"/>
+        <a:font script="Knda" typeface="Tunga"/>
+        <a:font script="Guru" typeface="Raavi"/>
+        <a:font script="Cans" typeface="Euphemia"/>
+        <a:font script="Cher" typeface="Plantagenet Cherokee"/>
+        <a:font script="Yiii" typeface="Microsoft Yi Baiti"/>
+        <a:font script="Tibt" typeface="Microsoft Himalaya"/>
+        <a:font script="Thaa" typeface="MV Boli"/>
+        <a:font script="Deva" typeface="Mangal"/>
+        <a:font script="Telu" typeface="Gautami"/>
+        <a:font script="Taml" typeface="Latha"/>
+        <a:font script="Syrc" typeface="Estrangelo Edessa"/>
+        <a:font script="Orya" typeface="Kalinga"/>
+        <a:font script="Mlym" typeface="Kartika"/>
+        <a:font script="Laoo" typeface="DokChampa"/>
+        <a:font script="Sinh" typeface="Iskoola Pota"/>
+        <a:font script="Mong" typeface="Mongolian Baiti"/>
+        <a:font script="Viet" typeface="Times New Roman"/>
+        <a:font script="Uigh" typeface="Microsoft Uighur"/>
+        <a:font script="Geor" typeface="Sylfaen"/>
+        <a:font script="Armn" typeface="Arial"/>
+        <a:font script="Bugi" typeface="Leelawadee UI"/>
+        <a:font script="Bopo" typeface="Microsoft JhengHei"/>
+        <a:font script="Java" typeface="Javanese Text"/>
+        <a:font script="Lisu" typeface="Segoe UI"/>
+        <a:font script="Mymr" typeface="Myanmar Text"/>
+        <a:font script="Nkoo" typeface="Ebrima"/>
+        <a:font script="Olck" typeface="Nirmala UI"/>
+        <a:font script="Osma" typeface="Ebrima"/>
+        <a:font script="Phag" typeface="Phagspa"/>
+        <a:font script="Syrn" typeface="Estrangelo Edessa"/>
+        <a:font script="Syrj" typeface="Estrangelo Edessa"/>
+        <a:font script="Syre" typeface="Estrangelo Edessa"/>
+        <a:font script="Sora" typeface="Nirmala UI"/>
+        <a:font script="Tale" typeface="Microsoft Tai Le"/>
+        <a:font script="Talu" typeface="Microsoft New Tai Lue"/>
+        <a:font script="Tfng" typeface="Ebrima"/>
+      </a:majorFont>
+      <a:minorFont>
+        <a:latin typeface="Calibri" panose="020F0502020204030204"/>
+        <a:ea typeface=""/>
+        <a:cs typeface=""/>
+        <a:font script="Jpan" typeface="游ゴシック"/>
+        <a:font script="Hang" typeface="맑은 고딕"/>
+        <a:font script="Hans" typeface="等线"/>
+        <a:font script="Hant" typeface="新細明體"/>
+        <a:font script="Arab" typeface="Arial"/>
+        <a:font script="Hebr" typeface="Arial"/>
+        <a:font script="Thai" typeface="Cordia New"/>
+        <a:font script="Ethi" typeface="Nyala"/>
+        <a:font script="Beng" typeface="Vrinda"/>
+        <a:font script="Gujr" typeface="Shruti"/>
+        <a:font script="Khmr" typeface="DaunPenh"/>
+        <a:font script="Knda" typeface="Tunga"/>
+        <a:font script="Guru" typeface="Raavi"/>
+        <a:font script="Cans" typeface="Euphemia"/>
+        <a:font script="Cher" typeface="Plantagenet Cherokee"/>
+        <a:font script="Yiii" typeface="Microsoft Yi Baiti"/>
+        <a:font script="Tibt" typeface="Microsoft Himalaya"/>
+        <a:font script="Thaa" typeface="MV Boli"/>
+        <a:font script="Deva" typeface="Mangal"/>
+        <a:font script="Telu" typeface="Gautami"/>
+        <a:font script="Taml" typeface="Latha"/>
+        <a:font script="Syrc" typeface="Estrangelo Edessa"/>
+        <a:font script="Orya" typeface="Kalinga"/>
+        <a:font script="Mlym" typeface="Kartika"/>
+        <a:font script="Laoo" typeface="DokChampa"/>
+        <a:font script="Sinh" typeface="Iskoola Pota"/>
+        <a:font script="Mong" typeface="Mongolian Baiti"/>
+        <a:font script="Viet" typeface="Arial"/>
+        <a:font script="Uigh" typeface="Microsoft Uighur"/>
+        <a:font script="Geor" typeface="Sylfaen"/>
+        <a:font script="Armn" typeface="Arial"/>
+        <a:font script="Bugi" typeface="Leelawadee UI"/>
+        <a:font script="Bopo" typeface="Microsoft JhengHei"/>
+        <a:font script="Java" typeface="Javanese Text"/>
+        <a:font script="Lisu" typeface="Segoe UI"/>
+        <a:font script="Mymr" typeface="Myanmar Text"/>
+        <a:font script="Nkoo" typeface="Ebrima"/>
+        <a:font script="Olck" typeface="Nirmala UI"/>
+        <a:font script="Osma" typeface="Ebrima"/>
+        <a:font script="Phag" typeface="Phagspa"/>
+        <a:font script="Syrn" typeface="Estrangelo Edessa"/>
+        <a:font script="Syrj" typeface="Estrangelo Edessa"/>
+        <a:font script="Syre" typeface="Estrangelo Edessa"/>
+        <a:font script="Sora" typeface="Nirmala UI"/>
+        <a:font script="Tale" typeface="Microsoft Tai Le"/>
+        <a:font script="Talu" typeface="Microsoft New Tai Lue"/>
+        <a:font script="Tfng" typeface="Ebrima"/>
+      </a:minorFont>
+    </a:fontScheme>
+    <a:fmtScheme name="Office">
+      <a:fillStyleLst>
+        <a:solidFill>
+          <a:schemeClr val="phClr"/>
+        </a:solidFill>
+        <a:gradFill rotWithShape="1">
+          <a:gsLst>
+            <a:gs pos="0">
+              <a:schemeClr val="phClr">
+                <a:lumMod val="110000"/>
+                <a:satMod val="105000"/>
+                <a:tint val="67000"/>
+              </a:schemeClr>
+            </a:gs>
+            <a:gs pos="50000">
+              <a:schemeClr val="phClr">
+                <a:lumMod val="105000"/>
+                <a:satMod val="103000"/>
+                <a:tint val="73000"/>
+              </a:schemeClr>
+            </a:gs>
+            <a:gs pos="100000">
+              <a:schemeClr val="phClr">
+                <a:lumMod val="105000"/>
+                <a:satMod val="109000"/>
+                <a:tint val="81000"/>
+              </a:schemeClr>
+            </a:gs>
+          </a:gsLst>
+          <a:lin ang="5400000" scaled="0"/>
+        </a:gradFill>
+        <a:gradFill rotWithShape="1">
+          <a:gsLst>
+            <a:gs pos="0">
+              <a:schemeClr val="phClr">
+                <a:satMod val="103000"/>
+                <a:lumMod val="102000"/>
+                <a:tint val="94000"/>
+              </a:schemeClr>
+            </a:gs>
+            <a:gs pos="50000">
+              <a:schemeClr val="phClr">
+                <a:satMod val="110000"/>
+                <a:lumMod val="100000"/>
+                <a:shade val="100000"/>
+              </a:schemeClr>
+            </a:gs>
+            <a:gs pos="100000">
+              <a:schemeClr val="phClr">
+                <a:lumMod val="99000"/>
+                <a:satMod val="120000"/>
+                <a:shade val="78000"/>
+              </a:schemeClr>
+            </a:gs>
+          </a:gsLst>
+          <a:lin ang="5400000" scaled="0"/>
+        </a:gradFill>
+      </a:fillStyleLst>
+      <a:lnStyleLst>
+        <a:ln w="6350" cap="flat" cmpd="sng" algn="ctr">
+          <a:solidFill>
+            <a:schemeClr val="phClr"/>
+          </a:solidFill>
+          <a:prstDash val="solid"/>
+          <a:miter lim="800000"/>
+        </a:ln>
+        <a:ln w="12700" cap="flat" cmpd="sng" algn="ctr">
+          <a:solidFill>
+            <a:schemeClr val="phClr"/>
+          </a:solidFill>
+          <a:prstDash val="solid"/>
+          <a:miter lim="800000"/>
+        </a:ln>
+        <a:ln w="19050" cap="flat" cmpd="sng" algn="ctr">
+          <a:solidFill>
+            <a:schemeClr val="phClr"/>
+          </a:solidFill>
+          <a:prstDash val="solid"/>
+          <a:miter lim="800000"/>
+        </a:ln>
+      </a:lnStyleLst>
+      <a:effectStyleLst>
+        <a:effectStyle>
+          <a:effectLst/>
+        </a:effectStyle>
+        <a:effectStyle>
+          <a:effectLst/>
+        </a:effectStyle>
+        <a:effectStyle>
+          <a:effectLst>
+            <a:outerShdw blurRad="57150" dist="19050" dir="5400000" algn="ctr" rotWithShape="0">
+              <a:srgbClr val="000000">
+                <a:alpha val="63000"/>
+              </a:srgbClr>
+            </a:outerShdw>
+          </a:effectLst>
+        </a:effectStyle>
+      </a:effectStyleLst>
+      <a:bgFillStyleLst>
+        <a:solidFill>
+          <a:schemeClr val="phClr"/>
+        </a:solidFill>
+        <a:solidFill>
+          <a:schemeClr val="phClr">
+            <a:tint val="95000"/>
+            <a:satMod val="170000"/>
+          </a:schemeClr>
+        </a:solidFill>
+        <a:gradFill rotWithShape="1">
+          <a:gsLst>
+            <a:gs pos="0">
+              <a:schemeClr val="phClr">
+                <a:tint val="93000"/>
+                <a:satMod val="150000"/>
+                <a:shade val="98000"/>
+                <a:lumMod val="102000"/>
+              </a:schemeClr>
+            </a:gs>
+            <a:gs pos="50000">
+              <a:schemeClr val="phClr">
+                <a:tint val="98000"/>
+                <a:satMod val="130000"/>
+                <a:shade val="90000"/>
+                <a:lumMod val="103000"/>
+              </a:schemeClr>
+            </a:gs>
+            <a:gs pos="100000">
+              <a:schemeClr val="phClr">
+                <a:shade val="63000"/>
+                <a:satMod val="120000"/>
+              </a:schemeClr>
+            </a:gs>
+          </a:gsLst>
+          <a:lin ang="5400000" scaled="0"/>
+        </a:gradFill>
+      </a:bgFillStyleLst>
+    </a:fmtScheme>
+  </a:themeElements>
+  <a:objectDefaults/>
+  <a:extraClrSchemeLst/>
+  <a:extLst>
+    <a:ext uri="{05A4C25C-085E-4340-85A3-A5531E510DB2}">
+      <thm15:themeFamily xmlns:thm15="http://schemas.microsoft.com/office/thememl/2012/main" name="Office Theme" id="{62F939B6-93AF-4DB8-9C6B-D6C7DFDC589F}" vid="{4A3C46E8-61CC-4603-A589-7422A47A8E4A}"/>
+    </a:ext>
+  </a:extLst>
+</a:theme>
 </file>
</xml_diff>

<commit_message>
feat(ci): consolidate Android CI pipeline, integrate Vulkan emulator, and refactor engine modules
</commit_message>
<xml_diff>
--- a/WebGPU Renderer.pptx
+++ b/WebGPU Renderer.pptx
@@ -5,7 +5,7 @@
     <p:sldMasterId id="2147483648" r:id="rId1"/>
   </p:sldMasterIdLst>
   <p:notesMasterIdLst>
-    <p:notesMasterId r:id="rId16"/>
+    <p:notesMasterId r:id="rId18"/>
   </p:notesMasterIdLst>
   <p:sldIdLst>
     <p:sldId id="256" r:id="rId2"/>
@@ -19,9 +19,11 @@
     <p:sldId id="262" r:id="rId10"/>
     <p:sldId id="271" r:id="rId11"/>
     <p:sldId id="272" r:id="rId12"/>
-    <p:sldId id="273" r:id="rId13"/>
-    <p:sldId id="259" r:id="rId14"/>
-    <p:sldId id="265" r:id="rId15"/>
+    <p:sldId id="275" r:id="rId13"/>
+    <p:sldId id="276" r:id="rId14"/>
+    <p:sldId id="273" r:id="rId15"/>
+    <p:sldId id="259" r:id="rId16"/>
+    <p:sldId id="265" r:id="rId17"/>
   </p:sldIdLst>
   <p:sldSz cx="12192000" cy="6858000"/>
   <p:notesSz cx="6858000" cy="9144000"/>
@@ -131,7 +133,7 @@
 <file path=ppt/revisionInfo.xml><?xml version="1.0" encoding="utf-8"?>
 <p1510:revInfo xmlns:a="http://schemas.openxmlformats.org/drawingml/2006/main" xmlns:r="http://schemas.openxmlformats.org/officeDocument/2006/relationships" xmlns:p1510="http://schemas.microsoft.com/office/powerpoint/2015/10/main">
   <p1510:revLst>
-    <p1510:client id="{CE661803-590C-4BF4-8418-3A596B2AE982}" v="35" dt="2026-10-13T12:11:19.985"/>
+    <p1510:client id="{CE661803-590C-4BF4-8418-3A596B2AE982}" v="42" dt="2026-10-14T07:17:04.301"/>
   </p1510:revLst>
 </p1510:revInfo>
 </file>
@@ -340,12 +342,12 @@
   <pc:docChgLst>
     <pc:chgData name="Tyrion Bao" userId="86a2b12e41226f78" providerId="LiveId" clId="{4891CA31-0AE7-4ECE-B60E-21685528A7C5}"/>
     <pc:docChg chg="undo custSel addSld delSld modSld">
-      <pc:chgData name="Tyrion Bao" userId="86a2b12e41226f78" providerId="LiveId" clId="{4891CA31-0AE7-4ECE-B60E-21685528A7C5}" dt="2026-10-13T12:20:14.083" v="1565" actId="1076"/>
+      <pc:chgData name="Tyrion Bao" userId="86a2b12e41226f78" providerId="LiveId" clId="{4891CA31-0AE7-4ECE-B60E-21685528A7C5}" dt="2026-10-14T07:28:41.403" v="1787" actId="1076"/>
       <pc:docMkLst>
         <pc:docMk/>
       </pc:docMkLst>
-      <pc:sldChg chg="modSp mod">
-        <pc:chgData name="Tyrion Bao" userId="86a2b12e41226f78" providerId="LiveId" clId="{4891CA31-0AE7-4ECE-B60E-21685528A7C5}" dt="2026-10-13T11:10:12.346" v="1456" actId="20577"/>
+      <pc:sldChg chg="addSp modSp mod">
+        <pc:chgData name="Tyrion Bao" userId="86a2b12e41226f78" providerId="LiveId" clId="{4891CA31-0AE7-4ECE-B60E-21685528A7C5}" dt="2026-10-14T06:55:25.620" v="1651" actId="20577"/>
         <pc:sldMkLst>
           <pc:docMk/>
           <pc:sldMk cId="3127194409" sldId="259"/>
@@ -359,13 +361,29 @@
           </ac:spMkLst>
         </pc:spChg>
         <pc:spChg chg="mod">
-          <ac:chgData name="Tyrion Bao" userId="86a2b12e41226f78" providerId="LiveId" clId="{4891CA31-0AE7-4ECE-B60E-21685528A7C5}" dt="2026-10-13T11:10:12.346" v="1456" actId="20577"/>
+          <ac:chgData name="Tyrion Bao" userId="86a2b12e41226f78" providerId="LiveId" clId="{4891CA31-0AE7-4ECE-B60E-21685528A7C5}" dt="2026-10-14T06:55:25.620" v="1651" actId="20577"/>
           <ac:spMkLst>
             <pc:docMk/>
             <pc:sldMk cId="3127194409" sldId="259"/>
             <ac:spMk id="3" creationId="{D864FF2B-5D3B-E95E-834D-1B30DB2A2B6B}"/>
           </ac:spMkLst>
         </pc:spChg>
+        <pc:picChg chg="add mod">
+          <ac:chgData name="Tyrion Bao" userId="86a2b12e41226f78" providerId="LiveId" clId="{4891CA31-0AE7-4ECE-B60E-21685528A7C5}" dt="2026-10-14T06:41:29.619" v="1635" actId="1076"/>
+          <ac:picMkLst>
+            <pc:docMk/>
+            <pc:sldMk cId="3127194409" sldId="259"/>
+            <ac:picMk id="5" creationId="{03329CC2-F2B7-4775-973E-D76E25BD7C18}"/>
+          </ac:picMkLst>
+        </pc:picChg>
+        <pc:picChg chg="add mod">
+          <ac:chgData name="Tyrion Bao" userId="86a2b12e41226f78" providerId="LiveId" clId="{4891CA31-0AE7-4ECE-B60E-21685528A7C5}" dt="2026-10-14T06:47:57.824" v="1648" actId="1076"/>
+          <ac:picMkLst>
+            <pc:docMk/>
+            <pc:sldMk cId="3127194409" sldId="259"/>
+            <ac:picMk id="7" creationId="{2C25E9FA-5154-3C1C-F824-A852ACC92A76}"/>
+          </ac:picMkLst>
+        </pc:picChg>
       </pc:sldChg>
       <pc:sldChg chg="modSp mod">
         <pc:chgData name="Tyrion Bao" userId="86a2b12e41226f78" providerId="LiveId" clId="{4891CA31-0AE7-4ECE-B60E-21685528A7C5}" dt="2026-10-13T11:30:32.135" v="1537" actId="20577"/>
@@ -383,7 +401,7 @@
         </pc:spChg>
       </pc:sldChg>
       <pc:sldChg chg="addSp modSp mod">
-        <pc:chgData name="Tyrion Bao" userId="86a2b12e41226f78" providerId="LiveId" clId="{4891CA31-0AE7-4ECE-B60E-21685528A7C5}" dt="2026-10-13T11:09:54.723" v="1448" actId="20577"/>
+        <pc:chgData name="Tyrion Bao" userId="86a2b12e41226f78" providerId="LiveId" clId="{4891CA31-0AE7-4ECE-B60E-21685528A7C5}" dt="2026-10-14T07:16:50.309" v="1777" actId="20577"/>
         <pc:sldMkLst>
           <pc:docMk/>
           <pc:sldMk cId="943744701" sldId="262"/>
@@ -397,7 +415,7 @@
           </ac:spMkLst>
         </pc:spChg>
         <pc:spChg chg="mod">
-          <ac:chgData name="Tyrion Bao" userId="86a2b12e41226f78" providerId="LiveId" clId="{4891CA31-0AE7-4ECE-B60E-21685528A7C5}" dt="2026-10-13T11:09:54.723" v="1448" actId="20577"/>
+          <ac:chgData name="Tyrion Bao" userId="86a2b12e41226f78" providerId="LiveId" clId="{4891CA31-0AE7-4ECE-B60E-21685528A7C5}" dt="2026-10-14T07:16:50.309" v="1777" actId="20577"/>
           <ac:spMkLst>
             <pc:docMk/>
             <pc:sldMk cId="943744701" sldId="262"/>
@@ -551,14 +569,6 @@
             <ac:spMk id="11" creationId="{7385F1EA-A542-3CF4-3490-CB75144606FE}"/>
           </ac:spMkLst>
         </pc:spChg>
-        <pc:spChg chg="add del mod">
-          <ac:chgData name="Tyrion Bao" userId="86a2b12e41226f78" providerId="LiveId" clId="{4891CA31-0AE7-4ECE-B60E-21685528A7C5}" dt="2026-10-12T06:06:52.031" v="576" actId="478"/>
-          <ac:spMkLst>
-            <pc:docMk/>
-            <pc:sldMk cId="2556202693" sldId="268"/>
-            <ac:spMk id="12" creationId="{61249B81-7BF9-207D-F10C-C84D190132E6}"/>
-          </ac:spMkLst>
-        </pc:spChg>
         <pc:spChg chg="add mod">
           <ac:chgData name="Tyrion Bao" userId="86a2b12e41226f78" providerId="LiveId" clId="{4891CA31-0AE7-4ECE-B60E-21685528A7C5}" dt="2026-10-13T07:25:58.841" v="1073" actId="14100"/>
           <ac:spMkLst>
@@ -591,14 +601,6 @@
             <ac:spMk id="24" creationId="{AA80C8C9-13B2-2C87-1E0E-6AFF692CFAF3}"/>
           </ac:spMkLst>
         </pc:spChg>
-        <pc:picChg chg="add del">
-          <ac:chgData name="Tyrion Bao" userId="86a2b12e41226f78" providerId="LiveId" clId="{4891CA31-0AE7-4ECE-B60E-21685528A7C5}" dt="2026-10-12T05:58:06.995" v="530" actId="478"/>
-          <ac:picMkLst>
-            <pc:docMk/>
-            <pc:sldMk cId="2556202693" sldId="268"/>
-            <ac:picMk id="7" creationId="{2951EAE8-F144-BBB8-1F43-DEA0E20ABE82}"/>
-          </ac:picMkLst>
-        </pc:picChg>
         <pc:picChg chg="add mod">
           <ac:chgData name="Tyrion Bao" userId="86a2b12e41226f78" providerId="LiveId" clId="{4891CA31-0AE7-4ECE-B60E-21685528A7C5}" dt="2026-10-12T06:06:13.960" v="535" actId="14100"/>
           <ac:picMkLst>
@@ -748,13 +750,13 @@
         </pc:picChg>
       </pc:sldChg>
       <pc:sldChg chg="addSp delSp modSp add mod">
-        <pc:chgData name="Tyrion Bao" userId="86a2b12e41226f78" providerId="LiveId" clId="{4891CA31-0AE7-4ECE-B60E-21685528A7C5}" dt="2026-10-13T12:20:14.083" v="1565" actId="1076"/>
+        <pc:chgData name="Tyrion Bao" userId="86a2b12e41226f78" providerId="LiveId" clId="{4891CA31-0AE7-4ECE-B60E-21685528A7C5}" dt="2026-10-14T05:09:09.399" v="1568" actId="1076"/>
         <pc:sldMkLst>
           <pc:docMk/>
           <pc:sldMk cId="843727772" sldId="274"/>
         </pc:sldMkLst>
         <pc:spChg chg="mod">
-          <ac:chgData name="Tyrion Bao" userId="86a2b12e41226f78" providerId="LiveId" clId="{4891CA31-0AE7-4ECE-B60E-21685528A7C5}" dt="2026-10-13T12:11:22.777" v="1551" actId="27636"/>
+          <ac:chgData name="Tyrion Bao" userId="86a2b12e41226f78" providerId="LiveId" clId="{4891CA31-0AE7-4ECE-B60E-21685528A7C5}" dt="2026-10-14T05:09:09.399" v="1568" actId="1076"/>
           <ac:spMkLst>
             <pc:docMk/>
             <pc:sldMk cId="843727772" sldId="274"/>
@@ -818,6 +820,53 @@
           </ac:picMkLst>
         </pc:picChg>
       </pc:sldChg>
+      <pc:sldChg chg="addSp delSp modSp add mod">
+        <pc:chgData name="Tyrion Bao" userId="86a2b12e41226f78" providerId="LiveId" clId="{4891CA31-0AE7-4ECE-B60E-21685528A7C5}" dt="2026-10-14T07:28:41.403" v="1787" actId="1076"/>
+        <pc:sldMkLst>
+          <pc:docMk/>
+          <pc:sldMk cId="2789359047" sldId="275"/>
+        </pc:sldMkLst>
+        <pc:spChg chg="mod">
+          <ac:chgData name="Tyrion Bao" userId="86a2b12e41226f78" providerId="LiveId" clId="{4891CA31-0AE7-4ECE-B60E-21685528A7C5}" dt="2026-10-14T06:55:41.974" v="1659" actId="20577"/>
+          <ac:spMkLst>
+            <pc:docMk/>
+            <pc:sldMk cId="2789359047" sldId="275"/>
+            <ac:spMk id="2" creationId="{D50E4326-4D9A-8D51-AE9E-8AA1218E3557}"/>
+          </ac:spMkLst>
+        </pc:spChg>
+        <pc:spChg chg="add mod">
+          <ac:chgData name="Tyrion Bao" userId="86a2b12e41226f78" providerId="LiveId" clId="{4891CA31-0AE7-4ECE-B60E-21685528A7C5}" dt="2026-10-14T07:13:39.920" v="1742" actId="1076"/>
+          <ac:spMkLst>
+            <pc:docMk/>
+            <pc:sldMk cId="2789359047" sldId="275"/>
+            <ac:spMk id="6" creationId="{F375FFB0-D2E0-691A-615B-29016704596C}"/>
+          </ac:spMkLst>
+        </pc:spChg>
+        <pc:spChg chg="add mod">
+          <ac:chgData name="Tyrion Bao" userId="86a2b12e41226f78" providerId="LiveId" clId="{4891CA31-0AE7-4ECE-B60E-21685528A7C5}" dt="2026-10-14T07:28:41.403" v="1787" actId="1076"/>
+          <ac:spMkLst>
+            <pc:docMk/>
+            <pc:sldMk cId="2789359047" sldId="275"/>
+            <ac:spMk id="8" creationId="{2AA8150B-0256-D5D3-5B9C-68DEEEDD1A8E}"/>
+          </ac:spMkLst>
+        </pc:spChg>
+        <pc:picChg chg="del">
+          <ac:chgData name="Tyrion Bao" userId="86a2b12e41226f78" providerId="LiveId" clId="{4891CA31-0AE7-4ECE-B60E-21685528A7C5}" dt="2026-10-14T06:55:43.558" v="1660" actId="478"/>
+          <ac:picMkLst>
+            <pc:docMk/>
+            <pc:sldMk cId="2789359047" sldId="275"/>
+            <ac:picMk id="4" creationId="{C1487B6F-9622-5091-B9B5-93F84786F8DE}"/>
+          </ac:picMkLst>
+        </pc:picChg>
+        <pc:picChg chg="add mod">
+          <ac:chgData name="Tyrion Bao" userId="86a2b12e41226f78" providerId="LiveId" clId="{4891CA31-0AE7-4ECE-B60E-21685528A7C5}" dt="2026-10-14T07:06:14.626" v="1727" actId="14100"/>
+          <ac:picMkLst>
+            <pc:docMk/>
+            <pc:sldMk cId="2789359047" sldId="275"/>
+            <ac:picMk id="5" creationId="{C77C9849-161A-8558-A227-89C7A6334591}"/>
+          </ac:picMkLst>
+        </pc:picChg>
+      </pc:sldChg>
       <pc:sldChg chg="modSp add del mod">
         <pc:chgData name="Tyrion Bao" userId="86a2b12e41226f78" providerId="LiveId" clId="{4891CA31-0AE7-4ECE-B60E-21685528A7C5}" dt="2026-10-13T11:30:20.408" v="1525" actId="47"/>
         <pc:sldMkLst>
@@ -840,6 +889,45 @@
             <ac:spMk id="3" creationId="{3C94A4E1-5D0C-23AA-F43B-F2638E5FAD34}"/>
           </ac:spMkLst>
         </pc:spChg>
+      </pc:sldChg>
+      <pc:sldChg chg="delSp modSp add mod">
+        <pc:chgData name="Tyrion Bao" userId="86a2b12e41226f78" providerId="LiveId" clId="{4891CA31-0AE7-4ECE-B60E-21685528A7C5}" dt="2026-10-14T07:17:06.313" v="1782" actId="20577"/>
+        <pc:sldMkLst>
+          <pc:docMk/>
+          <pc:sldMk cId="999397541" sldId="276"/>
+        </pc:sldMkLst>
+        <pc:spChg chg="mod">
+          <ac:chgData name="Tyrion Bao" userId="86a2b12e41226f78" providerId="LiveId" clId="{4891CA31-0AE7-4ECE-B60E-21685528A7C5}" dt="2026-10-14T07:17:04.301" v="1781"/>
+          <ac:spMkLst>
+            <pc:docMk/>
+            <pc:sldMk cId="999397541" sldId="276"/>
+            <ac:spMk id="2" creationId="{5EFBC410-2C7F-CFA6-CB61-3E7FFA2382C8}"/>
+          </ac:spMkLst>
+        </pc:spChg>
+        <pc:spChg chg="mod">
+          <ac:chgData name="Tyrion Bao" userId="86a2b12e41226f78" providerId="LiveId" clId="{4891CA31-0AE7-4ECE-B60E-21685528A7C5}" dt="2026-10-14T07:17:06.313" v="1782" actId="20577"/>
+          <ac:spMkLst>
+            <pc:docMk/>
+            <pc:sldMk cId="999397541" sldId="276"/>
+            <ac:spMk id="6" creationId="{FB3BF0A2-3382-AD7E-C296-76CEF4AFECCA}"/>
+          </ac:spMkLst>
+        </pc:spChg>
+        <pc:spChg chg="del">
+          <ac:chgData name="Tyrion Bao" userId="86a2b12e41226f78" providerId="LiveId" clId="{4891CA31-0AE7-4ECE-B60E-21685528A7C5}" dt="2026-10-14T07:16:57.007" v="1780" actId="478"/>
+          <ac:spMkLst>
+            <pc:docMk/>
+            <pc:sldMk cId="999397541" sldId="276"/>
+            <ac:spMk id="8" creationId="{7D6EF147-8731-8EE1-2FF5-812FD9E71FDC}"/>
+          </ac:spMkLst>
+        </pc:spChg>
+        <pc:picChg chg="del">
+          <ac:chgData name="Tyrion Bao" userId="86a2b12e41226f78" providerId="LiveId" clId="{4891CA31-0AE7-4ECE-B60E-21685528A7C5}" dt="2026-10-14T07:16:56.117" v="1779" actId="478"/>
+          <ac:picMkLst>
+            <pc:docMk/>
+            <pc:sldMk cId="999397541" sldId="276"/>
+            <ac:picMk id="5" creationId="{ABF97399-0615-6FB8-04E9-CE61296D5D05}"/>
+          </ac:picMkLst>
+        </pc:picChg>
       </pc:sldChg>
     </pc:docChg>
   </pc:docChgLst>
@@ -4859,6 +4947,356 @@
         <p:cNvPr id="1" name="">
           <a:extLst>
             <a:ext uri="{FF2B5EF4-FFF2-40B4-BE49-F238E27FC236}">
+              <a16:creationId xmlns:a16="http://schemas.microsoft.com/office/drawing/2014/main" id="{244A6928-CF3D-FF99-693C-8F20AB78BD12}"/>
+            </a:ext>
+          </a:extLst>
+        </p:cNvPr>
+        <p:cNvGrpSpPr/>
+        <p:nvPr/>
+      </p:nvGrpSpPr>
+      <p:grpSpPr>
+        <a:xfrm>
+          <a:off x="0" y="0"/>
+          <a:ext cx="0" cy="0"/>
+          <a:chOff x="0" y="0"/>
+          <a:chExt cx="0" cy="0"/>
+        </a:xfrm>
+      </p:grpSpPr>
+      <p:sp>
+        <p:nvSpPr>
+          <p:cNvPr id="2" name="标题 1">
+            <a:extLst>
+              <a:ext uri="{FF2B5EF4-FFF2-40B4-BE49-F238E27FC236}">
+                <a16:creationId xmlns:a16="http://schemas.microsoft.com/office/drawing/2014/main" id="{D50E4326-4D9A-8D51-AE9E-8AA1218E3557}"/>
+              </a:ext>
+            </a:extLst>
+          </p:cNvPr>
+          <p:cNvSpPr>
+            <a:spLocks noGrp="1"/>
+          </p:cNvSpPr>
+          <p:nvPr>
+            <p:ph type="title"/>
+          </p:nvPr>
+        </p:nvSpPr>
+        <p:spPr/>
+        <p:txBody>
+          <a:bodyPr/>
+          <a:lstStyle/>
+          <a:p>
+            <a:r>
+              <a:rPr lang="en-US" altLang="zh-CN" dirty="0"/>
+              <a:t>Lua</a:t>
+            </a:r>
+            <a:endParaRPr lang="zh-CN" altLang="en-US" dirty="0"/>
+          </a:p>
+        </p:txBody>
+      </p:sp>
+      <p:pic>
+        <p:nvPicPr>
+          <p:cNvPr id="5" name="Picture 4">
+            <a:extLst>
+              <a:ext uri="{FF2B5EF4-FFF2-40B4-BE49-F238E27FC236}">
+                <a16:creationId xmlns:a16="http://schemas.microsoft.com/office/drawing/2014/main" id="{C77C9849-161A-8558-A227-89C7A6334591}"/>
+              </a:ext>
+            </a:extLst>
+          </p:cNvPr>
+          <p:cNvPicPr>
+            <a:picLocks noChangeAspect="1"/>
+          </p:cNvPicPr>
+          <p:nvPr/>
+        </p:nvPicPr>
+        <p:blipFill>
+          <a:blip r:embed="rId2"/>
+          <a:stretch>
+            <a:fillRect/>
+          </a:stretch>
+        </p:blipFill>
+        <p:spPr>
+          <a:xfrm>
+            <a:off x="670892" y="2077357"/>
+            <a:ext cx="1782332" cy="1351643"/>
+          </a:xfrm>
+          <a:prstGeom prst="rect">
+            <a:avLst/>
+          </a:prstGeom>
+        </p:spPr>
+      </p:pic>
+      <p:sp>
+        <p:nvSpPr>
+          <p:cNvPr id="6" name="标题 1">
+            <a:extLst>
+              <a:ext uri="{FF2B5EF4-FFF2-40B4-BE49-F238E27FC236}">
+                <a16:creationId xmlns:a16="http://schemas.microsoft.com/office/drawing/2014/main" id="{F375FFB0-D2E0-691A-615B-29016704596C}"/>
+              </a:ext>
+            </a:extLst>
+          </p:cNvPr>
+          <p:cNvSpPr txBox="1">
+            <a:spLocks/>
+          </p:cNvSpPr>
+          <p:nvPr/>
+        </p:nvSpPr>
+        <p:spPr>
+          <a:xfrm>
+            <a:off x="617883" y="1571248"/>
+            <a:ext cx="10903225" cy="615359"/>
+          </a:xfrm>
+          <a:prstGeom prst="rect">
+            <a:avLst/>
+          </a:prstGeom>
+        </p:spPr>
+        <p:txBody>
+          <a:bodyPr vert="horz" lIns="91440" tIns="45720" rIns="91440" bIns="45720" rtlCol="0" anchor="ctr">
+            <a:normAutofit/>
+          </a:bodyPr>
+          <a:lstStyle>
+            <a:lvl1pPr algn="l" defTabSz="914400" rtl="0" eaLnBrk="1" latinLnBrk="0" hangingPunct="1">
+              <a:lnSpc>
+                <a:spcPct val="90000"/>
+              </a:lnSpc>
+              <a:spcBef>
+                <a:spcPct val="0"/>
+              </a:spcBef>
+              <a:buNone/>
+              <a:defRPr sz="4400" kern="1200">
+                <a:solidFill>
+                  <a:schemeClr val="tx1"/>
+                </a:solidFill>
+                <a:latin typeface="+mj-lt"/>
+                <a:ea typeface="+mj-ea"/>
+                <a:cs typeface="+mj-cs"/>
+              </a:defRPr>
+            </a:lvl1pPr>
+          </a:lstStyle>
+          <a:p>
+            <a:r>
+              <a:rPr lang="en-US" sz="1600" dirty="0"/>
+              <a:t>Superficially</a:t>
+            </a:r>
+            <a:r>
+              <a:rPr lang="en-US" altLang="zh-CN" sz="1600" dirty="0"/>
+              <a:t>, it’s very similar to python</a:t>
+            </a:r>
+            <a:r>
+              <a:rPr lang="en-US" sz="1600" dirty="0"/>
+              <a:t>—both are dynamic, garbage-collected, interpreted-bytecode scripting languages written in C with first-class functions.</a:t>
+            </a:r>
+            <a:endParaRPr lang="en-US" altLang="zh-CN" sz="1600" dirty="0"/>
+          </a:p>
+          <a:p>
+            <a:endParaRPr lang="zh-CN" altLang="en-US" sz="1600" dirty="0"/>
+          </a:p>
+        </p:txBody>
+      </p:sp>
+      <p:sp>
+        <p:nvSpPr>
+          <p:cNvPr id="8" name="标题 1">
+            <a:extLst>
+              <a:ext uri="{FF2B5EF4-FFF2-40B4-BE49-F238E27FC236}">
+                <a16:creationId xmlns:a16="http://schemas.microsoft.com/office/drawing/2014/main" id="{2AA8150B-0256-D5D3-5B9C-68DEEEDD1A8E}"/>
+              </a:ext>
+            </a:extLst>
+          </p:cNvPr>
+          <p:cNvSpPr txBox="1">
+            <a:spLocks/>
+          </p:cNvSpPr>
+          <p:nvPr/>
+        </p:nvSpPr>
+        <p:spPr>
+          <a:xfrm>
+            <a:off x="617883" y="3518452"/>
+            <a:ext cx="10515600" cy="932237"/>
+          </a:xfrm>
+          <a:prstGeom prst="rect">
+            <a:avLst/>
+          </a:prstGeom>
+        </p:spPr>
+        <p:txBody>
+          <a:bodyPr vert="horz" lIns="91440" tIns="45720" rIns="91440" bIns="45720" rtlCol="0" anchor="ctr">
+            <a:normAutofit lnSpcReduction="10000"/>
+          </a:bodyPr>
+          <a:lstStyle>
+            <a:lvl1pPr algn="l" defTabSz="914400" rtl="0" eaLnBrk="1" latinLnBrk="0" hangingPunct="1">
+              <a:lnSpc>
+                <a:spcPct val="90000"/>
+              </a:lnSpc>
+              <a:spcBef>
+                <a:spcPct val="0"/>
+              </a:spcBef>
+              <a:buNone/>
+              <a:defRPr sz="4400" kern="1200">
+                <a:solidFill>
+                  <a:schemeClr val="tx1"/>
+                </a:solidFill>
+                <a:latin typeface="+mj-lt"/>
+                <a:ea typeface="+mj-ea"/>
+                <a:cs typeface="+mj-cs"/>
+              </a:defRPr>
+            </a:lvl1pPr>
+          </a:lstStyle>
+          <a:p>
+            <a:r>
+              <a:rPr lang="en-US" sz="1600" dirty="0"/>
+              <a:t>Architecturally and philosophically, they are near-opposites: Python is a standalone, "batteries-included" monolith built around rich object-oriented abstractions and an enormous standard library,</a:t>
+            </a:r>
+          </a:p>
+          <a:p>
+            <a:r>
+              <a:rPr lang="en-US" sz="1600" dirty="0"/>
+              <a:t>while Lua is an ultra-minimal, embeddable configuration-and-scripting library with only one data structure and no native class mechanism.</a:t>
+            </a:r>
+            <a:endParaRPr lang="zh-CN" altLang="en-US" sz="1600" dirty="0"/>
+          </a:p>
+        </p:txBody>
+      </p:sp>
+    </p:spTree>
+    <p:extLst>
+      <p:ext uri="{BB962C8B-B14F-4D97-AF65-F5344CB8AC3E}">
+        <p14:creationId xmlns:p14="http://schemas.microsoft.com/office/powerpoint/2010/main" val="2789359047"/>
+      </p:ext>
+    </p:extLst>
+  </p:cSld>
+  <p:clrMapOvr>
+    <a:masterClrMapping/>
+  </p:clrMapOvr>
+</p:sld>
+</file>
+
+<file path=ppt/slides/slide13.xml><?xml version="1.0" encoding="utf-8"?>
+<p:sld xmlns:a="http://schemas.openxmlformats.org/drawingml/2006/main" xmlns:r="http://schemas.openxmlformats.org/officeDocument/2006/relationships" xmlns:p="http://schemas.openxmlformats.org/presentationml/2006/main">
+  <p:cSld>
+    <p:spTree>
+      <p:nvGrpSpPr>
+        <p:cNvPr id="1" name="">
+          <a:extLst>
+            <a:ext uri="{FF2B5EF4-FFF2-40B4-BE49-F238E27FC236}">
+              <a16:creationId xmlns:a16="http://schemas.microsoft.com/office/drawing/2014/main" id="{6ADB53B6-042D-0193-F763-674966E92538}"/>
+            </a:ext>
+          </a:extLst>
+        </p:cNvPr>
+        <p:cNvGrpSpPr/>
+        <p:nvPr/>
+      </p:nvGrpSpPr>
+      <p:grpSpPr>
+        <a:xfrm>
+          <a:off x="0" y="0"/>
+          <a:ext cx="0" cy="0"/>
+          <a:chOff x="0" y="0"/>
+          <a:chExt cx="0" cy="0"/>
+        </a:xfrm>
+      </p:grpSpPr>
+      <p:sp>
+        <p:nvSpPr>
+          <p:cNvPr id="2" name="标题 1">
+            <a:extLst>
+              <a:ext uri="{FF2B5EF4-FFF2-40B4-BE49-F238E27FC236}">
+                <a16:creationId xmlns:a16="http://schemas.microsoft.com/office/drawing/2014/main" id="{5EFBC410-2C7F-CFA6-CB61-3E7FFA2382C8}"/>
+              </a:ext>
+            </a:extLst>
+          </p:cNvPr>
+          <p:cNvSpPr>
+            <a:spLocks noGrp="1"/>
+          </p:cNvSpPr>
+          <p:nvPr>
+            <p:ph type="title"/>
+          </p:nvPr>
+        </p:nvSpPr>
+        <p:spPr/>
+        <p:txBody>
+          <a:bodyPr/>
+          <a:lstStyle/>
+          <a:p>
+            <a:r>
+              <a:rPr lang="en-US" altLang="zh-CN" dirty="0"/>
+              <a:t>WGSL</a:t>
+            </a:r>
+            <a:endParaRPr lang="zh-CN" altLang="en-US" dirty="0"/>
+          </a:p>
+        </p:txBody>
+      </p:sp>
+      <p:sp>
+        <p:nvSpPr>
+          <p:cNvPr id="6" name="标题 1">
+            <a:extLst>
+              <a:ext uri="{FF2B5EF4-FFF2-40B4-BE49-F238E27FC236}">
+                <a16:creationId xmlns:a16="http://schemas.microsoft.com/office/drawing/2014/main" id="{FB3BF0A2-3382-AD7E-C296-76CEF4AFECCA}"/>
+              </a:ext>
+            </a:extLst>
+          </p:cNvPr>
+          <p:cNvSpPr txBox="1">
+            <a:spLocks/>
+          </p:cNvSpPr>
+          <p:nvPr/>
+        </p:nvSpPr>
+        <p:spPr>
+          <a:xfrm>
+            <a:off x="617883" y="1571248"/>
+            <a:ext cx="10903225" cy="615359"/>
+          </a:xfrm>
+          <a:prstGeom prst="rect">
+            <a:avLst/>
+          </a:prstGeom>
+        </p:spPr>
+        <p:txBody>
+          <a:bodyPr vert="horz" lIns="91440" tIns="45720" rIns="91440" bIns="45720" rtlCol="0" anchor="ctr">
+            <a:normAutofit/>
+          </a:bodyPr>
+          <a:lstStyle>
+            <a:lvl1pPr algn="l" defTabSz="914400" rtl="0" eaLnBrk="1" latinLnBrk="0" hangingPunct="1">
+              <a:lnSpc>
+                <a:spcPct val="90000"/>
+              </a:lnSpc>
+              <a:spcBef>
+                <a:spcPct val="0"/>
+              </a:spcBef>
+              <a:buNone/>
+              <a:defRPr sz="4400" kern="1200">
+                <a:solidFill>
+                  <a:schemeClr val="tx1"/>
+                </a:solidFill>
+                <a:latin typeface="+mj-lt"/>
+                <a:ea typeface="+mj-ea"/>
+                <a:cs typeface="+mj-cs"/>
+              </a:defRPr>
+            </a:lvl1pPr>
+          </a:lstStyle>
+          <a:p>
+            <a:r>
+              <a:rPr lang="en-US" sz="1600" dirty="0"/>
+              <a:t>Superficially</a:t>
+            </a:r>
+            <a:r>
+              <a:rPr lang="en-US" altLang="zh-CN" sz="1600" dirty="0"/>
+              <a:t>, it’s very similar to python</a:t>
+            </a:r>
+            <a:r>
+              <a:rPr lang="en-US" sz="1600" dirty="0"/>
+              <a:t>—both are dynamic, garbage-collected, interpreted-bytecode scripting languages written in C with first-class functions.</a:t>
+            </a:r>
+            <a:endParaRPr lang="en-US" altLang="zh-CN" sz="1600" dirty="0"/>
+          </a:p>
+        </p:txBody>
+      </p:sp>
+    </p:spTree>
+    <p:extLst>
+      <p:ext uri="{BB962C8B-B14F-4D97-AF65-F5344CB8AC3E}">
+        <p14:creationId xmlns:p14="http://schemas.microsoft.com/office/powerpoint/2010/main" val="999397541"/>
+      </p:ext>
+    </p:extLst>
+  </p:cSld>
+  <p:clrMapOvr>
+    <a:masterClrMapping/>
+  </p:clrMapOvr>
+</p:sld>
+</file>
+
+<file path=ppt/slides/slide14.xml><?xml version="1.0" encoding="utf-8"?>
+<p:sld xmlns:a="http://schemas.openxmlformats.org/drawingml/2006/main" xmlns:r="http://schemas.openxmlformats.org/officeDocument/2006/relationships" xmlns:p="http://schemas.openxmlformats.org/presentationml/2006/main">
+  <p:cSld>
+    <p:spTree>
+      <p:nvGrpSpPr>
+        <p:cNvPr id="1" name="">
+          <a:extLst>
+            <a:ext uri="{FF2B5EF4-FFF2-40B4-BE49-F238E27FC236}">
               <a16:creationId xmlns:a16="http://schemas.microsoft.com/office/drawing/2014/main" id="{156660F6-F363-FD77-5D1E-98DC0379C139}"/>
             </a:ext>
           </a:extLst>
@@ -4946,7 +5384,7 @@
 </p:sld>
 </file>
 
-<file path=ppt/slides/slide13.xml><?xml version="1.0" encoding="utf-8"?>
+<file path=ppt/slides/slide15.xml><?xml version="1.0" encoding="utf-8"?>
 <p:sld xmlns:a="http://schemas.openxmlformats.org/drawingml/2006/main" xmlns:r="http://schemas.openxmlformats.org/officeDocument/2006/relationships" xmlns:p="http://schemas.openxmlformats.org/presentationml/2006/main">
   <p:cSld>
     <p:spTree>
@@ -5035,10 +5473,75 @@
               <a:rPr lang="en-US" altLang="zh-CN" dirty="0"/>
               <a:t>About my personal career plan</a:t>
             </a:r>
-            <a:endParaRPr lang="zh-CN" altLang="en-US" dirty="0"/>
-          </a:p>
-        </p:txBody>
-      </p:sp>
+          </a:p>
+          <a:p>
+            <a:r>
+              <a:rPr lang="en-US" altLang="zh-CN" dirty="0"/>
+              <a:t>About my thoughts about Kanzi(IMPORTANT)</a:t>
+            </a:r>
+          </a:p>
+        </p:txBody>
+      </p:sp>
+      <p:pic>
+        <p:nvPicPr>
+          <p:cNvPr id="5" name="Picture 4">
+            <a:extLst>
+              <a:ext uri="{FF2B5EF4-FFF2-40B4-BE49-F238E27FC236}">
+                <a16:creationId xmlns:a16="http://schemas.microsoft.com/office/drawing/2014/main" id="{03329CC2-F2B7-4775-973E-D76E25BD7C18}"/>
+              </a:ext>
+            </a:extLst>
+          </p:cNvPr>
+          <p:cNvPicPr>
+            <a:picLocks noChangeAspect="1"/>
+          </p:cNvPicPr>
+          <p:nvPr/>
+        </p:nvPicPr>
+        <p:blipFill>
+          <a:blip r:embed="rId2"/>
+          <a:stretch>
+            <a:fillRect/>
+          </a:stretch>
+        </p:blipFill>
+        <p:spPr>
+          <a:xfrm>
+            <a:off x="5953539" y="3263894"/>
+            <a:ext cx="1073425" cy="671590"/>
+          </a:xfrm>
+          <a:prstGeom prst="rect">
+            <a:avLst/>
+          </a:prstGeom>
+        </p:spPr>
+      </p:pic>
+      <p:pic>
+        <p:nvPicPr>
+          <p:cNvPr id="7" name="Picture 6">
+            <a:extLst>
+              <a:ext uri="{FF2B5EF4-FFF2-40B4-BE49-F238E27FC236}">
+                <a16:creationId xmlns:a16="http://schemas.microsoft.com/office/drawing/2014/main" id="{2C25E9FA-5154-3C1C-F824-A852ACC92A76}"/>
+              </a:ext>
+            </a:extLst>
+          </p:cNvPr>
+          <p:cNvPicPr>
+            <a:picLocks noChangeAspect="1"/>
+          </p:cNvPicPr>
+          <p:nvPr/>
+        </p:nvPicPr>
+        <p:blipFill>
+          <a:blip r:embed="rId3"/>
+          <a:stretch>
+            <a:fillRect/>
+          </a:stretch>
+        </p:blipFill>
+        <p:spPr>
+          <a:xfrm>
+            <a:off x="6952422" y="3374334"/>
+            <a:ext cx="735305" cy="506484"/>
+          </a:xfrm>
+          <a:prstGeom prst="rect">
+            <a:avLst/>
+          </a:prstGeom>
+        </p:spPr>
+      </p:pic>
     </p:spTree>
     <p:extLst>
       <p:ext uri="{BB962C8B-B14F-4D97-AF65-F5344CB8AC3E}">
@@ -5052,7 +5555,7 @@
 </p:sld>
 </file>
 
-<file path=ppt/slides/slide14.xml><?xml version="1.0" encoding="utf-8"?>
+<file path=ppt/slides/slide16.xml><?xml version="1.0" encoding="utf-8"?>
 <p:sld xmlns:a="http://schemas.openxmlformats.org/drawingml/2006/main" xmlns:r="http://schemas.openxmlformats.org/officeDocument/2006/relationships" xmlns:p="http://schemas.openxmlformats.org/presentationml/2006/main">
   <p:cSld>
     <p:spTree>
@@ -7595,6 +8098,18 @@
             <a:r>
               <a:rPr lang="en-US" altLang="zh-CN" dirty="0"/>
               <a:t> blender plugin for plant resources</a:t>
+            </a:r>
+          </a:p>
+          <a:p>
+            <a:r>
+              <a:rPr lang="en-US" altLang="zh-CN" dirty="0"/>
+              <a:t>Lua</a:t>
+            </a:r>
+          </a:p>
+          <a:p>
+            <a:r>
+              <a:rPr lang="en-US" altLang="zh-CN" dirty="0"/>
+              <a:t>WGSL Shading language</a:t>
             </a:r>
           </a:p>
           <a:p>

</xml_diff>